<commit_message>
Redesign presentation: full-page slides, Sanchay-only attribution, results chart
</commit_message>
<xml_diff>
--- a/docs/Gold-Price-Prediction-Presentation.pptx
+++ b/docs/Gold-Price-Prediction-Presentation.pptx
@@ -3152,8 +3152,8 @@
         </p:nvSpPr>
         <p:spPr>
           <a:xfrm>
-            <a:off x="0" y="4160520"/>
-            <a:ext cx="12191695" cy="73152"/>
+            <a:off x="0" y="3977639"/>
+            <a:ext cx="12191695" cy="54864"/>
           </a:xfrm>
           <a:prstGeom prst="rect">
             <a:avLst/>
@@ -3190,7 +3190,7 @@
       </p:sp>
       <p:pic>
         <p:nvPicPr>
-          <p:cNvPr id="4" name="Picture 3" descr="college_logo.jpg"/>
+          <p:cNvPr id="4" name="Picture 3" descr="college_logo_navy.png"/>
           <p:cNvPicPr>
             <a:picLocks noChangeAspect="1"/>
           </p:cNvPicPr>
@@ -3204,8 +3204,8 @@
         </p:blipFill>
         <p:spPr>
           <a:xfrm>
-            <a:off x="5318607" y="640080"/>
-            <a:ext cx="1554480" cy="1554480"/>
+            <a:off x="5227167" y="548640"/>
+            <a:ext cx="1737360" cy="1737360"/>
           </a:xfrm>
           <a:prstGeom prst="rect">
             <a:avLst/>
@@ -3220,7 +3220,7 @@
         </p:nvSpPr>
         <p:spPr>
           <a:xfrm>
-            <a:off x="731520" y="2377440"/>
+            <a:off x="731520" y="2331720"/>
             <a:ext cx="10728655" cy="1463040"/>
           </a:xfrm>
           <a:prstGeom prst="rect">
@@ -3233,6 +3233,93 @@
             <a:spAutoFit/>
           </a:bodyPr>
           <a:lstStyle/>
+          <a:p>
+            <a:pPr algn="ctr">
+              <a:spcAft>
+                <a:spcPts val="600"/>
+              </a:spcAft>
+            </a:pPr>
+            <a:r>
+              <a:rPr sz="3400" b="1">
+                <a:solidFill>
+                  <a:srgbClr val="FFFFFF"/>
+                </a:solidFill>
+                <a:latin typeface="Calibri"/>
+              </a:rPr>
+              <a:t>Gold Price Prediction using Machine Learning</a:t>
+            </a:r>
+          </a:p>
+          <a:p>
+            <a:pPr algn="ctr">
+              <a:spcAft>
+                <a:spcPts val="600"/>
+              </a:spcAft>
+            </a:pPr>
+            <a:r>
+              <a:rPr sz="1800" b="0">
+                <a:solidFill>
+                  <a:srgbClr val="C9A227"/>
+                </a:solidFill>
+                <a:latin typeface="Calibri"/>
+              </a:rPr>
+              <a:t>A Mini Project in Machine Learning</a:t>
+            </a:r>
+          </a:p>
+        </p:txBody>
+      </p:sp>
+      <p:sp>
+        <p:nvSpPr>
+          <p:cNvPr id="6" name="TextBox 5"/>
+          <p:cNvSpPr txBox="1"/>
+          <p:nvPr/>
+        </p:nvSpPr>
+        <p:spPr>
+          <a:xfrm>
+            <a:off x="914400" y="4297680"/>
+            <a:ext cx="10362895" cy="2194560"/>
+          </a:xfrm>
+          <a:prstGeom prst="rect">
+            <a:avLst/>
+          </a:prstGeom>
+          <a:noFill/>
+        </p:spPr>
+        <p:txBody>
+          <a:bodyPr wrap="square">
+            <a:spAutoFit/>
+          </a:bodyPr>
+          <a:lstStyle/>
+          <a:p>
+            <a:pPr algn="ctr">
+              <a:spcAft>
+                <a:spcPts val="200"/>
+              </a:spcAft>
+            </a:pPr>
+            <a:r>
+              <a:rPr sz="1300" b="1">
+                <a:solidFill>
+                  <a:srgbClr val="C9A227"/>
+                </a:solidFill>
+                <a:latin typeface="Calibri"/>
+              </a:rPr>
+              <a:t>Submitted by</a:t>
+            </a:r>
+          </a:p>
+          <a:p>
+            <a:pPr algn="ctr">
+              <a:spcAft>
+                <a:spcPts val="1400"/>
+              </a:spcAft>
+            </a:pPr>
+            <a:r>
+              <a:rPr sz="2200" b="1">
+                <a:solidFill>
+                  <a:srgbClr val="FFFFFF"/>
+                </a:solidFill>
+                <a:latin typeface="Calibri"/>
+              </a:rPr>
+              <a:t>Sanchay Bhardwaj  (2300650100104)</a:t>
+            </a:r>
+          </a:p>
           <a:p>
             <a:pPr algn="ctr">
               <a:spcAft>
@@ -3240,13 +3327,29 @@
               </a:spcAft>
             </a:pPr>
             <a:r>
-              <a:rPr sz="3400" b="1">
+              <a:rPr sz="1500" b="0">
                 <a:solidFill>
                   <a:srgbClr val="FFFFFF"/>
                 </a:solidFill>
                 <a:latin typeface="Calibri"/>
               </a:rPr>
-              <a:t>Gold Price Prediction using Machine Learning</a:t>
+              <a:t>Project Guide:  Mrs. Ashna Thakur</a:t>
+            </a:r>
+          </a:p>
+          <a:p>
+            <a:pPr algn="ctr">
+              <a:spcAft>
+                <a:spcPts val="400"/>
+              </a:spcAft>
+            </a:pPr>
+            <a:r>
+              <a:rPr sz="1400" b="0">
+                <a:solidFill>
+                  <a:srgbClr val="FFFFFF"/>
+                </a:solidFill>
+                <a:latin typeface="Calibri"/>
+              </a:rPr>
+              <a:t>B.S.A. College of Engineering &amp; Technology, Mathura</a:t>
             </a:r>
           </a:p>
           <a:p>
@@ -3256,112 +3359,9 @@
               </a:spcAft>
             </a:pPr>
             <a:r>
-              <a:rPr sz="1800" b="0">
+              <a:rPr sz="1200" b="0">
                 <a:solidFill>
                   <a:srgbClr val="C9A227"/>
-                </a:solidFill>
-                <a:latin typeface="Calibri"/>
-              </a:rPr>
-              <a:t>A Mini Project in Machine Learning</a:t>
-            </a:r>
-          </a:p>
-        </p:txBody>
-      </p:sp>
-      <p:sp>
-        <p:nvSpPr>
-          <p:cNvPr id="6" name="TextBox 5"/>
-          <p:cNvSpPr txBox="1"/>
-          <p:nvPr/>
-        </p:nvSpPr>
-        <p:spPr>
-          <a:xfrm>
-            <a:off x="731520" y="4389120"/>
-            <a:ext cx="10728655" cy="2103120"/>
-          </a:xfrm>
-          <a:prstGeom prst="rect">
-            <a:avLst/>
-          </a:prstGeom>
-          <a:noFill/>
-        </p:spPr>
-        <p:txBody>
-          <a:bodyPr wrap="square">
-            <a:spAutoFit/>
-          </a:bodyPr>
-          <a:lstStyle/>
-          <a:p>
-            <a:pPr algn="ctr">
-              <a:spcAft>
-                <a:spcPts val="300"/>
-              </a:spcAft>
-            </a:pPr>
-            <a:r>
-              <a:rPr sz="1300" b="0">
-                <a:solidFill>
-                  <a:srgbClr val="FFFFFF"/>
-                </a:solidFill>
-                <a:latin typeface="Calibri"/>
-              </a:rPr>
-              <a:t>Submitted by:  Tapesh Sharma   (2300650100118)</a:t>
-            </a:r>
-          </a:p>
-          <a:p>
-            <a:pPr algn="ctr">
-              <a:spcAft>
-                <a:spcPts val="300"/>
-              </a:spcAft>
-            </a:pPr>
-            <a:r>
-              <a:rPr sz="1300" b="0">
-                <a:solidFill>
-                  <a:srgbClr val="FFFFFF"/>
-                </a:solidFill>
-                <a:latin typeface="Calibri"/>
-              </a:rPr>
-              <a:t>Team:  Sanchay Bhardwaj (2300650100104)   |   Vivek (2300650100127)</a:t>
-            </a:r>
-          </a:p>
-          <a:p>
-            <a:pPr algn="ctr">
-              <a:spcAft>
-                <a:spcPts val="300"/>
-              </a:spcAft>
-            </a:pPr>
-            <a:r>
-              <a:rPr sz="1300" b="0">
-                <a:solidFill>
-                  <a:srgbClr val="FFFFFF"/>
-                </a:solidFill>
-                <a:latin typeface="Calibri"/>
-              </a:rPr>
-              <a:t>Project Guide:  Mrs. Ashna Thakur</a:t>
-            </a:r>
-          </a:p>
-          <a:p>
-            <a:pPr algn="ctr">
-              <a:spcAft>
-                <a:spcPts val="300"/>
-              </a:spcAft>
-            </a:pPr>
-            <a:r>
-              <a:rPr sz="1300" b="0">
-                <a:solidFill>
-                  <a:srgbClr val="FFFFFF"/>
-                </a:solidFill>
-                <a:latin typeface="Calibri"/>
-              </a:rPr>
-              <a:t>B.S.A. College of Engineering &amp; Technology, Mathura</a:t>
-            </a:r>
-          </a:p>
-          <a:p>
-            <a:pPr algn="ctr">
-              <a:spcAft>
-                <a:spcPts val="300"/>
-              </a:spcAft>
-            </a:pPr>
-            <a:r>
-              <a:rPr sz="1300" b="0">
-                <a:solidFill>
-                  <a:srgbClr val="FFFFFF"/>
                 </a:solidFill>
                 <a:latin typeface="Calibri"/>
               </a:rPr>
@@ -3441,7 +3441,7 @@
         <p:spPr>
           <a:xfrm>
             <a:off x="0" y="960120"/>
-            <a:ext cx="12191695" cy="54864"/>
+            <a:ext cx="12191695" cy="64008"/>
           </a:xfrm>
           <a:prstGeom prst="rect">
             <a:avLst/>
@@ -3484,8 +3484,8 @@
         </p:nvSpPr>
         <p:spPr>
           <a:xfrm>
-            <a:off x="457200" y="109728"/>
-            <a:ext cx="11277295" cy="777240"/>
+            <a:off x="457200" y="137160"/>
+            <a:ext cx="8351215" cy="731520"/>
           </a:xfrm>
           <a:prstGeom prst="rect">
             <a:avLst/>
@@ -3515,9 +3515,214 @@
           </a:p>
         </p:txBody>
       </p:sp>
+      <p:sp>
+        <p:nvSpPr>
+          <p:cNvPr id="5" name="TextBox 4"/>
+          <p:cNvSpPr txBox="1"/>
+          <p:nvPr/>
+        </p:nvSpPr>
+        <p:spPr>
+          <a:xfrm>
+            <a:off x="8534095" y="137160"/>
+            <a:ext cx="3200400" cy="731520"/>
+          </a:xfrm>
+          <a:prstGeom prst="rect">
+            <a:avLst/>
+          </a:prstGeom>
+          <a:noFill/>
+        </p:spPr>
+        <p:txBody>
+          <a:bodyPr wrap="square" anchor="ctr">
+            <a:spAutoFit/>
+          </a:bodyPr>
+          <a:lstStyle/>
+          <a:p>
+            <a:pPr algn="r">
+              <a:spcAft>
+                <a:spcPts val="600"/>
+              </a:spcAft>
+            </a:pPr>
+            <a:r>
+              <a:rPr sz="1200" b="1">
+                <a:solidFill>
+                  <a:srgbClr val="C9A227"/>
+                </a:solidFill>
+                <a:latin typeface="Calibri"/>
+              </a:rPr>
+              <a:t>Gold Price Prediction</a:t>
+            </a:r>
+          </a:p>
+        </p:txBody>
+      </p:sp>
+      <p:sp>
+        <p:nvSpPr>
+          <p:cNvPr id="6" name="Rectangle 5"/>
+          <p:cNvSpPr/>
+          <p:nvPr/>
+        </p:nvSpPr>
+        <p:spPr>
+          <a:xfrm>
+            <a:off x="0" y="6473952"/>
+            <a:ext cx="12191695" cy="384048"/>
+          </a:xfrm>
+          <a:prstGeom prst="rect">
+            <a:avLst/>
+          </a:prstGeom>
+          <a:solidFill>
+            <a:srgbClr val="1F3864"/>
+          </a:solidFill>
+          <a:ln>
+            <a:noFill/>
+          </a:ln>
+          <a:effectLst/>
+        </p:spPr>
+        <p:style>
+          <a:lnRef idx="1">
+            <a:schemeClr val="accent1"/>
+          </a:lnRef>
+          <a:fillRef idx="3">
+            <a:schemeClr val="accent1"/>
+          </a:fillRef>
+          <a:effectRef idx="2">
+            <a:schemeClr val="accent1"/>
+          </a:effectRef>
+          <a:fontRef idx="minor">
+            <a:schemeClr val="lt1"/>
+          </a:fontRef>
+        </p:style>
+        <p:txBody>
+          <a:bodyPr rtlCol="0" anchor="ctr"/>
+          <a:lstStyle/>
+          <a:p>
+            <a:pPr algn="ctr"/>
+          </a:p>
+        </p:txBody>
+      </p:sp>
+      <p:sp>
+        <p:nvSpPr>
+          <p:cNvPr id="7" name="Rectangle 6"/>
+          <p:cNvSpPr/>
+          <p:nvPr/>
+        </p:nvSpPr>
+        <p:spPr>
+          <a:xfrm>
+            <a:off x="0" y="6473952"/>
+            <a:ext cx="128016" cy="384048"/>
+          </a:xfrm>
+          <a:prstGeom prst="rect">
+            <a:avLst/>
+          </a:prstGeom>
+          <a:solidFill>
+            <a:srgbClr val="C9A227"/>
+          </a:solidFill>
+          <a:ln>
+            <a:noFill/>
+          </a:ln>
+          <a:effectLst/>
+        </p:spPr>
+        <p:style>
+          <a:lnRef idx="1">
+            <a:schemeClr val="accent1"/>
+          </a:lnRef>
+          <a:fillRef idx="3">
+            <a:schemeClr val="accent1"/>
+          </a:fillRef>
+          <a:effectRef idx="2">
+            <a:schemeClr val="accent1"/>
+          </a:effectRef>
+          <a:fontRef idx="minor">
+            <a:schemeClr val="lt1"/>
+          </a:fontRef>
+        </p:style>
+        <p:txBody>
+          <a:bodyPr rtlCol="0" anchor="ctr"/>
+          <a:lstStyle/>
+          <a:p>
+            <a:pPr algn="ctr"/>
+          </a:p>
+        </p:txBody>
+      </p:sp>
+      <p:sp>
+        <p:nvSpPr>
+          <p:cNvPr id="8" name="TextBox 7"/>
+          <p:cNvSpPr txBox="1"/>
+          <p:nvPr/>
+        </p:nvSpPr>
+        <p:spPr>
+          <a:xfrm>
+            <a:off x="274320" y="6473952"/>
+            <a:ext cx="10362895" cy="384048"/>
+          </a:xfrm>
+          <a:prstGeom prst="rect">
+            <a:avLst/>
+          </a:prstGeom>
+          <a:noFill/>
+        </p:spPr>
+        <p:txBody>
+          <a:bodyPr wrap="square" anchor="ctr">
+            <a:spAutoFit/>
+          </a:bodyPr>
+          <a:lstStyle/>
+          <a:p>
+            <a:pPr algn="l">
+              <a:spcAft>
+                <a:spcPts val="600"/>
+              </a:spcAft>
+            </a:pPr>
+            <a:r>
+              <a:rPr sz="900" b="0">
+                <a:solidFill>
+                  <a:srgbClr val="FFFFFF"/>
+                </a:solidFill>
+                <a:latin typeface="Calibri"/>
+              </a:rPr>
+              <a:t>Sanchay Bhardwaj (2300650100104)  |  B.S.A. College of Engineering &amp; Technology, Mathura</a:t>
+            </a:r>
+          </a:p>
+        </p:txBody>
+      </p:sp>
+      <p:sp>
+        <p:nvSpPr>
+          <p:cNvPr id="9" name="TextBox 8"/>
+          <p:cNvSpPr txBox="1"/>
+          <p:nvPr/>
+        </p:nvSpPr>
+        <p:spPr>
+          <a:xfrm>
+            <a:off x="10728655" y="6473952"/>
+            <a:ext cx="1188720" cy="384048"/>
+          </a:xfrm>
+          <a:prstGeom prst="rect">
+            <a:avLst/>
+          </a:prstGeom>
+          <a:noFill/>
+        </p:spPr>
+        <p:txBody>
+          <a:bodyPr wrap="square" anchor="ctr">
+            <a:spAutoFit/>
+          </a:bodyPr>
+          <a:lstStyle/>
+          <a:p>
+            <a:pPr algn="r">
+              <a:spcAft>
+                <a:spcPts val="600"/>
+              </a:spcAft>
+            </a:pPr>
+            <a:r>
+              <a:rPr sz="900" b="1">
+                <a:solidFill>
+                  <a:srgbClr val="C9A227"/>
+                </a:solidFill>
+                <a:latin typeface="Calibri"/>
+              </a:rPr>
+              <a:t>Slide 10</a:t>
+            </a:r>
+          </a:p>
+        </p:txBody>
+      </p:sp>
       <p:pic>
         <p:nvPicPr>
-          <p:cNvPr id="5" name="Picture 4" descr="screenshot_train.png"/>
+          <p:cNvPr id="10" name="Picture 9" descr="screenshot_train.png"/>
           <p:cNvPicPr>
             <a:picLocks noChangeAspect="1"/>
           </p:cNvPicPr>
@@ -3531,8 +3736,8 @@
         </p:blipFill>
         <p:spPr>
           <a:xfrm>
-            <a:off x="2426491" y="1371600"/>
-            <a:ext cx="7338713" cy="4846320"/>
+            <a:off x="2703423" y="1325880"/>
+            <a:ext cx="6784848" cy="4480560"/>
           </a:xfrm>
           <a:prstGeom prst="rect">
             <a:avLst/>
@@ -3541,14 +3746,14 @@
       </p:pic>
       <p:sp>
         <p:nvSpPr>
-          <p:cNvPr id="6" name="TextBox 5"/>
+          <p:cNvPr id="11" name="TextBox 10"/>
           <p:cNvSpPr txBox="1"/>
           <p:nvPr/>
         </p:nvSpPr>
         <p:spPr>
           <a:xfrm>
-            <a:off x="914400" y="6126480"/>
-            <a:ext cx="10362895" cy="548640"/>
+            <a:off x="914400" y="5623560"/>
+            <a:ext cx="10362895" cy="640080"/>
           </a:xfrm>
           <a:prstGeom prst="rect">
             <a:avLst/>
@@ -3573,7 +3778,7 @@
                 </a:solidFill>
                 <a:latin typeface="Calibri"/>
               </a:rPr>
-              <a:t>Train tab: accuracy table and the error comparison across models.</a:t>
+              <a:t>Train tab: accuracy table and the error comparison across all models.</a:t>
             </a:r>
           </a:p>
         </p:txBody>
@@ -3649,7 +3854,7 @@
         <p:spPr>
           <a:xfrm>
             <a:off x="0" y="960120"/>
-            <a:ext cx="12191695" cy="54864"/>
+            <a:ext cx="12191695" cy="64008"/>
           </a:xfrm>
           <a:prstGeom prst="rect">
             <a:avLst/>
@@ -3692,8 +3897,8 @@
         </p:nvSpPr>
         <p:spPr>
           <a:xfrm>
-            <a:off x="457200" y="109728"/>
-            <a:ext cx="11277295" cy="777240"/>
+            <a:off x="457200" y="137160"/>
+            <a:ext cx="8351215" cy="731520"/>
           </a:xfrm>
           <a:prstGeom prst="rect">
             <a:avLst/>
@@ -3731,8 +3936,8 @@
         </p:nvSpPr>
         <p:spPr>
           <a:xfrm>
-            <a:off x="640080" y="1371600"/>
-            <a:ext cx="10911535" cy="5029200"/>
+            <a:off x="8534095" y="137160"/>
+            <a:ext cx="3200400" cy="731520"/>
           </a:xfrm>
           <a:prstGeom prst="rect">
             <a:avLst/>
@@ -3740,18 +3945,267 @@
           <a:noFill/>
         </p:spPr>
         <p:txBody>
-          <a:bodyPr wrap="square">
+          <a:bodyPr wrap="square" anchor="ctr">
             <a:spAutoFit/>
           </a:bodyPr>
           <a:lstStyle/>
           <a:p>
+            <a:pPr algn="r">
+              <a:spcAft>
+                <a:spcPts val="600"/>
+              </a:spcAft>
+            </a:pPr>
+            <a:r>
+              <a:rPr sz="1200" b="1">
+                <a:solidFill>
+                  <a:srgbClr val="C9A227"/>
+                </a:solidFill>
+                <a:latin typeface="Calibri"/>
+              </a:rPr>
+              <a:t>Gold Price Prediction</a:t>
+            </a:r>
+          </a:p>
+        </p:txBody>
+      </p:sp>
+      <p:sp>
+        <p:nvSpPr>
+          <p:cNvPr id="6" name="Rectangle 5"/>
+          <p:cNvSpPr/>
+          <p:nvPr/>
+        </p:nvSpPr>
+        <p:spPr>
+          <a:xfrm>
+            <a:off x="0" y="6473952"/>
+            <a:ext cx="12191695" cy="384048"/>
+          </a:xfrm>
+          <a:prstGeom prst="rect">
+            <a:avLst/>
+          </a:prstGeom>
+          <a:solidFill>
+            <a:srgbClr val="1F3864"/>
+          </a:solidFill>
+          <a:ln>
+            <a:noFill/>
+          </a:ln>
+          <a:effectLst/>
+        </p:spPr>
+        <p:style>
+          <a:lnRef idx="1">
+            <a:schemeClr val="accent1"/>
+          </a:lnRef>
+          <a:fillRef idx="3">
+            <a:schemeClr val="accent1"/>
+          </a:fillRef>
+          <a:effectRef idx="2">
+            <a:schemeClr val="accent1"/>
+          </a:effectRef>
+          <a:fontRef idx="minor">
+            <a:schemeClr val="lt1"/>
+          </a:fontRef>
+        </p:style>
+        <p:txBody>
+          <a:bodyPr rtlCol="0" anchor="ctr"/>
+          <a:lstStyle/>
+          <a:p>
+            <a:pPr algn="ctr"/>
+          </a:p>
+        </p:txBody>
+      </p:sp>
+      <p:sp>
+        <p:nvSpPr>
+          <p:cNvPr id="7" name="Rectangle 6"/>
+          <p:cNvSpPr/>
+          <p:nvPr/>
+        </p:nvSpPr>
+        <p:spPr>
+          <a:xfrm>
+            <a:off x="0" y="6473952"/>
+            <a:ext cx="128016" cy="384048"/>
+          </a:xfrm>
+          <a:prstGeom prst="rect">
+            <a:avLst/>
+          </a:prstGeom>
+          <a:solidFill>
+            <a:srgbClr val="C9A227"/>
+          </a:solidFill>
+          <a:ln>
+            <a:noFill/>
+          </a:ln>
+          <a:effectLst/>
+        </p:spPr>
+        <p:style>
+          <a:lnRef idx="1">
+            <a:schemeClr val="accent1"/>
+          </a:lnRef>
+          <a:fillRef idx="3">
+            <a:schemeClr val="accent1"/>
+          </a:fillRef>
+          <a:effectRef idx="2">
+            <a:schemeClr val="accent1"/>
+          </a:effectRef>
+          <a:fontRef idx="minor">
+            <a:schemeClr val="lt1"/>
+          </a:fontRef>
+        </p:style>
+        <p:txBody>
+          <a:bodyPr rtlCol="0" anchor="ctr"/>
+          <a:lstStyle/>
+          <a:p>
+            <a:pPr algn="ctr"/>
+          </a:p>
+        </p:txBody>
+      </p:sp>
+      <p:sp>
+        <p:nvSpPr>
+          <p:cNvPr id="8" name="TextBox 7"/>
+          <p:cNvSpPr txBox="1"/>
+          <p:nvPr/>
+        </p:nvSpPr>
+        <p:spPr>
+          <a:xfrm>
+            <a:off x="274320" y="6473952"/>
+            <a:ext cx="10362895" cy="384048"/>
+          </a:xfrm>
+          <a:prstGeom prst="rect">
+            <a:avLst/>
+          </a:prstGeom>
+          <a:noFill/>
+        </p:spPr>
+        <p:txBody>
+          <a:bodyPr wrap="square" anchor="ctr">
+            <a:spAutoFit/>
+          </a:bodyPr>
+          <a:lstStyle/>
+          <a:p>
             <a:pPr algn="l">
               <a:spcAft>
-                <a:spcPts val="1400"/>
+                <a:spcPts val="600"/>
               </a:spcAft>
             </a:pPr>
             <a:r>
-              <a:rPr sz="1800" b="0">
+              <a:rPr sz="900" b="0">
+                <a:solidFill>
+                  <a:srgbClr val="FFFFFF"/>
+                </a:solidFill>
+                <a:latin typeface="Calibri"/>
+              </a:rPr>
+              <a:t>Sanchay Bhardwaj (2300650100104)  |  B.S.A. College of Engineering &amp; Technology, Mathura</a:t>
+            </a:r>
+          </a:p>
+        </p:txBody>
+      </p:sp>
+      <p:sp>
+        <p:nvSpPr>
+          <p:cNvPr id="9" name="TextBox 8"/>
+          <p:cNvSpPr txBox="1"/>
+          <p:nvPr/>
+        </p:nvSpPr>
+        <p:spPr>
+          <a:xfrm>
+            <a:off x="10728655" y="6473952"/>
+            <a:ext cx="1188720" cy="384048"/>
+          </a:xfrm>
+          <a:prstGeom prst="rect">
+            <a:avLst/>
+          </a:prstGeom>
+          <a:noFill/>
+        </p:spPr>
+        <p:txBody>
+          <a:bodyPr wrap="square" anchor="ctr">
+            <a:spAutoFit/>
+          </a:bodyPr>
+          <a:lstStyle/>
+          <a:p>
+            <a:pPr algn="r">
+              <a:spcAft>
+                <a:spcPts val="600"/>
+              </a:spcAft>
+            </a:pPr>
+            <a:r>
+              <a:rPr sz="900" b="1">
+                <a:solidFill>
+                  <a:srgbClr val="C9A227"/>
+                </a:solidFill>
+                <a:latin typeface="Calibri"/>
+              </a:rPr>
+              <a:t>Slide 11</a:t>
+            </a:r>
+          </a:p>
+        </p:txBody>
+      </p:sp>
+      <p:sp>
+        <p:nvSpPr>
+          <p:cNvPr id="10" name="Rectangle 9"/>
+          <p:cNvSpPr/>
+          <p:nvPr/>
+        </p:nvSpPr>
+        <p:spPr>
+          <a:xfrm>
+            <a:off x="502920" y="1554480"/>
+            <a:ext cx="82296" cy="4297680"/>
+          </a:xfrm>
+          <a:prstGeom prst="rect">
+            <a:avLst/>
+          </a:prstGeom>
+          <a:solidFill>
+            <a:srgbClr val="C9A227"/>
+          </a:solidFill>
+          <a:ln>
+            <a:noFill/>
+          </a:ln>
+          <a:effectLst/>
+        </p:spPr>
+        <p:style>
+          <a:lnRef idx="1">
+            <a:schemeClr val="accent1"/>
+          </a:lnRef>
+          <a:fillRef idx="3">
+            <a:schemeClr val="accent1"/>
+          </a:fillRef>
+          <a:effectRef idx="2">
+            <a:schemeClr val="accent1"/>
+          </a:effectRef>
+          <a:fontRef idx="minor">
+            <a:schemeClr val="lt1"/>
+          </a:fontRef>
+        </p:style>
+        <p:txBody>
+          <a:bodyPr rtlCol="0" anchor="ctr"/>
+          <a:lstStyle/>
+          <a:p>
+            <a:pPr algn="ctr"/>
+          </a:p>
+        </p:txBody>
+      </p:sp>
+      <p:sp>
+        <p:nvSpPr>
+          <p:cNvPr id="11" name="TextBox 10"/>
+          <p:cNvSpPr txBox="1"/>
+          <p:nvPr/>
+        </p:nvSpPr>
+        <p:spPr>
+          <a:xfrm>
+            <a:off x="868680" y="1371600"/>
+            <a:ext cx="10728655" cy="4663440"/>
+          </a:xfrm>
+          <a:prstGeom prst="rect">
+            <a:avLst/>
+          </a:prstGeom>
+          <a:noFill/>
+        </p:spPr>
+        <p:txBody>
+          <a:bodyPr wrap="square" anchor="ctr">
+            <a:spAutoFit/>
+          </a:bodyPr>
+          <a:lstStyle/>
+          <a:p>
+            <a:pPr algn="l">
+              <a:spcAft>
+                <a:spcPts val="2200"/>
+              </a:spcAft>
+            </a:pPr>
+            <a:r>
+              <a:rPr sz="2000" b="0">
                 <a:solidFill>
                   <a:srgbClr val="222222"/>
                 </a:solidFill>
@@ -3763,11 +4217,11 @@
           <a:p>
             <a:pPr algn="l">
               <a:spcAft>
-                <a:spcPts val="1400"/>
+                <a:spcPts val="2200"/>
               </a:spcAft>
             </a:pPr>
             <a:r>
-              <a:rPr sz="1800" b="0">
+              <a:rPr sz="2000" b="0">
                 <a:solidFill>
                   <a:srgbClr val="222222"/>
                 </a:solidFill>
@@ -3779,11 +4233,11 @@
           <a:p>
             <a:pPr algn="l">
               <a:spcAft>
-                <a:spcPts val="1400"/>
+                <a:spcPts val="2200"/>
               </a:spcAft>
             </a:pPr>
             <a:r>
-              <a:rPr sz="1800" b="0">
+              <a:rPr sz="2000" b="0">
                 <a:solidFill>
                   <a:srgbClr val="222222"/>
                 </a:solidFill>
@@ -3795,11 +4249,11 @@
           <a:p>
             <a:pPr algn="l">
               <a:spcAft>
-                <a:spcPts val="1400"/>
+                <a:spcPts val="2200"/>
               </a:spcAft>
             </a:pPr>
             <a:r>
-              <a:rPr sz="1800" b="0">
+              <a:rPr sz="2000" b="0">
                 <a:solidFill>
                   <a:srgbClr val="222222"/>
                 </a:solidFill>
@@ -3881,7 +4335,7 @@
         <p:spPr>
           <a:xfrm>
             <a:off x="0" y="960120"/>
-            <a:ext cx="12191695" cy="54864"/>
+            <a:ext cx="12191695" cy="64008"/>
           </a:xfrm>
           <a:prstGeom prst="rect">
             <a:avLst/>
@@ -3924,8 +4378,8 @@
         </p:nvSpPr>
         <p:spPr>
           <a:xfrm>
-            <a:off x="457200" y="109728"/>
-            <a:ext cx="11277295" cy="777240"/>
+            <a:off x="457200" y="137160"/>
+            <a:ext cx="8351215" cy="731520"/>
           </a:xfrm>
           <a:prstGeom prst="rect">
             <a:avLst/>
@@ -3963,8 +4417,8 @@
         </p:nvSpPr>
         <p:spPr>
           <a:xfrm>
-            <a:off x="640080" y="1371600"/>
-            <a:ext cx="10911535" cy="5029200"/>
+            <a:off x="8534095" y="137160"/>
+            <a:ext cx="3200400" cy="731520"/>
           </a:xfrm>
           <a:prstGeom prst="rect">
             <a:avLst/>
@@ -3972,18 +4426,267 @@
           <a:noFill/>
         </p:spPr>
         <p:txBody>
-          <a:bodyPr wrap="square">
+          <a:bodyPr wrap="square" anchor="ctr">
             <a:spAutoFit/>
           </a:bodyPr>
           <a:lstStyle/>
           <a:p>
+            <a:pPr algn="r">
+              <a:spcAft>
+                <a:spcPts val="600"/>
+              </a:spcAft>
+            </a:pPr>
+            <a:r>
+              <a:rPr sz="1200" b="1">
+                <a:solidFill>
+                  <a:srgbClr val="C9A227"/>
+                </a:solidFill>
+                <a:latin typeface="Calibri"/>
+              </a:rPr>
+              <a:t>Gold Price Prediction</a:t>
+            </a:r>
+          </a:p>
+        </p:txBody>
+      </p:sp>
+      <p:sp>
+        <p:nvSpPr>
+          <p:cNvPr id="6" name="Rectangle 5"/>
+          <p:cNvSpPr/>
+          <p:nvPr/>
+        </p:nvSpPr>
+        <p:spPr>
+          <a:xfrm>
+            <a:off x="0" y="6473952"/>
+            <a:ext cx="12191695" cy="384048"/>
+          </a:xfrm>
+          <a:prstGeom prst="rect">
+            <a:avLst/>
+          </a:prstGeom>
+          <a:solidFill>
+            <a:srgbClr val="1F3864"/>
+          </a:solidFill>
+          <a:ln>
+            <a:noFill/>
+          </a:ln>
+          <a:effectLst/>
+        </p:spPr>
+        <p:style>
+          <a:lnRef idx="1">
+            <a:schemeClr val="accent1"/>
+          </a:lnRef>
+          <a:fillRef idx="3">
+            <a:schemeClr val="accent1"/>
+          </a:fillRef>
+          <a:effectRef idx="2">
+            <a:schemeClr val="accent1"/>
+          </a:effectRef>
+          <a:fontRef idx="minor">
+            <a:schemeClr val="lt1"/>
+          </a:fontRef>
+        </p:style>
+        <p:txBody>
+          <a:bodyPr rtlCol="0" anchor="ctr"/>
+          <a:lstStyle/>
+          <a:p>
+            <a:pPr algn="ctr"/>
+          </a:p>
+        </p:txBody>
+      </p:sp>
+      <p:sp>
+        <p:nvSpPr>
+          <p:cNvPr id="7" name="Rectangle 6"/>
+          <p:cNvSpPr/>
+          <p:nvPr/>
+        </p:nvSpPr>
+        <p:spPr>
+          <a:xfrm>
+            <a:off x="0" y="6473952"/>
+            <a:ext cx="128016" cy="384048"/>
+          </a:xfrm>
+          <a:prstGeom prst="rect">
+            <a:avLst/>
+          </a:prstGeom>
+          <a:solidFill>
+            <a:srgbClr val="C9A227"/>
+          </a:solidFill>
+          <a:ln>
+            <a:noFill/>
+          </a:ln>
+          <a:effectLst/>
+        </p:spPr>
+        <p:style>
+          <a:lnRef idx="1">
+            <a:schemeClr val="accent1"/>
+          </a:lnRef>
+          <a:fillRef idx="3">
+            <a:schemeClr val="accent1"/>
+          </a:fillRef>
+          <a:effectRef idx="2">
+            <a:schemeClr val="accent1"/>
+          </a:effectRef>
+          <a:fontRef idx="minor">
+            <a:schemeClr val="lt1"/>
+          </a:fontRef>
+        </p:style>
+        <p:txBody>
+          <a:bodyPr rtlCol="0" anchor="ctr"/>
+          <a:lstStyle/>
+          <a:p>
+            <a:pPr algn="ctr"/>
+          </a:p>
+        </p:txBody>
+      </p:sp>
+      <p:sp>
+        <p:nvSpPr>
+          <p:cNvPr id="8" name="TextBox 7"/>
+          <p:cNvSpPr txBox="1"/>
+          <p:nvPr/>
+        </p:nvSpPr>
+        <p:spPr>
+          <a:xfrm>
+            <a:off x="274320" y="6473952"/>
+            <a:ext cx="10362895" cy="384048"/>
+          </a:xfrm>
+          <a:prstGeom prst="rect">
+            <a:avLst/>
+          </a:prstGeom>
+          <a:noFill/>
+        </p:spPr>
+        <p:txBody>
+          <a:bodyPr wrap="square" anchor="ctr">
+            <a:spAutoFit/>
+          </a:bodyPr>
+          <a:lstStyle/>
+          <a:p>
             <a:pPr algn="l">
               <a:spcAft>
-                <a:spcPts val="1400"/>
+                <a:spcPts val="600"/>
               </a:spcAft>
             </a:pPr>
             <a:r>
-              <a:rPr sz="1800" b="0">
+              <a:rPr sz="900" b="0">
+                <a:solidFill>
+                  <a:srgbClr val="FFFFFF"/>
+                </a:solidFill>
+                <a:latin typeface="Calibri"/>
+              </a:rPr>
+              <a:t>Sanchay Bhardwaj (2300650100104)  |  B.S.A. College of Engineering &amp; Technology, Mathura</a:t>
+            </a:r>
+          </a:p>
+        </p:txBody>
+      </p:sp>
+      <p:sp>
+        <p:nvSpPr>
+          <p:cNvPr id="9" name="TextBox 8"/>
+          <p:cNvSpPr txBox="1"/>
+          <p:nvPr/>
+        </p:nvSpPr>
+        <p:spPr>
+          <a:xfrm>
+            <a:off x="10728655" y="6473952"/>
+            <a:ext cx="1188720" cy="384048"/>
+          </a:xfrm>
+          <a:prstGeom prst="rect">
+            <a:avLst/>
+          </a:prstGeom>
+          <a:noFill/>
+        </p:spPr>
+        <p:txBody>
+          <a:bodyPr wrap="square" anchor="ctr">
+            <a:spAutoFit/>
+          </a:bodyPr>
+          <a:lstStyle/>
+          <a:p>
+            <a:pPr algn="r">
+              <a:spcAft>
+                <a:spcPts val="600"/>
+              </a:spcAft>
+            </a:pPr>
+            <a:r>
+              <a:rPr sz="900" b="1">
+                <a:solidFill>
+                  <a:srgbClr val="C9A227"/>
+                </a:solidFill>
+                <a:latin typeface="Calibri"/>
+              </a:rPr>
+              <a:t>Slide 12</a:t>
+            </a:r>
+          </a:p>
+        </p:txBody>
+      </p:sp>
+      <p:sp>
+        <p:nvSpPr>
+          <p:cNvPr id="10" name="Rectangle 9"/>
+          <p:cNvSpPr/>
+          <p:nvPr/>
+        </p:nvSpPr>
+        <p:spPr>
+          <a:xfrm>
+            <a:off x="502920" y="1554480"/>
+            <a:ext cx="82296" cy="4297680"/>
+          </a:xfrm>
+          <a:prstGeom prst="rect">
+            <a:avLst/>
+          </a:prstGeom>
+          <a:solidFill>
+            <a:srgbClr val="C9A227"/>
+          </a:solidFill>
+          <a:ln>
+            <a:noFill/>
+          </a:ln>
+          <a:effectLst/>
+        </p:spPr>
+        <p:style>
+          <a:lnRef idx="1">
+            <a:schemeClr val="accent1"/>
+          </a:lnRef>
+          <a:fillRef idx="3">
+            <a:schemeClr val="accent1"/>
+          </a:fillRef>
+          <a:effectRef idx="2">
+            <a:schemeClr val="accent1"/>
+          </a:effectRef>
+          <a:fontRef idx="minor">
+            <a:schemeClr val="lt1"/>
+          </a:fontRef>
+        </p:style>
+        <p:txBody>
+          <a:bodyPr rtlCol="0" anchor="ctr"/>
+          <a:lstStyle/>
+          <a:p>
+            <a:pPr algn="ctr"/>
+          </a:p>
+        </p:txBody>
+      </p:sp>
+      <p:sp>
+        <p:nvSpPr>
+          <p:cNvPr id="11" name="TextBox 10"/>
+          <p:cNvSpPr txBox="1"/>
+          <p:nvPr/>
+        </p:nvSpPr>
+        <p:spPr>
+          <a:xfrm>
+            <a:off x="868680" y="1371600"/>
+            <a:ext cx="10728655" cy="4663440"/>
+          </a:xfrm>
+          <a:prstGeom prst="rect">
+            <a:avLst/>
+          </a:prstGeom>
+          <a:noFill/>
+        </p:spPr>
+        <p:txBody>
+          <a:bodyPr wrap="square" anchor="ctr">
+            <a:spAutoFit/>
+          </a:bodyPr>
+          <a:lstStyle/>
+          <a:p>
+            <a:pPr algn="l">
+              <a:spcAft>
+                <a:spcPts val="2200"/>
+              </a:spcAft>
+            </a:pPr>
+            <a:r>
+              <a:rPr sz="2000" b="0">
                 <a:solidFill>
                   <a:srgbClr val="222222"/>
                 </a:solidFill>
@@ -3995,11 +4698,11 @@
           <a:p>
             <a:pPr algn="l">
               <a:spcAft>
-                <a:spcPts val="1400"/>
+                <a:spcPts val="2200"/>
               </a:spcAft>
             </a:pPr>
             <a:r>
-              <a:rPr sz="1800" b="0">
+              <a:rPr sz="2000" b="0">
                 <a:solidFill>
                   <a:srgbClr val="222222"/>
                 </a:solidFill>
@@ -4011,11 +4714,11 @@
           <a:p>
             <a:pPr algn="l">
               <a:spcAft>
-                <a:spcPts val="1400"/>
+                <a:spcPts val="2200"/>
               </a:spcAft>
             </a:pPr>
             <a:r>
-              <a:rPr sz="1800" b="0">
+              <a:rPr sz="2000" b="0">
                 <a:solidFill>
                   <a:srgbClr val="222222"/>
                 </a:solidFill>
@@ -4027,11 +4730,11 @@
           <a:p>
             <a:pPr algn="l">
               <a:spcAft>
-                <a:spcPts val="1400"/>
+                <a:spcPts val="2200"/>
               </a:spcAft>
             </a:pPr>
             <a:r>
-              <a:rPr sz="1800" b="0">
+              <a:rPr sz="2000" b="0">
                 <a:solidFill>
                   <a:srgbClr val="222222"/>
                 </a:solidFill>
@@ -4112,7 +4815,7 @@
         </p:nvSpPr>
         <p:spPr>
           <a:xfrm>
-            <a:off x="0" y="3566160"/>
+            <a:off x="0" y="3246120"/>
             <a:ext cx="12191695" cy="54864"/>
           </a:xfrm>
           <a:prstGeom prst="rect">
@@ -4148,16 +4851,40 @@
           </a:p>
         </p:txBody>
       </p:sp>
-      <p:sp>
-        <p:nvSpPr>
-          <p:cNvPr id="4" name="TextBox 3"/>
+      <p:pic>
+        <p:nvPicPr>
+          <p:cNvPr id="4" name="Picture 3" descr="college_logo_navy.png"/>
+          <p:cNvPicPr>
+            <a:picLocks noChangeAspect="1"/>
+          </p:cNvPicPr>
+          <p:nvPr/>
+        </p:nvPicPr>
+        <p:blipFill>
+          <a:blip r:embed="rId2"/>
+          <a:stretch>
+            <a:fillRect/>
+          </a:stretch>
+        </p:blipFill>
+        <p:spPr>
+          <a:xfrm>
+            <a:off x="5455767" y="822960"/>
+            <a:ext cx="1280160" cy="1280160"/>
+          </a:xfrm>
+          <a:prstGeom prst="rect">
+            <a:avLst/>
+          </a:prstGeom>
+        </p:spPr>
+      </p:pic>
+      <p:sp>
+        <p:nvSpPr>
+          <p:cNvPr id="5" name="TextBox 4"/>
           <p:cNvSpPr txBox="1"/>
           <p:nvPr/>
         </p:nvSpPr>
         <p:spPr>
           <a:xfrm>
-            <a:off x="914400" y="2377440"/>
-            <a:ext cx="10362895" cy="1280160"/>
+            <a:off x="914400" y="2468880"/>
+            <a:ext cx="10362895" cy="1097280"/>
           </a:xfrm>
           <a:prstGeom prst="rect">
             <a:avLst/>
@@ -4189,14 +4916,14 @@
       </p:sp>
       <p:sp>
         <p:nvSpPr>
-          <p:cNvPr id="5" name="TextBox 4"/>
+          <p:cNvPr id="6" name="TextBox 5"/>
           <p:cNvSpPr txBox="1"/>
           <p:nvPr/>
         </p:nvSpPr>
         <p:spPr>
           <a:xfrm>
-            <a:off x="914400" y="3840480"/>
-            <a:ext cx="10362895" cy="1097280"/>
+            <a:off x="914400" y="3657600"/>
+            <a:ext cx="10362895" cy="2377440"/>
           </a:xfrm>
           <a:prstGeom prst="rect">
             <a:avLst/>
@@ -4211,7 +4938,7 @@
           <a:p>
             <a:pPr algn="ctr">
               <a:spcAft>
-                <a:spcPts val="800"/>
+                <a:spcPts val="1600"/>
               </a:spcAft>
             </a:pPr>
             <a:r>
@@ -4222,6 +4949,38 @@
                 <a:latin typeface="Calibri"/>
               </a:rPr>
               <a:t>Questions &amp; suggestions are welcome</a:t>
+            </a:r>
+          </a:p>
+          <a:p>
+            <a:pPr algn="ctr">
+              <a:spcAft>
+                <a:spcPts val="300"/>
+              </a:spcAft>
+            </a:pPr>
+            <a:r>
+              <a:rPr sz="1500" b="0">
+                <a:solidFill>
+                  <a:srgbClr val="FFFFFF"/>
+                </a:solidFill>
+                <a:latin typeface="Calibri"/>
+              </a:rPr>
+              <a:t>Sanchay Bhardwaj  (2300650100104)</a:t>
+            </a:r>
+          </a:p>
+          <a:p>
+            <a:pPr algn="ctr">
+              <a:spcAft>
+                <a:spcPts val="300"/>
+              </a:spcAft>
+            </a:pPr>
+            <a:r>
+              <a:rPr sz="1400" b="0">
+                <a:solidFill>
+                  <a:srgbClr val="FFFFFF"/>
+                </a:solidFill>
+                <a:latin typeface="Calibri"/>
+              </a:rPr>
+              <a:t>Guide: Mrs. Ashna Thakur</a:t>
             </a:r>
           </a:p>
           <a:p>
@@ -4231,13 +4990,13 @@
               </a:spcAft>
             </a:pPr>
             <a:r>
-              <a:rPr sz="1400" b="0">
-                <a:solidFill>
-                  <a:srgbClr val="FFFFFF"/>
+              <a:rPr sz="1300" b="0">
+                <a:solidFill>
+                  <a:srgbClr val="C9A227"/>
                 </a:solidFill>
                 <a:latin typeface="Calibri"/>
               </a:rPr>
-              <a:t>Gold Price Prediction using Machine Learning</a:t>
+              <a:t>B.S.A. College of Engineering &amp; Technology, Mathura</a:t>
             </a:r>
           </a:p>
         </p:txBody>
@@ -4313,7 +5072,7 @@
         <p:spPr>
           <a:xfrm>
             <a:off x="0" y="960120"/>
-            <a:ext cx="12191695" cy="54864"/>
+            <a:ext cx="12191695" cy="64008"/>
           </a:xfrm>
           <a:prstGeom prst="rect">
             <a:avLst/>
@@ -4356,8 +5115,8 @@
         </p:nvSpPr>
         <p:spPr>
           <a:xfrm>
-            <a:off x="457200" y="109728"/>
-            <a:ext cx="11277295" cy="777240"/>
+            <a:off x="457200" y="137160"/>
+            <a:ext cx="8351215" cy="731520"/>
           </a:xfrm>
           <a:prstGeom prst="rect">
             <a:avLst/>
@@ -4395,8 +5154,8 @@
         </p:nvSpPr>
         <p:spPr>
           <a:xfrm>
-            <a:off x="640080" y="1371600"/>
-            <a:ext cx="10911535" cy="5029200"/>
+            <a:off x="8534095" y="137160"/>
+            <a:ext cx="3200400" cy="731520"/>
           </a:xfrm>
           <a:prstGeom prst="rect">
             <a:avLst/>
@@ -4404,18 +5163,267 @@
           <a:noFill/>
         </p:spPr>
         <p:txBody>
-          <a:bodyPr wrap="square">
+          <a:bodyPr wrap="square" anchor="ctr">
             <a:spAutoFit/>
           </a:bodyPr>
           <a:lstStyle/>
           <a:p>
+            <a:pPr algn="r">
+              <a:spcAft>
+                <a:spcPts val="600"/>
+              </a:spcAft>
+            </a:pPr>
+            <a:r>
+              <a:rPr sz="1200" b="1">
+                <a:solidFill>
+                  <a:srgbClr val="C9A227"/>
+                </a:solidFill>
+                <a:latin typeface="Calibri"/>
+              </a:rPr>
+              <a:t>Gold Price Prediction</a:t>
+            </a:r>
+          </a:p>
+        </p:txBody>
+      </p:sp>
+      <p:sp>
+        <p:nvSpPr>
+          <p:cNvPr id="6" name="Rectangle 5"/>
+          <p:cNvSpPr/>
+          <p:nvPr/>
+        </p:nvSpPr>
+        <p:spPr>
+          <a:xfrm>
+            <a:off x="0" y="6473952"/>
+            <a:ext cx="12191695" cy="384048"/>
+          </a:xfrm>
+          <a:prstGeom prst="rect">
+            <a:avLst/>
+          </a:prstGeom>
+          <a:solidFill>
+            <a:srgbClr val="1F3864"/>
+          </a:solidFill>
+          <a:ln>
+            <a:noFill/>
+          </a:ln>
+          <a:effectLst/>
+        </p:spPr>
+        <p:style>
+          <a:lnRef idx="1">
+            <a:schemeClr val="accent1"/>
+          </a:lnRef>
+          <a:fillRef idx="3">
+            <a:schemeClr val="accent1"/>
+          </a:fillRef>
+          <a:effectRef idx="2">
+            <a:schemeClr val="accent1"/>
+          </a:effectRef>
+          <a:fontRef idx="minor">
+            <a:schemeClr val="lt1"/>
+          </a:fontRef>
+        </p:style>
+        <p:txBody>
+          <a:bodyPr rtlCol="0" anchor="ctr"/>
+          <a:lstStyle/>
+          <a:p>
+            <a:pPr algn="ctr"/>
+          </a:p>
+        </p:txBody>
+      </p:sp>
+      <p:sp>
+        <p:nvSpPr>
+          <p:cNvPr id="7" name="Rectangle 6"/>
+          <p:cNvSpPr/>
+          <p:nvPr/>
+        </p:nvSpPr>
+        <p:spPr>
+          <a:xfrm>
+            <a:off x="0" y="6473952"/>
+            <a:ext cx="128016" cy="384048"/>
+          </a:xfrm>
+          <a:prstGeom prst="rect">
+            <a:avLst/>
+          </a:prstGeom>
+          <a:solidFill>
+            <a:srgbClr val="C9A227"/>
+          </a:solidFill>
+          <a:ln>
+            <a:noFill/>
+          </a:ln>
+          <a:effectLst/>
+        </p:spPr>
+        <p:style>
+          <a:lnRef idx="1">
+            <a:schemeClr val="accent1"/>
+          </a:lnRef>
+          <a:fillRef idx="3">
+            <a:schemeClr val="accent1"/>
+          </a:fillRef>
+          <a:effectRef idx="2">
+            <a:schemeClr val="accent1"/>
+          </a:effectRef>
+          <a:fontRef idx="minor">
+            <a:schemeClr val="lt1"/>
+          </a:fontRef>
+        </p:style>
+        <p:txBody>
+          <a:bodyPr rtlCol="0" anchor="ctr"/>
+          <a:lstStyle/>
+          <a:p>
+            <a:pPr algn="ctr"/>
+          </a:p>
+        </p:txBody>
+      </p:sp>
+      <p:sp>
+        <p:nvSpPr>
+          <p:cNvPr id="8" name="TextBox 7"/>
+          <p:cNvSpPr txBox="1"/>
+          <p:nvPr/>
+        </p:nvSpPr>
+        <p:spPr>
+          <a:xfrm>
+            <a:off x="274320" y="6473952"/>
+            <a:ext cx="10362895" cy="384048"/>
+          </a:xfrm>
+          <a:prstGeom prst="rect">
+            <a:avLst/>
+          </a:prstGeom>
+          <a:noFill/>
+        </p:spPr>
+        <p:txBody>
+          <a:bodyPr wrap="square" anchor="ctr">
+            <a:spAutoFit/>
+          </a:bodyPr>
+          <a:lstStyle/>
+          <a:p>
             <a:pPr algn="l">
               <a:spcAft>
-                <a:spcPts val="1400"/>
+                <a:spcPts val="600"/>
               </a:spcAft>
             </a:pPr>
             <a:r>
-              <a:rPr sz="1800" b="0">
+              <a:rPr sz="900" b="0">
+                <a:solidFill>
+                  <a:srgbClr val="FFFFFF"/>
+                </a:solidFill>
+                <a:latin typeface="Calibri"/>
+              </a:rPr>
+              <a:t>Sanchay Bhardwaj (2300650100104)  |  B.S.A. College of Engineering &amp; Technology, Mathura</a:t>
+            </a:r>
+          </a:p>
+        </p:txBody>
+      </p:sp>
+      <p:sp>
+        <p:nvSpPr>
+          <p:cNvPr id="9" name="TextBox 8"/>
+          <p:cNvSpPr txBox="1"/>
+          <p:nvPr/>
+        </p:nvSpPr>
+        <p:spPr>
+          <a:xfrm>
+            <a:off x="10728655" y="6473952"/>
+            <a:ext cx="1188720" cy="384048"/>
+          </a:xfrm>
+          <a:prstGeom prst="rect">
+            <a:avLst/>
+          </a:prstGeom>
+          <a:noFill/>
+        </p:spPr>
+        <p:txBody>
+          <a:bodyPr wrap="square" anchor="ctr">
+            <a:spAutoFit/>
+          </a:bodyPr>
+          <a:lstStyle/>
+          <a:p>
+            <a:pPr algn="r">
+              <a:spcAft>
+                <a:spcPts val="600"/>
+              </a:spcAft>
+            </a:pPr>
+            <a:r>
+              <a:rPr sz="900" b="1">
+                <a:solidFill>
+                  <a:srgbClr val="C9A227"/>
+                </a:solidFill>
+                <a:latin typeface="Calibri"/>
+              </a:rPr>
+              <a:t>Slide 2</a:t>
+            </a:r>
+          </a:p>
+        </p:txBody>
+      </p:sp>
+      <p:sp>
+        <p:nvSpPr>
+          <p:cNvPr id="10" name="Rectangle 9"/>
+          <p:cNvSpPr/>
+          <p:nvPr/>
+        </p:nvSpPr>
+        <p:spPr>
+          <a:xfrm>
+            <a:off x="502920" y="1554480"/>
+            <a:ext cx="82296" cy="4297680"/>
+          </a:xfrm>
+          <a:prstGeom prst="rect">
+            <a:avLst/>
+          </a:prstGeom>
+          <a:solidFill>
+            <a:srgbClr val="C9A227"/>
+          </a:solidFill>
+          <a:ln>
+            <a:noFill/>
+          </a:ln>
+          <a:effectLst/>
+        </p:spPr>
+        <p:style>
+          <a:lnRef idx="1">
+            <a:schemeClr val="accent1"/>
+          </a:lnRef>
+          <a:fillRef idx="3">
+            <a:schemeClr val="accent1"/>
+          </a:fillRef>
+          <a:effectRef idx="2">
+            <a:schemeClr val="accent1"/>
+          </a:effectRef>
+          <a:fontRef idx="minor">
+            <a:schemeClr val="lt1"/>
+          </a:fontRef>
+        </p:style>
+        <p:txBody>
+          <a:bodyPr rtlCol="0" anchor="ctr"/>
+          <a:lstStyle/>
+          <a:p>
+            <a:pPr algn="ctr"/>
+          </a:p>
+        </p:txBody>
+      </p:sp>
+      <p:sp>
+        <p:nvSpPr>
+          <p:cNvPr id="11" name="TextBox 10"/>
+          <p:cNvSpPr txBox="1"/>
+          <p:nvPr/>
+        </p:nvSpPr>
+        <p:spPr>
+          <a:xfrm>
+            <a:off x="868680" y="1371600"/>
+            <a:ext cx="10728655" cy="4663440"/>
+          </a:xfrm>
+          <a:prstGeom prst="rect">
+            <a:avLst/>
+          </a:prstGeom>
+          <a:noFill/>
+        </p:spPr>
+        <p:txBody>
+          <a:bodyPr wrap="square" anchor="ctr">
+            <a:spAutoFit/>
+          </a:bodyPr>
+          <a:lstStyle/>
+          <a:p>
+            <a:pPr algn="l">
+              <a:spcAft>
+                <a:spcPts val="2200"/>
+              </a:spcAft>
+            </a:pPr>
+            <a:r>
+              <a:rPr sz="2000" b="0">
                 <a:solidFill>
                   <a:srgbClr val="222222"/>
                 </a:solidFill>
@@ -4427,11 +5435,11 @@
           <a:p>
             <a:pPr algn="l">
               <a:spcAft>
-                <a:spcPts val="1400"/>
+                <a:spcPts val="2200"/>
               </a:spcAft>
             </a:pPr>
             <a:r>
-              <a:rPr sz="1800" b="0">
+              <a:rPr sz="2000" b="0">
                 <a:solidFill>
                   <a:srgbClr val="222222"/>
                 </a:solidFill>
@@ -4443,11 +5451,11 @@
           <a:p>
             <a:pPr algn="l">
               <a:spcAft>
-                <a:spcPts val="1400"/>
+                <a:spcPts val="2200"/>
               </a:spcAft>
             </a:pPr>
             <a:r>
-              <a:rPr sz="1800" b="0">
+              <a:rPr sz="2000" b="0">
                 <a:solidFill>
                   <a:srgbClr val="222222"/>
                 </a:solidFill>
@@ -4459,11 +5467,11 @@
           <a:p>
             <a:pPr algn="l">
               <a:spcAft>
-                <a:spcPts val="1400"/>
+                <a:spcPts val="2200"/>
               </a:spcAft>
             </a:pPr>
             <a:r>
-              <a:rPr sz="1800" b="0">
+              <a:rPr sz="2000" b="0">
                 <a:solidFill>
                   <a:srgbClr val="222222"/>
                 </a:solidFill>
@@ -4545,7 +5553,7 @@
         <p:spPr>
           <a:xfrm>
             <a:off x="0" y="960120"/>
-            <a:ext cx="12191695" cy="54864"/>
+            <a:ext cx="12191695" cy="64008"/>
           </a:xfrm>
           <a:prstGeom prst="rect">
             <a:avLst/>
@@ -4588,8 +5596,8 @@
         </p:nvSpPr>
         <p:spPr>
           <a:xfrm>
-            <a:off x="457200" y="109728"/>
-            <a:ext cx="11277295" cy="777240"/>
+            <a:off x="457200" y="137160"/>
+            <a:ext cx="8351215" cy="731520"/>
           </a:xfrm>
           <a:prstGeom prst="rect">
             <a:avLst/>
@@ -4627,8 +5635,8 @@
         </p:nvSpPr>
         <p:spPr>
           <a:xfrm>
-            <a:off x="640080" y="1371600"/>
-            <a:ext cx="10911535" cy="5029200"/>
+            <a:off x="8534095" y="137160"/>
+            <a:ext cx="3200400" cy="731520"/>
           </a:xfrm>
           <a:prstGeom prst="rect">
             <a:avLst/>
@@ -4636,18 +5644,267 @@
           <a:noFill/>
         </p:spPr>
         <p:txBody>
-          <a:bodyPr wrap="square">
+          <a:bodyPr wrap="square" anchor="ctr">
             <a:spAutoFit/>
           </a:bodyPr>
           <a:lstStyle/>
           <a:p>
+            <a:pPr algn="r">
+              <a:spcAft>
+                <a:spcPts val="600"/>
+              </a:spcAft>
+            </a:pPr>
+            <a:r>
+              <a:rPr sz="1200" b="1">
+                <a:solidFill>
+                  <a:srgbClr val="C9A227"/>
+                </a:solidFill>
+                <a:latin typeface="Calibri"/>
+              </a:rPr>
+              <a:t>Gold Price Prediction</a:t>
+            </a:r>
+          </a:p>
+        </p:txBody>
+      </p:sp>
+      <p:sp>
+        <p:nvSpPr>
+          <p:cNvPr id="6" name="Rectangle 5"/>
+          <p:cNvSpPr/>
+          <p:nvPr/>
+        </p:nvSpPr>
+        <p:spPr>
+          <a:xfrm>
+            <a:off x="0" y="6473952"/>
+            <a:ext cx="12191695" cy="384048"/>
+          </a:xfrm>
+          <a:prstGeom prst="rect">
+            <a:avLst/>
+          </a:prstGeom>
+          <a:solidFill>
+            <a:srgbClr val="1F3864"/>
+          </a:solidFill>
+          <a:ln>
+            <a:noFill/>
+          </a:ln>
+          <a:effectLst/>
+        </p:spPr>
+        <p:style>
+          <a:lnRef idx="1">
+            <a:schemeClr val="accent1"/>
+          </a:lnRef>
+          <a:fillRef idx="3">
+            <a:schemeClr val="accent1"/>
+          </a:fillRef>
+          <a:effectRef idx="2">
+            <a:schemeClr val="accent1"/>
+          </a:effectRef>
+          <a:fontRef idx="minor">
+            <a:schemeClr val="lt1"/>
+          </a:fontRef>
+        </p:style>
+        <p:txBody>
+          <a:bodyPr rtlCol="0" anchor="ctr"/>
+          <a:lstStyle/>
+          <a:p>
+            <a:pPr algn="ctr"/>
+          </a:p>
+        </p:txBody>
+      </p:sp>
+      <p:sp>
+        <p:nvSpPr>
+          <p:cNvPr id="7" name="Rectangle 6"/>
+          <p:cNvSpPr/>
+          <p:nvPr/>
+        </p:nvSpPr>
+        <p:spPr>
+          <a:xfrm>
+            <a:off x="0" y="6473952"/>
+            <a:ext cx="128016" cy="384048"/>
+          </a:xfrm>
+          <a:prstGeom prst="rect">
+            <a:avLst/>
+          </a:prstGeom>
+          <a:solidFill>
+            <a:srgbClr val="C9A227"/>
+          </a:solidFill>
+          <a:ln>
+            <a:noFill/>
+          </a:ln>
+          <a:effectLst/>
+        </p:spPr>
+        <p:style>
+          <a:lnRef idx="1">
+            <a:schemeClr val="accent1"/>
+          </a:lnRef>
+          <a:fillRef idx="3">
+            <a:schemeClr val="accent1"/>
+          </a:fillRef>
+          <a:effectRef idx="2">
+            <a:schemeClr val="accent1"/>
+          </a:effectRef>
+          <a:fontRef idx="minor">
+            <a:schemeClr val="lt1"/>
+          </a:fontRef>
+        </p:style>
+        <p:txBody>
+          <a:bodyPr rtlCol="0" anchor="ctr"/>
+          <a:lstStyle/>
+          <a:p>
+            <a:pPr algn="ctr"/>
+          </a:p>
+        </p:txBody>
+      </p:sp>
+      <p:sp>
+        <p:nvSpPr>
+          <p:cNvPr id="8" name="TextBox 7"/>
+          <p:cNvSpPr txBox="1"/>
+          <p:nvPr/>
+        </p:nvSpPr>
+        <p:spPr>
+          <a:xfrm>
+            <a:off x="274320" y="6473952"/>
+            <a:ext cx="10362895" cy="384048"/>
+          </a:xfrm>
+          <a:prstGeom prst="rect">
+            <a:avLst/>
+          </a:prstGeom>
+          <a:noFill/>
+        </p:spPr>
+        <p:txBody>
+          <a:bodyPr wrap="square" anchor="ctr">
+            <a:spAutoFit/>
+          </a:bodyPr>
+          <a:lstStyle/>
+          <a:p>
             <a:pPr algn="l">
               <a:spcAft>
-                <a:spcPts val="1400"/>
+                <a:spcPts val="600"/>
               </a:spcAft>
             </a:pPr>
             <a:r>
-              <a:rPr sz="1800" b="0">
+              <a:rPr sz="900" b="0">
+                <a:solidFill>
+                  <a:srgbClr val="FFFFFF"/>
+                </a:solidFill>
+                <a:latin typeface="Calibri"/>
+              </a:rPr>
+              <a:t>Sanchay Bhardwaj (2300650100104)  |  B.S.A. College of Engineering &amp; Technology, Mathura</a:t>
+            </a:r>
+          </a:p>
+        </p:txBody>
+      </p:sp>
+      <p:sp>
+        <p:nvSpPr>
+          <p:cNvPr id="9" name="TextBox 8"/>
+          <p:cNvSpPr txBox="1"/>
+          <p:nvPr/>
+        </p:nvSpPr>
+        <p:spPr>
+          <a:xfrm>
+            <a:off x="10728655" y="6473952"/>
+            <a:ext cx="1188720" cy="384048"/>
+          </a:xfrm>
+          <a:prstGeom prst="rect">
+            <a:avLst/>
+          </a:prstGeom>
+          <a:noFill/>
+        </p:spPr>
+        <p:txBody>
+          <a:bodyPr wrap="square" anchor="ctr">
+            <a:spAutoFit/>
+          </a:bodyPr>
+          <a:lstStyle/>
+          <a:p>
+            <a:pPr algn="r">
+              <a:spcAft>
+                <a:spcPts val="600"/>
+              </a:spcAft>
+            </a:pPr>
+            <a:r>
+              <a:rPr sz="900" b="1">
+                <a:solidFill>
+                  <a:srgbClr val="C9A227"/>
+                </a:solidFill>
+                <a:latin typeface="Calibri"/>
+              </a:rPr>
+              <a:t>Slide 3</a:t>
+            </a:r>
+          </a:p>
+        </p:txBody>
+      </p:sp>
+      <p:sp>
+        <p:nvSpPr>
+          <p:cNvPr id="10" name="Rectangle 9"/>
+          <p:cNvSpPr/>
+          <p:nvPr/>
+        </p:nvSpPr>
+        <p:spPr>
+          <a:xfrm>
+            <a:off x="502920" y="1554480"/>
+            <a:ext cx="82296" cy="4297680"/>
+          </a:xfrm>
+          <a:prstGeom prst="rect">
+            <a:avLst/>
+          </a:prstGeom>
+          <a:solidFill>
+            <a:srgbClr val="C9A227"/>
+          </a:solidFill>
+          <a:ln>
+            <a:noFill/>
+          </a:ln>
+          <a:effectLst/>
+        </p:spPr>
+        <p:style>
+          <a:lnRef idx="1">
+            <a:schemeClr val="accent1"/>
+          </a:lnRef>
+          <a:fillRef idx="3">
+            <a:schemeClr val="accent1"/>
+          </a:fillRef>
+          <a:effectRef idx="2">
+            <a:schemeClr val="accent1"/>
+          </a:effectRef>
+          <a:fontRef idx="minor">
+            <a:schemeClr val="lt1"/>
+          </a:fontRef>
+        </p:style>
+        <p:txBody>
+          <a:bodyPr rtlCol="0" anchor="ctr"/>
+          <a:lstStyle/>
+          <a:p>
+            <a:pPr algn="ctr"/>
+          </a:p>
+        </p:txBody>
+      </p:sp>
+      <p:sp>
+        <p:nvSpPr>
+          <p:cNvPr id="11" name="TextBox 10"/>
+          <p:cNvSpPr txBox="1"/>
+          <p:nvPr/>
+        </p:nvSpPr>
+        <p:spPr>
+          <a:xfrm>
+            <a:off x="868680" y="1371600"/>
+            <a:ext cx="10728655" cy="4663440"/>
+          </a:xfrm>
+          <a:prstGeom prst="rect">
+            <a:avLst/>
+          </a:prstGeom>
+          <a:noFill/>
+        </p:spPr>
+        <p:txBody>
+          <a:bodyPr wrap="square" anchor="ctr">
+            <a:spAutoFit/>
+          </a:bodyPr>
+          <a:lstStyle/>
+          <a:p>
+            <a:pPr algn="l">
+              <a:spcAft>
+                <a:spcPts val="2200"/>
+              </a:spcAft>
+            </a:pPr>
+            <a:r>
+              <a:rPr sz="2000" b="0">
                 <a:solidFill>
                   <a:srgbClr val="222222"/>
                 </a:solidFill>
@@ -4659,11 +5916,11 @@
           <a:p>
             <a:pPr algn="l">
               <a:spcAft>
-                <a:spcPts val="1400"/>
+                <a:spcPts val="2200"/>
               </a:spcAft>
             </a:pPr>
             <a:r>
-              <a:rPr sz="1800" b="0">
+              <a:rPr sz="2000" b="0">
                 <a:solidFill>
                   <a:srgbClr val="222222"/>
                 </a:solidFill>
@@ -4675,17 +5932,33 @@
           <a:p>
             <a:pPr algn="l">
               <a:spcAft>
-                <a:spcPts val="1400"/>
+                <a:spcPts val="2200"/>
               </a:spcAft>
             </a:pPr>
             <a:r>
-              <a:rPr sz="1800" b="0">
+              <a:rPr sz="2000" b="0">
                 <a:solidFill>
                   <a:srgbClr val="222222"/>
                 </a:solidFill>
                 <a:latin typeface="Calibri"/>
               </a:rPr>
               <a:t>•   Multiple models are trained and the most accurate one is kept for prediction.</a:t>
+            </a:r>
+          </a:p>
+          <a:p>
+            <a:pPr algn="l">
+              <a:spcAft>
+                <a:spcPts val="2200"/>
+              </a:spcAft>
+            </a:pPr>
+            <a:r>
+              <a:rPr sz="2000" b="0">
+                <a:solidFill>
+                  <a:srgbClr val="222222"/>
+                </a:solidFill>
+                <a:latin typeface="Calibri"/>
+              </a:rPr>
+              <a:t>•   The winning model is then wrapped in a simple desktop application.</a:t>
             </a:r>
           </a:p>
         </p:txBody>
@@ -4761,7 +6034,7 @@
         <p:spPr>
           <a:xfrm>
             <a:off x="0" y="960120"/>
-            <a:ext cx="12191695" cy="54864"/>
+            <a:ext cx="12191695" cy="64008"/>
           </a:xfrm>
           <a:prstGeom prst="rect">
             <a:avLst/>
@@ -4804,8 +6077,8 @@
         </p:nvSpPr>
         <p:spPr>
           <a:xfrm>
-            <a:off x="457200" y="109728"/>
-            <a:ext cx="11277295" cy="777240"/>
+            <a:off x="457200" y="137160"/>
+            <a:ext cx="8351215" cy="731520"/>
           </a:xfrm>
           <a:prstGeom prst="rect">
             <a:avLst/>
@@ -4843,8 +6116,8 @@
         </p:nvSpPr>
         <p:spPr>
           <a:xfrm>
-            <a:off x="640080" y="1371600"/>
-            <a:ext cx="10911535" cy="5029200"/>
+            <a:off x="8534095" y="137160"/>
+            <a:ext cx="3200400" cy="731520"/>
           </a:xfrm>
           <a:prstGeom prst="rect">
             <a:avLst/>
@@ -4852,18 +6125,267 @@
           <a:noFill/>
         </p:spPr>
         <p:txBody>
-          <a:bodyPr wrap="square">
+          <a:bodyPr wrap="square" anchor="ctr">
             <a:spAutoFit/>
           </a:bodyPr>
           <a:lstStyle/>
           <a:p>
+            <a:pPr algn="r">
+              <a:spcAft>
+                <a:spcPts val="600"/>
+              </a:spcAft>
+            </a:pPr>
+            <a:r>
+              <a:rPr sz="1200" b="1">
+                <a:solidFill>
+                  <a:srgbClr val="C9A227"/>
+                </a:solidFill>
+                <a:latin typeface="Calibri"/>
+              </a:rPr>
+              <a:t>Gold Price Prediction</a:t>
+            </a:r>
+          </a:p>
+        </p:txBody>
+      </p:sp>
+      <p:sp>
+        <p:nvSpPr>
+          <p:cNvPr id="6" name="Rectangle 5"/>
+          <p:cNvSpPr/>
+          <p:nvPr/>
+        </p:nvSpPr>
+        <p:spPr>
+          <a:xfrm>
+            <a:off x="0" y="6473952"/>
+            <a:ext cx="12191695" cy="384048"/>
+          </a:xfrm>
+          <a:prstGeom prst="rect">
+            <a:avLst/>
+          </a:prstGeom>
+          <a:solidFill>
+            <a:srgbClr val="1F3864"/>
+          </a:solidFill>
+          <a:ln>
+            <a:noFill/>
+          </a:ln>
+          <a:effectLst/>
+        </p:spPr>
+        <p:style>
+          <a:lnRef idx="1">
+            <a:schemeClr val="accent1"/>
+          </a:lnRef>
+          <a:fillRef idx="3">
+            <a:schemeClr val="accent1"/>
+          </a:fillRef>
+          <a:effectRef idx="2">
+            <a:schemeClr val="accent1"/>
+          </a:effectRef>
+          <a:fontRef idx="minor">
+            <a:schemeClr val="lt1"/>
+          </a:fontRef>
+        </p:style>
+        <p:txBody>
+          <a:bodyPr rtlCol="0" anchor="ctr"/>
+          <a:lstStyle/>
+          <a:p>
+            <a:pPr algn="ctr"/>
+          </a:p>
+        </p:txBody>
+      </p:sp>
+      <p:sp>
+        <p:nvSpPr>
+          <p:cNvPr id="7" name="Rectangle 6"/>
+          <p:cNvSpPr/>
+          <p:nvPr/>
+        </p:nvSpPr>
+        <p:spPr>
+          <a:xfrm>
+            <a:off x="0" y="6473952"/>
+            <a:ext cx="128016" cy="384048"/>
+          </a:xfrm>
+          <a:prstGeom prst="rect">
+            <a:avLst/>
+          </a:prstGeom>
+          <a:solidFill>
+            <a:srgbClr val="C9A227"/>
+          </a:solidFill>
+          <a:ln>
+            <a:noFill/>
+          </a:ln>
+          <a:effectLst/>
+        </p:spPr>
+        <p:style>
+          <a:lnRef idx="1">
+            <a:schemeClr val="accent1"/>
+          </a:lnRef>
+          <a:fillRef idx="3">
+            <a:schemeClr val="accent1"/>
+          </a:fillRef>
+          <a:effectRef idx="2">
+            <a:schemeClr val="accent1"/>
+          </a:effectRef>
+          <a:fontRef idx="minor">
+            <a:schemeClr val="lt1"/>
+          </a:fontRef>
+        </p:style>
+        <p:txBody>
+          <a:bodyPr rtlCol="0" anchor="ctr"/>
+          <a:lstStyle/>
+          <a:p>
+            <a:pPr algn="ctr"/>
+          </a:p>
+        </p:txBody>
+      </p:sp>
+      <p:sp>
+        <p:nvSpPr>
+          <p:cNvPr id="8" name="TextBox 7"/>
+          <p:cNvSpPr txBox="1"/>
+          <p:nvPr/>
+        </p:nvSpPr>
+        <p:spPr>
+          <a:xfrm>
+            <a:off x="274320" y="6473952"/>
+            <a:ext cx="10362895" cy="384048"/>
+          </a:xfrm>
+          <a:prstGeom prst="rect">
+            <a:avLst/>
+          </a:prstGeom>
+          <a:noFill/>
+        </p:spPr>
+        <p:txBody>
+          <a:bodyPr wrap="square" anchor="ctr">
+            <a:spAutoFit/>
+          </a:bodyPr>
+          <a:lstStyle/>
+          <a:p>
             <a:pPr algn="l">
               <a:spcAft>
-                <a:spcPts val="1400"/>
+                <a:spcPts val="600"/>
               </a:spcAft>
             </a:pPr>
             <a:r>
-              <a:rPr sz="1800" b="0">
+              <a:rPr sz="900" b="0">
+                <a:solidFill>
+                  <a:srgbClr val="FFFFFF"/>
+                </a:solidFill>
+                <a:latin typeface="Calibri"/>
+              </a:rPr>
+              <a:t>Sanchay Bhardwaj (2300650100104)  |  B.S.A. College of Engineering &amp; Technology, Mathura</a:t>
+            </a:r>
+          </a:p>
+        </p:txBody>
+      </p:sp>
+      <p:sp>
+        <p:nvSpPr>
+          <p:cNvPr id="9" name="TextBox 8"/>
+          <p:cNvSpPr txBox="1"/>
+          <p:nvPr/>
+        </p:nvSpPr>
+        <p:spPr>
+          <a:xfrm>
+            <a:off x="10728655" y="6473952"/>
+            <a:ext cx="1188720" cy="384048"/>
+          </a:xfrm>
+          <a:prstGeom prst="rect">
+            <a:avLst/>
+          </a:prstGeom>
+          <a:noFill/>
+        </p:spPr>
+        <p:txBody>
+          <a:bodyPr wrap="square" anchor="ctr">
+            <a:spAutoFit/>
+          </a:bodyPr>
+          <a:lstStyle/>
+          <a:p>
+            <a:pPr algn="r">
+              <a:spcAft>
+                <a:spcPts val="600"/>
+              </a:spcAft>
+            </a:pPr>
+            <a:r>
+              <a:rPr sz="900" b="1">
+                <a:solidFill>
+                  <a:srgbClr val="C9A227"/>
+                </a:solidFill>
+                <a:latin typeface="Calibri"/>
+              </a:rPr>
+              <a:t>Slide 4</a:t>
+            </a:r>
+          </a:p>
+        </p:txBody>
+      </p:sp>
+      <p:sp>
+        <p:nvSpPr>
+          <p:cNvPr id="10" name="Rectangle 9"/>
+          <p:cNvSpPr/>
+          <p:nvPr/>
+        </p:nvSpPr>
+        <p:spPr>
+          <a:xfrm>
+            <a:off x="502920" y="1554480"/>
+            <a:ext cx="82296" cy="4297680"/>
+          </a:xfrm>
+          <a:prstGeom prst="rect">
+            <a:avLst/>
+          </a:prstGeom>
+          <a:solidFill>
+            <a:srgbClr val="C9A227"/>
+          </a:solidFill>
+          <a:ln>
+            <a:noFill/>
+          </a:ln>
+          <a:effectLst/>
+        </p:spPr>
+        <p:style>
+          <a:lnRef idx="1">
+            <a:schemeClr val="accent1"/>
+          </a:lnRef>
+          <a:fillRef idx="3">
+            <a:schemeClr val="accent1"/>
+          </a:fillRef>
+          <a:effectRef idx="2">
+            <a:schemeClr val="accent1"/>
+          </a:effectRef>
+          <a:fontRef idx="minor">
+            <a:schemeClr val="lt1"/>
+          </a:fontRef>
+        </p:style>
+        <p:txBody>
+          <a:bodyPr rtlCol="0" anchor="ctr"/>
+          <a:lstStyle/>
+          <a:p>
+            <a:pPr algn="ctr"/>
+          </a:p>
+        </p:txBody>
+      </p:sp>
+      <p:sp>
+        <p:nvSpPr>
+          <p:cNvPr id="11" name="TextBox 10"/>
+          <p:cNvSpPr txBox="1"/>
+          <p:nvPr/>
+        </p:nvSpPr>
+        <p:spPr>
+          <a:xfrm>
+            <a:off x="868680" y="1371600"/>
+            <a:ext cx="10728655" cy="4663440"/>
+          </a:xfrm>
+          <a:prstGeom prst="rect">
+            <a:avLst/>
+          </a:prstGeom>
+          <a:noFill/>
+        </p:spPr>
+        <p:txBody>
+          <a:bodyPr wrap="square" anchor="ctr">
+            <a:spAutoFit/>
+          </a:bodyPr>
+          <a:lstStyle/>
+          <a:p>
+            <a:pPr algn="l">
+              <a:spcAft>
+                <a:spcPts val="2200"/>
+              </a:spcAft>
+            </a:pPr>
+            <a:r>
+              <a:rPr sz="2000" b="0">
                 <a:solidFill>
                   <a:srgbClr val="222222"/>
                 </a:solidFill>
@@ -4875,11 +6397,11 @@
           <a:p>
             <a:pPr algn="l">
               <a:spcAft>
-                <a:spcPts val="1400"/>
+                <a:spcPts val="2200"/>
               </a:spcAft>
             </a:pPr>
             <a:r>
-              <a:rPr sz="1800" b="0">
+              <a:rPr sz="2000" b="0">
                 <a:solidFill>
                   <a:srgbClr val="222222"/>
                 </a:solidFill>
@@ -4891,11 +6413,11 @@
           <a:p>
             <a:pPr algn="l">
               <a:spcAft>
-                <a:spcPts val="1400"/>
+                <a:spcPts val="2200"/>
               </a:spcAft>
             </a:pPr>
             <a:r>
-              <a:rPr sz="1800" b="0">
+              <a:rPr sz="2000" b="0">
                 <a:solidFill>
                   <a:srgbClr val="222222"/>
                 </a:solidFill>
@@ -4907,11 +6429,11 @@
           <a:p>
             <a:pPr algn="l">
               <a:spcAft>
-                <a:spcPts val="1400"/>
+                <a:spcPts val="2200"/>
               </a:spcAft>
             </a:pPr>
             <a:r>
-              <a:rPr sz="1800" b="0">
+              <a:rPr sz="2000" b="0">
                 <a:solidFill>
                   <a:srgbClr val="222222"/>
                 </a:solidFill>
@@ -4923,11 +6445,11 @@
           <a:p>
             <a:pPr algn="l">
               <a:spcAft>
-                <a:spcPts val="1400"/>
+                <a:spcPts val="2200"/>
               </a:spcAft>
             </a:pPr>
             <a:r>
-              <a:rPr sz="1800" b="0">
+              <a:rPr sz="2000" b="0">
                 <a:solidFill>
                   <a:srgbClr val="222222"/>
                 </a:solidFill>
@@ -5009,7 +6531,7 @@
         <p:spPr>
           <a:xfrm>
             <a:off x="0" y="960120"/>
-            <a:ext cx="12191695" cy="54864"/>
+            <a:ext cx="12191695" cy="64008"/>
           </a:xfrm>
           <a:prstGeom prst="rect">
             <a:avLst/>
@@ -5052,8 +6574,8 @@
         </p:nvSpPr>
         <p:spPr>
           <a:xfrm>
-            <a:off x="457200" y="109728"/>
-            <a:ext cx="11277295" cy="777240"/>
+            <a:off x="457200" y="137160"/>
+            <a:ext cx="8351215" cy="731520"/>
           </a:xfrm>
           <a:prstGeom prst="rect">
             <a:avLst/>
@@ -5091,8 +6613,8 @@
         </p:nvSpPr>
         <p:spPr>
           <a:xfrm>
-            <a:off x="640080" y="1371600"/>
-            <a:ext cx="10911535" cy="5029200"/>
+            <a:off x="8534095" y="137160"/>
+            <a:ext cx="3200400" cy="731520"/>
           </a:xfrm>
           <a:prstGeom prst="rect">
             <a:avLst/>
@@ -5100,18 +6622,267 @@
           <a:noFill/>
         </p:spPr>
         <p:txBody>
-          <a:bodyPr wrap="square">
+          <a:bodyPr wrap="square" anchor="ctr">
             <a:spAutoFit/>
           </a:bodyPr>
           <a:lstStyle/>
           <a:p>
+            <a:pPr algn="r">
+              <a:spcAft>
+                <a:spcPts val="600"/>
+              </a:spcAft>
+            </a:pPr>
+            <a:r>
+              <a:rPr sz="1200" b="1">
+                <a:solidFill>
+                  <a:srgbClr val="C9A227"/>
+                </a:solidFill>
+                <a:latin typeface="Calibri"/>
+              </a:rPr>
+              <a:t>Gold Price Prediction</a:t>
+            </a:r>
+          </a:p>
+        </p:txBody>
+      </p:sp>
+      <p:sp>
+        <p:nvSpPr>
+          <p:cNvPr id="6" name="Rectangle 5"/>
+          <p:cNvSpPr/>
+          <p:nvPr/>
+        </p:nvSpPr>
+        <p:spPr>
+          <a:xfrm>
+            <a:off x="0" y="6473952"/>
+            <a:ext cx="12191695" cy="384048"/>
+          </a:xfrm>
+          <a:prstGeom prst="rect">
+            <a:avLst/>
+          </a:prstGeom>
+          <a:solidFill>
+            <a:srgbClr val="1F3864"/>
+          </a:solidFill>
+          <a:ln>
+            <a:noFill/>
+          </a:ln>
+          <a:effectLst/>
+        </p:spPr>
+        <p:style>
+          <a:lnRef idx="1">
+            <a:schemeClr val="accent1"/>
+          </a:lnRef>
+          <a:fillRef idx="3">
+            <a:schemeClr val="accent1"/>
+          </a:fillRef>
+          <a:effectRef idx="2">
+            <a:schemeClr val="accent1"/>
+          </a:effectRef>
+          <a:fontRef idx="minor">
+            <a:schemeClr val="lt1"/>
+          </a:fontRef>
+        </p:style>
+        <p:txBody>
+          <a:bodyPr rtlCol="0" anchor="ctr"/>
+          <a:lstStyle/>
+          <a:p>
+            <a:pPr algn="ctr"/>
+          </a:p>
+        </p:txBody>
+      </p:sp>
+      <p:sp>
+        <p:nvSpPr>
+          <p:cNvPr id="7" name="Rectangle 6"/>
+          <p:cNvSpPr/>
+          <p:nvPr/>
+        </p:nvSpPr>
+        <p:spPr>
+          <a:xfrm>
+            <a:off x="0" y="6473952"/>
+            <a:ext cx="128016" cy="384048"/>
+          </a:xfrm>
+          <a:prstGeom prst="rect">
+            <a:avLst/>
+          </a:prstGeom>
+          <a:solidFill>
+            <a:srgbClr val="C9A227"/>
+          </a:solidFill>
+          <a:ln>
+            <a:noFill/>
+          </a:ln>
+          <a:effectLst/>
+        </p:spPr>
+        <p:style>
+          <a:lnRef idx="1">
+            <a:schemeClr val="accent1"/>
+          </a:lnRef>
+          <a:fillRef idx="3">
+            <a:schemeClr val="accent1"/>
+          </a:fillRef>
+          <a:effectRef idx="2">
+            <a:schemeClr val="accent1"/>
+          </a:effectRef>
+          <a:fontRef idx="minor">
+            <a:schemeClr val="lt1"/>
+          </a:fontRef>
+        </p:style>
+        <p:txBody>
+          <a:bodyPr rtlCol="0" anchor="ctr"/>
+          <a:lstStyle/>
+          <a:p>
+            <a:pPr algn="ctr"/>
+          </a:p>
+        </p:txBody>
+      </p:sp>
+      <p:sp>
+        <p:nvSpPr>
+          <p:cNvPr id="8" name="TextBox 7"/>
+          <p:cNvSpPr txBox="1"/>
+          <p:nvPr/>
+        </p:nvSpPr>
+        <p:spPr>
+          <a:xfrm>
+            <a:off x="274320" y="6473952"/>
+            <a:ext cx="10362895" cy="384048"/>
+          </a:xfrm>
+          <a:prstGeom prst="rect">
+            <a:avLst/>
+          </a:prstGeom>
+          <a:noFill/>
+        </p:spPr>
+        <p:txBody>
+          <a:bodyPr wrap="square" anchor="ctr">
+            <a:spAutoFit/>
+          </a:bodyPr>
+          <a:lstStyle/>
+          <a:p>
             <a:pPr algn="l">
               <a:spcAft>
-                <a:spcPts val="1400"/>
+                <a:spcPts val="600"/>
               </a:spcAft>
             </a:pPr>
             <a:r>
-              <a:rPr sz="1800" b="0">
+              <a:rPr sz="900" b="0">
+                <a:solidFill>
+                  <a:srgbClr val="FFFFFF"/>
+                </a:solidFill>
+                <a:latin typeface="Calibri"/>
+              </a:rPr>
+              <a:t>Sanchay Bhardwaj (2300650100104)  |  B.S.A. College of Engineering &amp; Technology, Mathura</a:t>
+            </a:r>
+          </a:p>
+        </p:txBody>
+      </p:sp>
+      <p:sp>
+        <p:nvSpPr>
+          <p:cNvPr id="9" name="TextBox 8"/>
+          <p:cNvSpPr txBox="1"/>
+          <p:nvPr/>
+        </p:nvSpPr>
+        <p:spPr>
+          <a:xfrm>
+            <a:off x="10728655" y="6473952"/>
+            <a:ext cx="1188720" cy="384048"/>
+          </a:xfrm>
+          <a:prstGeom prst="rect">
+            <a:avLst/>
+          </a:prstGeom>
+          <a:noFill/>
+        </p:spPr>
+        <p:txBody>
+          <a:bodyPr wrap="square" anchor="ctr">
+            <a:spAutoFit/>
+          </a:bodyPr>
+          <a:lstStyle/>
+          <a:p>
+            <a:pPr algn="r">
+              <a:spcAft>
+                <a:spcPts val="600"/>
+              </a:spcAft>
+            </a:pPr>
+            <a:r>
+              <a:rPr sz="900" b="1">
+                <a:solidFill>
+                  <a:srgbClr val="C9A227"/>
+                </a:solidFill>
+                <a:latin typeface="Calibri"/>
+              </a:rPr>
+              <a:t>Slide 5</a:t>
+            </a:r>
+          </a:p>
+        </p:txBody>
+      </p:sp>
+      <p:sp>
+        <p:nvSpPr>
+          <p:cNvPr id="10" name="Rectangle 9"/>
+          <p:cNvSpPr/>
+          <p:nvPr/>
+        </p:nvSpPr>
+        <p:spPr>
+          <a:xfrm>
+            <a:off x="502920" y="1554480"/>
+            <a:ext cx="82296" cy="4297680"/>
+          </a:xfrm>
+          <a:prstGeom prst="rect">
+            <a:avLst/>
+          </a:prstGeom>
+          <a:solidFill>
+            <a:srgbClr val="C9A227"/>
+          </a:solidFill>
+          <a:ln>
+            <a:noFill/>
+          </a:ln>
+          <a:effectLst/>
+        </p:spPr>
+        <p:style>
+          <a:lnRef idx="1">
+            <a:schemeClr val="accent1"/>
+          </a:lnRef>
+          <a:fillRef idx="3">
+            <a:schemeClr val="accent1"/>
+          </a:fillRef>
+          <a:effectRef idx="2">
+            <a:schemeClr val="accent1"/>
+          </a:effectRef>
+          <a:fontRef idx="minor">
+            <a:schemeClr val="lt1"/>
+          </a:fontRef>
+        </p:style>
+        <p:txBody>
+          <a:bodyPr rtlCol="0" anchor="ctr"/>
+          <a:lstStyle/>
+          <a:p>
+            <a:pPr algn="ctr"/>
+          </a:p>
+        </p:txBody>
+      </p:sp>
+      <p:sp>
+        <p:nvSpPr>
+          <p:cNvPr id="11" name="TextBox 10"/>
+          <p:cNvSpPr txBox="1"/>
+          <p:nvPr/>
+        </p:nvSpPr>
+        <p:spPr>
+          <a:xfrm>
+            <a:off x="868680" y="1371600"/>
+            <a:ext cx="10728655" cy="4663440"/>
+          </a:xfrm>
+          <a:prstGeom prst="rect">
+            <a:avLst/>
+          </a:prstGeom>
+          <a:noFill/>
+        </p:spPr>
+        <p:txBody>
+          <a:bodyPr wrap="square" anchor="ctr">
+            <a:spAutoFit/>
+          </a:bodyPr>
+          <a:lstStyle/>
+          <a:p>
+            <a:pPr algn="l">
+              <a:spcAft>
+                <a:spcPts val="2200"/>
+              </a:spcAft>
+            </a:pPr>
+            <a:r>
+              <a:rPr sz="2000" b="0">
                 <a:solidFill>
                   <a:srgbClr val="222222"/>
                 </a:solidFill>
@@ -5123,11 +6894,11 @@
           <a:p>
             <a:pPr algn="l">
               <a:spcAft>
-                <a:spcPts val="1400"/>
+                <a:spcPts val="2200"/>
               </a:spcAft>
             </a:pPr>
             <a:r>
-              <a:rPr sz="1800" b="0">
+              <a:rPr sz="2000" b="0">
                 <a:solidFill>
                   <a:srgbClr val="222222"/>
                 </a:solidFill>
@@ -5139,11 +6910,11 @@
           <a:p>
             <a:pPr algn="l">
               <a:spcAft>
-                <a:spcPts val="1400"/>
+                <a:spcPts val="2200"/>
               </a:spcAft>
             </a:pPr>
             <a:r>
-              <a:rPr sz="1800" b="0">
+              <a:rPr sz="2000" b="0">
                 <a:solidFill>
                   <a:srgbClr val="222222"/>
                 </a:solidFill>
@@ -5155,11 +6926,11 @@
           <a:p>
             <a:pPr algn="l">
               <a:spcAft>
-                <a:spcPts val="1400"/>
+                <a:spcPts val="2200"/>
               </a:spcAft>
             </a:pPr>
             <a:r>
-              <a:rPr sz="1800" b="0">
+              <a:rPr sz="2000" b="0">
                 <a:solidFill>
                   <a:srgbClr val="222222"/>
                 </a:solidFill>
@@ -5241,7 +7012,7 @@
         <p:spPr>
           <a:xfrm>
             <a:off x="0" y="960120"/>
-            <a:ext cx="12191695" cy="54864"/>
+            <a:ext cx="12191695" cy="64008"/>
           </a:xfrm>
           <a:prstGeom prst="rect">
             <a:avLst/>
@@ -5284,8 +7055,8 @@
         </p:nvSpPr>
         <p:spPr>
           <a:xfrm>
-            <a:off x="457200" y="109728"/>
-            <a:ext cx="11277295" cy="777240"/>
+            <a:off x="457200" y="137160"/>
+            <a:ext cx="8351215" cy="731520"/>
           </a:xfrm>
           <a:prstGeom prst="rect">
             <a:avLst/>
@@ -5323,8 +7094,8 @@
         </p:nvSpPr>
         <p:spPr>
           <a:xfrm>
-            <a:off x="640080" y="1371600"/>
-            <a:ext cx="10911535" cy="5029200"/>
+            <a:off x="8534095" y="137160"/>
+            <a:ext cx="3200400" cy="731520"/>
           </a:xfrm>
           <a:prstGeom prst="rect">
             <a:avLst/>
@@ -5332,18 +7103,267 @@
           <a:noFill/>
         </p:spPr>
         <p:txBody>
-          <a:bodyPr wrap="square">
+          <a:bodyPr wrap="square" anchor="ctr">
             <a:spAutoFit/>
           </a:bodyPr>
           <a:lstStyle/>
           <a:p>
+            <a:pPr algn="r">
+              <a:spcAft>
+                <a:spcPts val="600"/>
+              </a:spcAft>
+            </a:pPr>
+            <a:r>
+              <a:rPr sz="1200" b="1">
+                <a:solidFill>
+                  <a:srgbClr val="C9A227"/>
+                </a:solidFill>
+                <a:latin typeface="Calibri"/>
+              </a:rPr>
+              <a:t>Gold Price Prediction</a:t>
+            </a:r>
+          </a:p>
+        </p:txBody>
+      </p:sp>
+      <p:sp>
+        <p:nvSpPr>
+          <p:cNvPr id="6" name="Rectangle 5"/>
+          <p:cNvSpPr/>
+          <p:nvPr/>
+        </p:nvSpPr>
+        <p:spPr>
+          <a:xfrm>
+            <a:off x="0" y="6473952"/>
+            <a:ext cx="12191695" cy="384048"/>
+          </a:xfrm>
+          <a:prstGeom prst="rect">
+            <a:avLst/>
+          </a:prstGeom>
+          <a:solidFill>
+            <a:srgbClr val="1F3864"/>
+          </a:solidFill>
+          <a:ln>
+            <a:noFill/>
+          </a:ln>
+          <a:effectLst/>
+        </p:spPr>
+        <p:style>
+          <a:lnRef idx="1">
+            <a:schemeClr val="accent1"/>
+          </a:lnRef>
+          <a:fillRef idx="3">
+            <a:schemeClr val="accent1"/>
+          </a:fillRef>
+          <a:effectRef idx="2">
+            <a:schemeClr val="accent1"/>
+          </a:effectRef>
+          <a:fontRef idx="minor">
+            <a:schemeClr val="lt1"/>
+          </a:fontRef>
+        </p:style>
+        <p:txBody>
+          <a:bodyPr rtlCol="0" anchor="ctr"/>
+          <a:lstStyle/>
+          <a:p>
+            <a:pPr algn="ctr"/>
+          </a:p>
+        </p:txBody>
+      </p:sp>
+      <p:sp>
+        <p:nvSpPr>
+          <p:cNvPr id="7" name="Rectangle 6"/>
+          <p:cNvSpPr/>
+          <p:nvPr/>
+        </p:nvSpPr>
+        <p:spPr>
+          <a:xfrm>
+            <a:off x="0" y="6473952"/>
+            <a:ext cx="128016" cy="384048"/>
+          </a:xfrm>
+          <a:prstGeom prst="rect">
+            <a:avLst/>
+          </a:prstGeom>
+          <a:solidFill>
+            <a:srgbClr val="C9A227"/>
+          </a:solidFill>
+          <a:ln>
+            <a:noFill/>
+          </a:ln>
+          <a:effectLst/>
+        </p:spPr>
+        <p:style>
+          <a:lnRef idx="1">
+            <a:schemeClr val="accent1"/>
+          </a:lnRef>
+          <a:fillRef idx="3">
+            <a:schemeClr val="accent1"/>
+          </a:fillRef>
+          <a:effectRef idx="2">
+            <a:schemeClr val="accent1"/>
+          </a:effectRef>
+          <a:fontRef idx="minor">
+            <a:schemeClr val="lt1"/>
+          </a:fontRef>
+        </p:style>
+        <p:txBody>
+          <a:bodyPr rtlCol="0" anchor="ctr"/>
+          <a:lstStyle/>
+          <a:p>
+            <a:pPr algn="ctr"/>
+          </a:p>
+        </p:txBody>
+      </p:sp>
+      <p:sp>
+        <p:nvSpPr>
+          <p:cNvPr id="8" name="TextBox 7"/>
+          <p:cNvSpPr txBox="1"/>
+          <p:nvPr/>
+        </p:nvSpPr>
+        <p:spPr>
+          <a:xfrm>
+            <a:off x="274320" y="6473952"/>
+            <a:ext cx="10362895" cy="384048"/>
+          </a:xfrm>
+          <a:prstGeom prst="rect">
+            <a:avLst/>
+          </a:prstGeom>
+          <a:noFill/>
+        </p:spPr>
+        <p:txBody>
+          <a:bodyPr wrap="square" anchor="ctr">
+            <a:spAutoFit/>
+          </a:bodyPr>
+          <a:lstStyle/>
+          <a:p>
             <a:pPr algn="l">
               <a:spcAft>
-                <a:spcPts val="1400"/>
+                <a:spcPts val="600"/>
               </a:spcAft>
             </a:pPr>
             <a:r>
-              <a:rPr sz="1800" b="0">
+              <a:rPr sz="900" b="0">
+                <a:solidFill>
+                  <a:srgbClr val="FFFFFF"/>
+                </a:solidFill>
+                <a:latin typeface="Calibri"/>
+              </a:rPr>
+              <a:t>Sanchay Bhardwaj (2300650100104)  |  B.S.A. College of Engineering &amp; Technology, Mathura</a:t>
+            </a:r>
+          </a:p>
+        </p:txBody>
+      </p:sp>
+      <p:sp>
+        <p:nvSpPr>
+          <p:cNvPr id="9" name="TextBox 8"/>
+          <p:cNvSpPr txBox="1"/>
+          <p:nvPr/>
+        </p:nvSpPr>
+        <p:spPr>
+          <a:xfrm>
+            <a:off x="10728655" y="6473952"/>
+            <a:ext cx="1188720" cy="384048"/>
+          </a:xfrm>
+          <a:prstGeom prst="rect">
+            <a:avLst/>
+          </a:prstGeom>
+          <a:noFill/>
+        </p:spPr>
+        <p:txBody>
+          <a:bodyPr wrap="square" anchor="ctr">
+            <a:spAutoFit/>
+          </a:bodyPr>
+          <a:lstStyle/>
+          <a:p>
+            <a:pPr algn="r">
+              <a:spcAft>
+                <a:spcPts val="600"/>
+              </a:spcAft>
+            </a:pPr>
+            <a:r>
+              <a:rPr sz="900" b="1">
+                <a:solidFill>
+                  <a:srgbClr val="C9A227"/>
+                </a:solidFill>
+                <a:latin typeface="Calibri"/>
+              </a:rPr>
+              <a:t>Slide 6</a:t>
+            </a:r>
+          </a:p>
+        </p:txBody>
+      </p:sp>
+      <p:sp>
+        <p:nvSpPr>
+          <p:cNvPr id="10" name="Rectangle 9"/>
+          <p:cNvSpPr/>
+          <p:nvPr/>
+        </p:nvSpPr>
+        <p:spPr>
+          <a:xfrm>
+            <a:off x="502920" y="1554480"/>
+            <a:ext cx="82296" cy="4297680"/>
+          </a:xfrm>
+          <a:prstGeom prst="rect">
+            <a:avLst/>
+          </a:prstGeom>
+          <a:solidFill>
+            <a:srgbClr val="C9A227"/>
+          </a:solidFill>
+          <a:ln>
+            <a:noFill/>
+          </a:ln>
+          <a:effectLst/>
+        </p:spPr>
+        <p:style>
+          <a:lnRef idx="1">
+            <a:schemeClr val="accent1"/>
+          </a:lnRef>
+          <a:fillRef idx="3">
+            <a:schemeClr val="accent1"/>
+          </a:fillRef>
+          <a:effectRef idx="2">
+            <a:schemeClr val="accent1"/>
+          </a:effectRef>
+          <a:fontRef idx="minor">
+            <a:schemeClr val="lt1"/>
+          </a:fontRef>
+        </p:style>
+        <p:txBody>
+          <a:bodyPr rtlCol="0" anchor="ctr"/>
+          <a:lstStyle/>
+          <a:p>
+            <a:pPr algn="ctr"/>
+          </a:p>
+        </p:txBody>
+      </p:sp>
+      <p:sp>
+        <p:nvSpPr>
+          <p:cNvPr id="11" name="TextBox 10"/>
+          <p:cNvSpPr txBox="1"/>
+          <p:nvPr/>
+        </p:nvSpPr>
+        <p:spPr>
+          <a:xfrm>
+            <a:off x="868680" y="1371600"/>
+            <a:ext cx="10728655" cy="4663440"/>
+          </a:xfrm>
+          <a:prstGeom prst="rect">
+            <a:avLst/>
+          </a:prstGeom>
+          <a:noFill/>
+        </p:spPr>
+        <p:txBody>
+          <a:bodyPr wrap="square" anchor="ctr">
+            <a:spAutoFit/>
+          </a:bodyPr>
+          <a:lstStyle/>
+          <a:p>
+            <a:pPr algn="l">
+              <a:spcAft>
+                <a:spcPts val="2200"/>
+              </a:spcAft>
+            </a:pPr>
+            <a:r>
+              <a:rPr sz="2000" b="0">
                 <a:solidFill>
                   <a:srgbClr val="222222"/>
                 </a:solidFill>
@@ -5355,11 +7375,11 @@
           <a:p>
             <a:pPr algn="l">
               <a:spcAft>
-                <a:spcPts val="1400"/>
+                <a:spcPts val="2200"/>
               </a:spcAft>
             </a:pPr>
             <a:r>
-              <a:rPr sz="1800" b="0">
+              <a:rPr sz="2000" b="0">
                 <a:solidFill>
                   <a:srgbClr val="222222"/>
                 </a:solidFill>
@@ -5371,27 +7391,27 @@
           <a:p>
             <a:pPr algn="l">
               <a:spcAft>
-                <a:spcPts val="1400"/>
+                <a:spcPts val="2200"/>
               </a:spcAft>
             </a:pPr>
             <a:r>
-              <a:rPr sz="1800" b="0">
+              <a:rPr sz="2000" b="0">
                 <a:solidFill>
                   <a:srgbClr val="222222"/>
                 </a:solidFill>
                 <a:latin typeface="Calibri"/>
               </a:rPr>
-              <a:t>•   Price is rebuilt as:  next price = last price x (1 + predicted return).</a:t>
+              <a:t>•   Price is rebuilt as   next price = last price x (1 + predicted return).</a:t>
             </a:r>
           </a:p>
           <a:p>
             <a:pPr algn="l">
               <a:spcAft>
-                <a:spcPts val="1400"/>
+                <a:spcPts val="2200"/>
               </a:spcAft>
             </a:pPr>
             <a:r>
-              <a:rPr sz="1800" b="0">
+              <a:rPr sz="2000" b="0">
                 <a:solidFill>
                   <a:srgbClr val="222222"/>
                 </a:solidFill>
@@ -5403,11 +7423,11 @@
           <a:p>
             <a:pPr algn="l">
               <a:spcAft>
-                <a:spcPts val="1400"/>
+                <a:spcPts val="2200"/>
               </a:spcAft>
             </a:pPr>
             <a:r>
-              <a:rPr sz="1800" b="0">
+              <a:rPr sz="2000" b="0">
                 <a:solidFill>
                   <a:srgbClr val="222222"/>
                 </a:solidFill>
@@ -5489,7 +7509,7 @@
         <p:spPr>
           <a:xfrm>
             <a:off x="0" y="960120"/>
-            <a:ext cx="12191695" cy="54864"/>
+            <a:ext cx="12191695" cy="64008"/>
           </a:xfrm>
           <a:prstGeom prst="rect">
             <a:avLst/>
@@ -5532,8 +7552,8 @@
         </p:nvSpPr>
         <p:spPr>
           <a:xfrm>
-            <a:off x="457200" y="109728"/>
-            <a:ext cx="11277295" cy="777240"/>
+            <a:off x="457200" y="137160"/>
+            <a:ext cx="8351215" cy="731520"/>
           </a:xfrm>
           <a:prstGeom prst="rect">
             <a:avLst/>
@@ -5571,8 +7591,8 @@
         </p:nvSpPr>
         <p:spPr>
           <a:xfrm>
-            <a:off x="640080" y="1371600"/>
-            <a:ext cx="10911535" cy="5029200"/>
+            <a:off x="8534095" y="137160"/>
+            <a:ext cx="3200400" cy="731520"/>
           </a:xfrm>
           <a:prstGeom prst="rect">
             <a:avLst/>
@@ -5580,18 +7600,267 @@
           <a:noFill/>
         </p:spPr>
         <p:txBody>
-          <a:bodyPr wrap="square">
+          <a:bodyPr wrap="square" anchor="ctr">
             <a:spAutoFit/>
           </a:bodyPr>
           <a:lstStyle/>
           <a:p>
+            <a:pPr algn="r">
+              <a:spcAft>
+                <a:spcPts val="600"/>
+              </a:spcAft>
+            </a:pPr>
+            <a:r>
+              <a:rPr sz="1200" b="1">
+                <a:solidFill>
+                  <a:srgbClr val="C9A227"/>
+                </a:solidFill>
+                <a:latin typeface="Calibri"/>
+              </a:rPr>
+              <a:t>Gold Price Prediction</a:t>
+            </a:r>
+          </a:p>
+        </p:txBody>
+      </p:sp>
+      <p:sp>
+        <p:nvSpPr>
+          <p:cNvPr id="6" name="Rectangle 5"/>
+          <p:cNvSpPr/>
+          <p:nvPr/>
+        </p:nvSpPr>
+        <p:spPr>
+          <a:xfrm>
+            <a:off x="0" y="6473952"/>
+            <a:ext cx="12191695" cy="384048"/>
+          </a:xfrm>
+          <a:prstGeom prst="rect">
+            <a:avLst/>
+          </a:prstGeom>
+          <a:solidFill>
+            <a:srgbClr val="1F3864"/>
+          </a:solidFill>
+          <a:ln>
+            <a:noFill/>
+          </a:ln>
+          <a:effectLst/>
+        </p:spPr>
+        <p:style>
+          <a:lnRef idx="1">
+            <a:schemeClr val="accent1"/>
+          </a:lnRef>
+          <a:fillRef idx="3">
+            <a:schemeClr val="accent1"/>
+          </a:fillRef>
+          <a:effectRef idx="2">
+            <a:schemeClr val="accent1"/>
+          </a:effectRef>
+          <a:fontRef idx="minor">
+            <a:schemeClr val="lt1"/>
+          </a:fontRef>
+        </p:style>
+        <p:txBody>
+          <a:bodyPr rtlCol="0" anchor="ctr"/>
+          <a:lstStyle/>
+          <a:p>
+            <a:pPr algn="ctr"/>
+          </a:p>
+        </p:txBody>
+      </p:sp>
+      <p:sp>
+        <p:nvSpPr>
+          <p:cNvPr id="7" name="Rectangle 6"/>
+          <p:cNvSpPr/>
+          <p:nvPr/>
+        </p:nvSpPr>
+        <p:spPr>
+          <a:xfrm>
+            <a:off x="0" y="6473952"/>
+            <a:ext cx="128016" cy="384048"/>
+          </a:xfrm>
+          <a:prstGeom prst="rect">
+            <a:avLst/>
+          </a:prstGeom>
+          <a:solidFill>
+            <a:srgbClr val="C9A227"/>
+          </a:solidFill>
+          <a:ln>
+            <a:noFill/>
+          </a:ln>
+          <a:effectLst/>
+        </p:spPr>
+        <p:style>
+          <a:lnRef idx="1">
+            <a:schemeClr val="accent1"/>
+          </a:lnRef>
+          <a:fillRef idx="3">
+            <a:schemeClr val="accent1"/>
+          </a:fillRef>
+          <a:effectRef idx="2">
+            <a:schemeClr val="accent1"/>
+          </a:effectRef>
+          <a:fontRef idx="minor">
+            <a:schemeClr val="lt1"/>
+          </a:fontRef>
+        </p:style>
+        <p:txBody>
+          <a:bodyPr rtlCol="0" anchor="ctr"/>
+          <a:lstStyle/>
+          <a:p>
+            <a:pPr algn="ctr"/>
+          </a:p>
+        </p:txBody>
+      </p:sp>
+      <p:sp>
+        <p:nvSpPr>
+          <p:cNvPr id="8" name="TextBox 7"/>
+          <p:cNvSpPr txBox="1"/>
+          <p:nvPr/>
+        </p:nvSpPr>
+        <p:spPr>
+          <a:xfrm>
+            <a:off x="274320" y="6473952"/>
+            <a:ext cx="10362895" cy="384048"/>
+          </a:xfrm>
+          <a:prstGeom prst="rect">
+            <a:avLst/>
+          </a:prstGeom>
+          <a:noFill/>
+        </p:spPr>
+        <p:txBody>
+          <a:bodyPr wrap="square" anchor="ctr">
+            <a:spAutoFit/>
+          </a:bodyPr>
+          <a:lstStyle/>
+          <a:p>
             <a:pPr algn="l">
               <a:spcAft>
-                <a:spcPts val="1400"/>
+                <a:spcPts val="600"/>
               </a:spcAft>
             </a:pPr>
             <a:r>
-              <a:rPr sz="1800" b="0">
+              <a:rPr sz="900" b="0">
+                <a:solidFill>
+                  <a:srgbClr val="FFFFFF"/>
+                </a:solidFill>
+                <a:latin typeface="Calibri"/>
+              </a:rPr>
+              <a:t>Sanchay Bhardwaj (2300650100104)  |  B.S.A. College of Engineering &amp; Technology, Mathura</a:t>
+            </a:r>
+          </a:p>
+        </p:txBody>
+      </p:sp>
+      <p:sp>
+        <p:nvSpPr>
+          <p:cNvPr id="9" name="TextBox 8"/>
+          <p:cNvSpPr txBox="1"/>
+          <p:nvPr/>
+        </p:nvSpPr>
+        <p:spPr>
+          <a:xfrm>
+            <a:off x="10728655" y="6473952"/>
+            <a:ext cx="1188720" cy="384048"/>
+          </a:xfrm>
+          <a:prstGeom prst="rect">
+            <a:avLst/>
+          </a:prstGeom>
+          <a:noFill/>
+        </p:spPr>
+        <p:txBody>
+          <a:bodyPr wrap="square" anchor="ctr">
+            <a:spAutoFit/>
+          </a:bodyPr>
+          <a:lstStyle/>
+          <a:p>
+            <a:pPr algn="r">
+              <a:spcAft>
+                <a:spcPts val="600"/>
+              </a:spcAft>
+            </a:pPr>
+            <a:r>
+              <a:rPr sz="900" b="1">
+                <a:solidFill>
+                  <a:srgbClr val="C9A227"/>
+                </a:solidFill>
+                <a:latin typeface="Calibri"/>
+              </a:rPr>
+              <a:t>Slide 7</a:t>
+            </a:r>
+          </a:p>
+        </p:txBody>
+      </p:sp>
+      <p:sp>
+        <p:nvSpPr>
+          <p:cNvPr id="10" name="Rectangle 9"/>
+          <p:cNvSpPr/>
+          <p:nvPr/>
+        </p:nvSpPr>
+        <p:spPr>
+          <a:xfrm>
+            <a:off x="502920" y="1554480"/>
+            <a:ext cx="82296" cy="4297680"/>
+          </a:xfrm>
+          <a:prstGeom prst="rect">
+            <a:avLst/>
+          </a:prstGeom>
+          <a:solidFill>
+            <a:srgbClr val="C9A227"/>
+          </a:solidFill>
+          <a:ln>
+            <a:noFill/>
+          </a:ln>
+          <a:effectLst/>
+        </p:spPr>
+        <p:style>
+          <a:lnRef idx="1">
+            <a:schemeClr val="accent1"/>
+          </a:lnRef>
+          <a:fillRef idx="3">
+            <a:schemeClr val="accent1"/>
+          </a:fillRef>
+          <a:effectRef idx="2">
+            <a:schemeClr val="accent1"/>
+          </a:effectRef>
+          <a:fontRef idx="minor">
+            <a:schemeClr val="lt1"/>
+          </a:fontRef>
+        </p:style>
+        <p:txBody>
+          <a:bodyPr rtlCol="0" anchor="ctr"/>
+          <a:lstStyle/>
+          <a:p>
+            <a:pPr algn="ctr"/>
+          </a:p>
+        </p:txBody>
+      </p:sp>
+      <p:sp>
+        <p:nvSpPr>
+          <p:cNvPr id="11" name="TextBox 10"/>
+          <p:cNvSpPr txBox="1"/>
+          <p:nvPr/>
+        </p:nvSpPr>
+        <p:spPr>
+          <a:xfrm>
+            <a:off x="868680" y="1371600"/>
+            <a:ext cx="10728655" cy="4663440"/>
+          </a:xfrm>
+          <a:prstGeom prst="rect">
+            <a:avLst/>
+          </a:prstGeom>
+          <a:noFill/>
+        </p:spPr>
+        <p:txBody>
+          <a:bodyPr wrap="square" anchor="ctr">
+            <a:spAutoFit/>
+          </a:bodyPr>
+          <a:lstStyle/>
+          <a:p>
+            <a:pPr algn="l">
+              <a:spcAft>
+                <a:spcPts val="2200"/>
+              </a:spcAft>
+            </a:pPr>
+            <a:r>
+              <a:rPr sz="2000" b="0">
                 <a:solidFill>
                   <a:srgbClr val="222222"/>
                 </a:solidFill>
@@ -5603,11 +7872,11 @@
           <a:p>
             <a:pPr algn="l">
               <a:spcAft>
-                <a:spcPts val="1400"/>
+                <a:spcPts val="2200"/>
               </a:spcAft>
             </a:pPr>
             <a:r>
-              <a:rPr sz="1800" b="0">
+              <a:rPr sz="2000" b="0">
                 <a:solidFill>
                   <a:srgbClr val="222222"/>
                 </a:solidFill>
@@ -5619,11 +7888,11 @@
           <a:p>
             <a:pPr algn="l">
               <a:spcAft>
-                <a:spcPts val="1400"/>
+                <a:spcPts val="2200"/>
               </a:spcAft>
             </a:pPr>
             <a:r>
-              <a:rPr sz="1800" b="0">
+              <a:rPr sz="2000" b="0">
                 <a:solidFill>
                   <a:srgbClr val="222222"/>
                 </a:solidFill>
@@ -5635,17 +7904,33 @@
           <a:p>
             <a:pPr algn="l">
               <a:spcAft>
-                <a:spcPts val="1400"/>
+                <a:spcPts val="2200"/>
               </a:spcAft>
             </a:pPr>
             <a:r>
-              <a:rPr sz="1800" b="0">
+              <a:rPr sz="2000" b="0">
                 <a:solidFill>
                   <a:srgbClr val="222222"/>
                 </a:solidFill>
                 <a:latin typeface="Calibri"/>
               </a:rPr>
-              <a:t>•   Charts: Matplotlib.   Interface: Tkinter.   Save/Load: Joblib.</a:t>
+              <a:t>•   Charts: Matplotlib.</a:t>
+            </a:r>
+          </a:p>
+          <a:p>
+            <a:pPr algn="l">
+              <a:spcAft>
+                <a:spcPts val="2200"/>
+              </a:spcAft>
+            </a:pPr>
+            <a:r>
+              <a:rPr sz="2000" b="0">
+                <a:solidFill>
+                  <a:srgbClr val="222222"/>
+                </a:solidFill>
+                <a:latin typeface="Calibri"/>
+              </a:rPr>
+              <a:t>•   Interface: Tkinter.   Save / Load: Joblib.</a:t>
             </a:r>
           </a:p>
         </p:txBody>
@@ -5721,7 +8006,7 @@
         <p:spPr>
           <a:xfrm>
             <a:off x="0" y="960120"/>
-            <a:ext cx="12191695" cy="54864"/>
+            <a:ext cx="12191695" cy="64008"/>
           </a:xfrm>
           <a:prstGeom prst="rect">
             <a:avLst/>
@@ -5764,8 +8049,8 @@
         </p:nvSpPr>
         <p:spPr>
           <a:xfrm>
-            <a:off x="457200" y="109728"/>
-            <a:ext cx="11277295" cy="777240"/>
+            <a:off x="457200" y="137160"/>
+            <a:ext cx="8351215" cy="731520"/>
           </a:xfrm>
           <a:prstGeom prst="rect">
             <a:avLst/>
@@ -5795,17 +8080,222 @@
           </a:p>
         </p:txBody>
       </p:sp>
+      <p:sp>
+        <p:nvSpPr>
+          <p:cNvPr id="5" name="TextBox 4"/>
+          <p:cNvSpPr txBox="1"/>
+          <p:nvPr/>
+        </p:nvSpPr>
+        <p:spPr>
+          <a:xfrm>
+            <a:off x="8534095" y="137160"/>
+            <a:ext cx="3200400" cy="731520"/>
+          </a:xfrm>
+          <a:prstGeom prst="rect">
+            <a:avLst/>
+          </a:prstGeom>
+          <a:noFill/>
+        </p:spPr>
+        <p:txBody>
+          <a:bodyPr wrap="square" anchor="ctr">
+            <a:spAutoFit/>
+          </a:bodyPr>
+          <a:lstStyle/>
+          <a:p>
+            <a:pPr algn="r">
+              <a:spcAft>
+                <a:spcPts val="600"/>
+              </a:spcAft>
+            </a:pPr>
+            <a:r>
+              <a:rPr sz="1200" b="1">
+                <a:solidFill>
+                  <a:srgbClr val="C9A227"/>
+                </a:solidFill>
+                <a:latin typeface="Calibri"/>
+              </a:rPr>
+              <a:t>Gold Price Prediction</a:t>
+            </a:r>
+          </a:p>
+        </p:txBody>
+      </p:sp>
+      <p:sp>
+        <p:nvSpPr>
+          <p:cNvPr id="6" name="Rectangle 5"/>
+          <p:cNvSpPr/>
+          <p:nvPr/>
+        </p:nvSpPr>
+        <p:spPr>
+          <a:xfrm>
+            <a:off x="0" y="6473952"/>
+            <a:ext cx="12191695" cy="384048"/>
+          </a:xfrm>
+          <a:prstGeom prst="rect">
+            <a:avLst/>
+          </a:prstGeom>
+          <a:solidFill>
+            <a:srgbClr val="1F3864"/>
+          </a:solidFill>
+          <a:ln>
+            <a:noFill/>
+          </a:ln>
+          <a:effectLst/>
+        </p:spPr>
+        <p:style>
+          <a:lnRef idx="1">
+            <a:schemeClr val="accent1"/>
+          </a:lnRef>
+          <a:fillRef idx="3">
+            <a:schemeClr val="accent1"/>
+          </a:fillRef>
+          <a:effectRef idx="2">
+            <a:schemeClr val="accent1"/>
+          </a:effectRef>
+          <a:fontRef idx="minor">
+            <a:schemeClr val="lt1"/>
+          </a:fontRef>
+        </p:style>
+        <p:txBody>
+          <a:bodyPr rtlCol="0" anchor="ctr"/>
+          <a:lstStyle/>
+          <a:p>
+            <a:pPr algn="ctr"/>
+          </a:p>
+        </p:txBody>
+      </p:sp>
+      <p:sp>
+        <p:nvSpPr>
+          <p:cNvPr id="7" name="Rectangle 6"/>
+          <p:cNvSpPr/>
+          <p:nvPr/>
+        </p:nvSpPr>
+        <p:spPr>
+          <a:xfrm>
+            <a:off x="0" y="6473952"/>
+            <a:ext cx="128016" cy="384048"/>
+          </a:xfrm>
+          <a:prstGeom prst="rect">
+            <a:avLst/>
+          </a:prstGeom>
+          <a:solidFill>
+            <a:srgbClr val="C9A227"/>
+          </a:solidFill>
+          <a:ln>
+            <a:noFill/>
+          </a:ln>
+          <a:effectLst/>
+        </p:spPr>
+        <p:style>
+          <a:lnRef idx="1">
+            <a:schemeClr val="accent1"/>
+          </a:lnRef>
+          <a:fillRef idx="3">
+            <a:schemeClr val="accent1"/>
+          </a:fillRef>
+          <a:effectRef idx="2">
+            <a:schemeClr val="accent1"/>
+          </a:effectRef>
+          <a:fontRef idx="minor">
+            <a:schemeClr val="lt1"/>
+          </a:fontRef>
+        </p:style>
+        <p:txBody>
+          <a:bodyPr rtlCol="0" anchor="ctr"/>
+          <a:lstStyle/>
+          <a:p>
+            <a:pPr algn="ctr"/>
+          </a:p>
+        </p:txBody>
+      </p:sp>
+      <p:sp>
+        <p:nvSpPr>
+          <p:cNvPr id="8" name="TextBox 7"/>
+          <p:cNvSpPr txBox="1"/>
+          <p:nvPr/>
+        </p:nvSpPr>
+        <p:spPr>
+          <a:xfrm>
+            <a:off x="274320" y="6473952"/>
+            <a:ext cx="10362895" cy="384048"/>
+          </a:xfrm>
+          <a:prstGeom prst="rect">
+            <a:avLst/>
+          </a:prstGeom>
+          <a:noFill/>
+        </p:spPr>
+        <p:txBody>
+          <a:bodyPr wrap="square" anchor="ctr">
+            <a:spAutoFit/>
+          </a:bodyPr>
+          <a:lstStyle/>
+          <a:p>
+            <a:pPr algn="l">
+              <a:spcAft>
+                <a:spcPts val="600"/>
+              </a:spcAft>
+            </a:pPr>
+            <a:r>
+              <a:rPr sz="900" b="0">
+                <a:solidFill>
+                  <a:srgbClr val="FFFFFF"/>
+                </a:solidFill>
+                <a:latin typeface="Calibri"/>
+              </a:rPr>
+              <a:t>Sanchay Bhardwaj (2300650100104)  |  B.S.A. College of Engineering &amp; Technology, Mathura</a:t>
+            </a:r>
+          </a:p>
+        </p:txBody>
+      </p:sp>
+      <p:sp>
+        <p:nvSpPr>
+          <p:cNvPr id="9" name="TextBox 8"/>
+          <p:cNvSpPr txBox="1"/>
+          <p:nvPr/>
+        </p:nvSpPr>
+        <p:spPr>
+          <a:xfrm>
+            <a:off x="10728655" y="6473952"/>
+            <a:ext cx="1188720" cy="384048"/>
+          </a:xfrm>
+          <a:prstGeom prst="rect">
+            <a:avLst/>
+          </a:prstGeom>
+          <a:noFill/>
+        </p:spPr>
+        <p:txBody>
+          <a:bodyPr wrap="square" anchor="ctr">
+            <a:spAutoFit/>
+          </a:bodyPr>
+          <a:lstStyle/>
+          <a:p>
+            <a:pPr algn="r">
+              <a:spcAft>
+                <a:spcPts val="600"/>
+              </a:spcAft>
+            </a:pPr>
+            <a:r>
+              <a:rPr sz="900" b="1">
+                <a:solidFill>
+                  <a:srgbClr val="C9A227"/>
+                </a:solidFill>
+                <a:latin typeface="Calibri"/>
+              </a:rPr>
+              <a:t>Slide 8</a:t>
+            </a:r>
+          </a:p>
+        </p:txBody>
+      </p:sp>
       <p:graphicFrame>
         <p:nvGraphicFramePr>
-          <p:cNvPr id="5" name="Table 4"/>
+          <p:cNvPr id="10" name="Table 9"/>
           <p:cNvGraphicFramePr>
             <a:graphicFrameLocks noGrp="1"/>
           </p:cNvGraphicFramePr>
           <p:nvPr/>
         </p:nvGraphicFramePr>
         <p:xfrm>
-          <a:off x="1097280" y="1554480"/>
-          <a:ext cx="9997135" cy="3337560"/>
+          <a:off x="640080" y="1737360"/>
+          <a:ext cx="6675120" cy="3108960"/>
         </p:xfrm>
         <a:graphic>
           <a:graphicData uri="http://schemas.openxmlformats.org/drawingml/2006/table">
@@ -5814,15 +8304,15 @@
                 <a:tableStyleId>{5C22544A-7EE6-4342-B048-85BDC9FD1C3A}</a:tableStyleId>
               </a:tblPr>
               <a:tblGrid>
-                <a:gridCol w="2499283"/>
-                <a:gridCol w="2499283"/>
-                <a:gridCol w="2499283"/>
-                <a:gridCol w="2499286"/>
+                <a:gridCol w="1668780"/>
+                <a:gridCol w="1668780"/>
+                <a:gridCol w="1668780"/>
+                <a:gridCol w="1668780"/>
               </a:tblGrid>
-              <a:tr h="667512">
+              <a:tr h="621792">
                 <a:tc>
                   <a:txBody>
-                    <a:bodyPr/>
+                    <a:bodyPr anchor="ctr"/>
                     <a:lstStyle/>
                     <a:p>
                       <a:pPr algn="ctr">
@@ -5849,7 +8339,7 @@
                 </a:tc>
                 <a:tc>
                   <a:txBody>
-                    <a:bodyPr/>
+                    <a:bodyPr anchor="ctr"/>
                     <a:lstStyle/>
                     <a:p>
                       <a:pPr algn="ctr">
@@ -5876,7 +8366,7 @@
                 </a:tc>
                 <a:tc>
                   <a:txBody>
-                    <a:bodyPr/>
+                    <a:bodyPr anchor="ctr"/>
                     <a:lstStyle/>
                     <a:p>
                       <a:pPr algn="ctr">
@@ -5903,7 +8393,7 @@
                 </a:tc>
                 <a:tc>
                   <a:txBody>
-                    <a:bodyPr/>
+                    <a:bodyPr anchor="ctr"/>
                     <a:lstStyle/>
                     <a:p>
                       <a:pPr algn="ctr">
@@ -5929,10 +8419,37 @@
                   </a:tcPr>
                 </a:tc>
               </a:tr>
-              <a:tr h="667512">
+              <a:tr h="621792">
                 <a:tc>
                   <a:txBody>
-                    <a:bodyPr/>
+                    <a:bodyPr anchor="ctr"/>
+                    <a:lstStyle/>
+                    <a:p>
+                      <a:pPr algn="l">
+                        <a:spcAft>
+                          <a:spcPts val="600"/>
+                        </a:spcAft>
+                      </a:pPr>
+                      <a:r>
+                        <a:rPr sz="1400" b="1">
+                          <a:solidFill>
+                            <a:srgbClr val="C9A227"/>
+                          </a:solidFill>
+                          <a:latin typeface="Calibri"/>
+                        </a:rPr>
+                        <a:t>RandomForest</a:t>
+                      </a:r>
+                    </a:p>
+                  </a:txBody>
+                  <a:tcPr>
+                    <a:solidFill>
+                      <a:srgbClr val="EEF3FA"/>
+                    </a:solidFill>
+                  </a:tcPr>
+                </a:tc>
+                <a:tc>
+                  <a:txBody>
+                    <a:bodyPr anchor="ctr"/>
                     <a:lstStyle/>
                     <a:p>
                       <a:pPr algn="ctr">
@@ -5944,33 +8461,6 @@
                         <a:rPr sz="1400" b="1">
                           <a:solidFill>
                             <a:srgbClr val="C9A227"/>
-                          </a:solidFill>
-                          <a:latin typeface="Calibri"/>
-                        </a:rPr>
-                        <a:t>RandomForest (best)</a:t>
-                      </a:r>
-                    </a:p>
-                  </a:txBody>
-                  <a:tcPr>
-                    <a:solidFill>
-                      <a:srgbClr val="EEF3FA"/>
-                    </a:solidFill>
-                  </a:tcPr>
-                </a:tc>
-                <a:tc>
-                  <a:txBody>
-                    <a:bodyPr/>
-                    <a:lstStyle/>
-                    <a:p>
-                      <a:pPr algn="ctr">
-                        <a:spcAft>
-                          <a:spcPts val="600"/>
-                        </a:spcAft>
-                      </a:pPr>
-                      <a:r>
-                        <a:rPr sz="1400" b="0">
-                          <a:solidFill>
-                            <a:srgbClr val="222222"/>
                           </a:solidFill>
                           <a:latin typeface="Calibri"/>
                         </a:rPr>
@@ -5986,7 +8476,7 @@
                 </a:tc>
                 <a:tc>
                   <a:txBody>
-                    <a:bodyPr/>
+                    <a:bodyPr anchor="ctr"/>
                     <a:lstStyle/>
                     <a:p>
                       <a:pPr algn="ctr">
@@ -5995,9 +8485,9 @@
                         </a:spcAft>
                       </a:pPr>
                       <a:r>
-                        <a:rPr sz="1400" b="0">
+                        <a:rPr sz="1400" b="1">
                           <a:solidFill>
-                            <a:srgbClr val="222222"/>
+                            <a:srgbClr val="C9A227"/>
                           </a:solidFill>
                           <a:latin typeface="Calibri"/>
                         </a:rPr>
@@ -6013,7 +8503,7 @@
                 </a:tc>
                 <a:tc>
                   <a:txBody>
-                    <a:bodyPr/>
+                    <a:bodyPr anchor="ctr"/>
                     <a:lstStyle/>
                     <a:p>
                       <a:pPr algn="ctr">
@@ -6022,9 +8512,9 @@
                         </a:spcAft>
                       </a:pPr>
                       <a:r>
-                        <a:rPr sz="1400" b="0">
+                        <a:rPr sz="1400" b="1">
                           <a:solidFill>
-                            <a:srgbClr val="222222"/>
+                            <a:srgbClr val="C9A227"/>
                           </a:solidFill>
                           <a:latin typeface="Calibri"/>
                         </a:rPr>
@@ -6039,13 +8529,13 @@
                   </a:tcPr>
                 </a:tc>
               </a:tr>
-              <a:tr h="667512">
+              <a:tr h="621792">
                 <a:tc>
                   <a:txBody>
-                    <a:bodyPr/>
+                    <a:bodyPr anchor="ctr"/>
                     <a:lstStyle/>
                     <a:p>
-                      <a:pPr algn="ctr">
+                      <a:pPr algn="l">
                         <a:spcAft>
                           <a:spcPts val="600"/>
                         </a:spcAft>
@@ -6069,7 +8559,7 @@
                 </a:tc>
                 <a:tc>
                   <a:txBody>
-                    <a:bodyPr/>
+                    <a:bodyPr anchor="ctr"/>
                     <a:lstStyle/>
                     <a:p>
                       <a:pPr algn="ctr">
@@ -6096,7 +8586,7 @@
                 </a:tc>
                 <a:tc>
                   <a:txBody>
-                    <a:bodyPr/>
+                    <a:bodyPr anchor="ctr"/>
                     <a:lstStyle/>
                     <a:p>
                       <a:pPr algn="ctr">
@@ -6123,7 +8613,7 @@
                 </a:tc>
                 <a:tc>
                   <a:txBody>
-                    <a:bodyPr/>
+                    <a:bodyPr anchor="ctr"/>
                     <a:lstStyle/>
                     <a:p>
                       <a:pPr algn="ctr">
@@ -6149,13 +8639,13 @@
                   </a:tcPr>
                 </a:tc>
               </a:tr>
-              <a:tr h="667512">
+              <a:tr h="621792">
                 <a:tc>
                   <a:txBody>
-                    <a:bodyPr/>
+                    <a:bodyPr anchor="ctr"/>
                     <a:lstStyle/>
                     <a:p>
-                      <a:pPr algn="ctr">
+                      <a:pPr algn="l">
                         <a:spcAft>
                           <a:spcPts val="600"/>
                         </a:spcAft>
@@ -6179,7 +8669,7 @@
                 </a:tc>
                 <a:tc>
                   <a:txBody>
-                    <a:bodyPr/>
+                    <a:bodyPr anchor="ctr"/>
                     <a:lstStyle/>
                     <a:p>
                       <a:pPr algn="ctr">
@@ -6206,7 +8696,7 @@
                 </a:tc>
                 <a:tc>
                   <a:txBody>
-                    <a:bodyPr/>
+                    <a:bodyPr anchor="ctr"/>
                     <a:lstStyle/>
                     <a:p>
                       <a:pPr algn="ctr">
@@ -6233,7 +8723,7 @@
                 </a:tc>
                 <a:tc>
                   <a:txBody>
-                    <a:bodyPr/>
+                    <a:bodyPr anchor="ctr"/>
                     <a:lstStyle/>
                     <a:p>
                       <a:pPr algn="ctr">
@@ -6259,13 +8749,13 @@
                   </a:tcPr>
                 </a:tc>
               </a:tr>
-              <a:tr h="667512">
+              <a:tr h="621792">
                 <a:tc>
                   <a:txBody>
-                    <a:bodyPr/>
+                    <a:bodyPr anchor="ctr"/>
                     <a:lstStyle/>
                     <a:p>
-                      <a:pPr algn="ctr">
+                      <a:pPr algn="l">
                         <a:spcAft>
                           <a:spcPts val="600"/>
                         </a:spcAft>
@@ -6289,7 +8779,7 @@
                 </a:tc>
                 <a:tc>
                   <a:txBody>
-                    <a:bodyPr/>
+                    <a:bodyPr anchor="ctr"/>
                     <a:lstStyle/>
                     <a:p>
                       <a:pPr algn="ctr">
@@ -6316,7 +8806,7 @@
                 </a:tc>
                 <a:tc>
                   <a:txBody>
-                    <a:bodyPr/>
+                    <a:bodyPr anchor="ctr"/>
                     <a:lstStyle/>
                     <a:p>
                       <a:pPr algn="ctr">
@@ -6343,7 +8833,7 @@
                 </a:tc>
                 <a:tc>
                   <a:txBody>
-                    <a:bodyPr/>
+                    <a:bodyPr anchor="ctr"/>
                     <a:lstStyle/>
                     <a:p>
                       <a:pPr algn="ctr">
@@ -6373,16 +8863,40 @@
           </a:graphicData>
         </a:graphic>
       </p:graphicFrame>
-      <p:sp>
-        <p:nvSpPr>
-          <p:cNvPr id="6" name="TextBox 5"/>
+      <p:pic>
+        <p:nvPicPr>
+          <p:cNvPr id="11" name="Picture 10" descr="results_chart.png"/>
+          <p:cNvPicPr>
+            <a:picLocks noChangeAspect="1"/>
+          </p:cNvPicPr>
+          <p:nvPr/>
+        </p:nvPicPr>
+        <p:blipFill>
+          <a:blip r:embed="rId2"/>
+          <a:stretch>
+            <a:fillRect/>
+          </a:stretch>
+        </p:blipFill>
+        <p:spPr>
+          <a:xfrm>
+            <a:off x="7680960" y="1554480"/>
+            <a:ext cx="3931920" cy="3291840"/>
+          </a:xfrm>
+          <a:prstGeom prst="rect">
+            <a:avLst/>
+          </a:prstGeom>
+        </p:spPr>
+      </p:pic>
+      <p:sp>
+        <p:nvSpPr>
+          <p:cNvPr id="12" name="TextBox 11"/>
           <p:cNvSpPr txBox="1"/>
           <p:nvPr/>
         </p:nvSpPr>
         <p:spPr>
           <a:xfrm>
-            <a:off x="1097280" y="5394960"/>
-            <a:ext cx="9997135" cy="822960"/>
+            <a:off x="640080" y="5212080"/>
+            <a:ext cx="6675120" cy="914400"/>
           </a:xfrm>
           <a:prstGeom prst="rect">
             <a:avLst/>
@@ -6395,7 +8909,7 @@
           </a:bodyPr>
           <a:lstStyle/>
           <a:p>
-            <a:pPr algn="ctr">
+            <a:pPr algn="l">
               <a:spcAft>
                 <a:spcPts val="600"/>
               </a:spcAft>
@@ -6407,7 +8921,7 @@
                 </a:solidFill>
                 <a:latin typeface="Calibri"/>
               </a:rPr>
-              <a:t>Test window: last 60 months (from Jan 2020). Lower MAE / RMSE and higher R-squared are better.</a:t>
+              <a:t>RandomForest wins on every metric. Test window: last 60 months (from Jan 2020). Lower MAE / RMSE and higher R-squared are better.</a:t>
             </a:r>
           </a:p>
         </p:txBody>
@@ -6483,7 +8997,7 @@
         <p:spPr>
           <a:xfrm>
             <a:off x="0" y="960120"/>
-            <a:ext cx="12191695" cy="54864"/>
+            <a:ext cx="12191695" cy="64008"/>
           </a:xfrm>
           <a:prstGeom prst="rect">
             <a:avLst/>
@@ -6526,8 +9040,8 @@
         </p:nvSpPr>
         <p:spPr>
           <a:xfrm>
-            <a:off x="457200" y="109728"/>
-            <a:ext cx="11277295" cy="777240"/>
+            <a:off x="457200" y="137160"/>
+            <a:ext cx="8351215" cy="731520"/>
           </a:xfrm>
           <a:prstGeom prst="rect">
             <a:avLst/>
@@ -6557,9 +9071,214 @@
           </a:p>
         </p:txBody>
       </p:sp>
+      <p:sp>
+        <p:nvSpPr>
+          <p:cNvPr id="5" name="TextBox 4"/>
+          <p:cNvSpPr txBox="1"/>
+          <p:nvPr/>
+        </p:nvSpPr>
+        <p:spPr>
+          <a:xfrm>
+            <a:off x="8534095" y="137160"/>
+            <a:ext cx="3200400" cy="731520"/>
+          </a:xfrm>
+          <a:prstGeom prst="rect">
+            <a:avLst/>
+          </a:prstGeom>
+          <a:noFill/>
+        </p:spPr>
+        <p:txBody>
+          <a:bodyPr wrap="square" anchor="ctr">
+            <a:spAutoFit/>
+          </a:bodyPr>
+          <a:lstStyle/>
+          <a:p>
+            <a:pPr algn="r">
+              <a:spcAft>
+                <a:spcPts val="600"/>
+              </a:spcAft>
+            </a:pPr>
+            <a:r>
+              <a:rPr sz="1200" b="1">
+                <a:solidFill>
+                  <a:srgbClr val="C9A227"/>
+                </a:solidFill>
+                <a:latin typeface="Calibri"/>
+              </a:rPr>
+              <a:t>Gold Price Prediction</a:t>
+            </a:r>
+          </a:p>
+        </p:txBody>
+      </p:sp>
+      <p:sp>
+        <p:nvSpPr>
+          <p:cNvPr id="6" name="Rectangle 5"/>
+          <p:cNvSpPr/>
+          <p:nvPr/>
+        </p:nvSpPr>
+        <p:spPr>
+          <a:xfrm>
+            <a:off x="0" y="6473952"/>
+            <a:ext cx="12191695" cy="384048"/>
+          </a:xfrm>
+          <a:prstGeom prst="rect">
+            <a:avLst/>
+          </a:prstGeom>
+          <a:solidFill>
+            <a:srgbClr val="1F3864"/>
+          </a:solidFill>
+          <a:ln>
+            <a:noFill/>
+          </a:ln>
+          <a:effectLst/>
+        </p:spPr>
+        <p:style>
+          <a:lnRef idx="1">
+            <a:schemeClr val="accent1"/>
+          </a:lnRef>
+          <a:fillRef idx="3">
+            <a:schemeClr val="accent1"/>
+          </a:fillRef>
+          <a:effectRef idx="2">
+            <a:schemeClr val="accent1"/>
+          </a:effectRef>
+          <a:fontRef idx="minor">
+            <a:schemeClr val="lt1"/>
+          </a:fontRef>
+        </p:style>
+        <p:txBody>
+          <a:bodyPr rtlCol="0" anchor="ctr"/>
+          <a:lstStyle/>
+          <a:p>
+            <a:pPr algn="ctr"/>
+          </a:p>
+        </p:txBody>
+      </p:sp>
+      <p:sp>
+        <p:nvSpPr>
+          <p:cNvPr id="7" name="Rectangle 6"/>
+          <p:cNvSpPr/>
+          <p:nvPr/>
+        </p:nvSpPr>
+        <p:spPr>
+          <a:xfrm>
+            <a:off x="0" y="6473952"/>
+            <a:ext cx="128016" cy="384048"/>
+          </a:xfrm>
+          <a:prstGeom prst="rect">
+            <a:avLst/>
+          </a:prstGeom>
+          <a:solidFill>
+            <a:srgbClr val="C9A227"/>
+          </a:solidFill>
+          <a:ln>
+            <a:noFill/>
+          </a:ln>
+          <a:effectLst/>
+        </p:spPr>
+        <p:style>
+          <a:lnRef idx="1">
+            <a:schemeClr val="accent1"/>
+          </a:lnRef>
+          <a:fillRef idx="3">
+            <a:schemeClr val="accent1"/>
+          </a:fillRef>
+          <a:effectRef idx="2">
+            <a:schemeClr val="accent1"/>
+          </a:effectRef>
+          <a:fontRef idx="minor">
+            <a:schemeClr val="lt1"/>
+          </a:fontRef>
+        </p:style>
+        <p:txBody>
+          <a:bodyPr rtlCol="0" anchor="ctr"/>
+          <a:lstStyle/>
+          <a:p>
+            <a:pPr algn="ctr"/>
+          </a:p>
+        </p:txBody>
+      </p:sp>
+      <p:sp>
+        <p:nvSpPr>
+          <p:cNvPr id="8" name="TextBox 7"/>
+          <p:cNvSpPr txBox="1"/>
+          <p:nvPr/>
+        </p:nvSpPr>
+        <p:spPr>
+          <a:xfrm>
+            <a:off x="274320" y="6473952"/>
+            <a:ext cx="10362895" cy="384048"/>
+          </a:xfrm>
+          <a:prstGeom prst="rect">
+            <a:avLst/>
+          </a:prstGeom>
+          <a:noFill/>
+        </p:spPr>
+        <p:txBody>
+          <a:bodyPr wrap="square" anchor="ctr">
+            <a:spAutoFit/>
+          </a:bodyPr>
+          <a:lstStyle/>
+          <a:p>
+            <a:pPr algn="l">
+              <a:spcAft>
+                <a:spcPts val="600"/>
+              </a:spcAft>
+            </a:pPr>
+            <a:r>
+              <a:rPr sz="900" b="0">
+                <a:solidFill>
+                  <a:srgbClr val="FFFFFF"/>
+                </a:solidFill>
+                <a:latin typeface="Calibri"/>
+              </a:rPr>
+              <a:t>Sanchay Bhardwaj (2300650100104)  |  B.S.A. College of Engineering &amp; Technology, Mathura</a:t>
+            </a:r>
+          </a:p>
+        </p:txBody>
+      </p:sp>
+      <p:sp>
+        <p:nvSpPr>
+          <p:cNvPr id="9" name="TextBox 8"/>
+          <p:cNvSpPr txBox="1"/>
+          <p:nvPr/>
+        </p:nvSpPr>
+        <p:spPr>
+          <a:xfrm>
+            <a:off x="10728655" y="6473952"/>
+            <a:ext cx="1188720" cy="384048"/>
+          </a:xfrm>
+          <a:prstGeom prst="rect">
+            <a:avLst/>
+          </a:prstGeom>
+          <a:noFill/>
+        </p:spPr>
+        <p:txBody>
+          <a:bodyPr wrap="square" anchor="ctr">
+            <a:spAutoFit/>
+          </a:bodyPr>
+          <a:lstStyle/>
+          <a:p>
+            <a:pPr algn="r">
+              <a:spcAft>
+                <a:spcPts val="600"/>
+              </a:spcAft>
+            </a:pPr>
+            <a:r>
+              <a:rPr sz="900" b="1">
+                <a:solidFill>
+                  <a:srgbClr val="C9A227"/>
+                </a:solidFill>
+                <a:latin typeface="Calibri"/>
+              </a:rPr>
+              <a:t>Slide 9</a:t>
+            </a:r>
+          </a:p>
+        </p:txBody>
+      </p:sp>
       <p:pic>
         <p:nvPicPr>
-          <p:cNvPr id="5" name="Picture 4" descr="screenshot_predict.png"/>
+          <p:cNvPr id="10" name="Picture 9" descr="screenshot_predict.png"/>
           <p:cNvPicPr>
             <a:picLocks noChangeAspect="1"/>
           </p:cNvPicPr>
@@ -6573,8 +9292,8 @@
         </p:blipFill>
         <p:spPr>
           <a:xfrm>
-            <a:off x="2426491" y="1371600"/>
-            <a:ext cx="7338713" cy="4846320"/>
+            <a:off x="2703423" y="1325880"/>
+            <a:ext cx="6784848" cy="4480560"/>
           </a:xfrm>
           <a:prstGeom prst="rect">
             <a:avLst/>
@@ -6583,14 +9302,14 @@
       </p:pic>
       <p:sp>
         <p:nvSpPr>
-          <p:cNvPr id="6" name="TextBox 5"/>
+          <p:cNvPr id="11" name="TextBox 10"/>
           <p:cNvSpPr txBox="1"/>
           <p:nvPr/>
         </p:nvSpPr>
         <p:spPr>
           <a:xfrm>
-            <a:off x="914400" y="6126480"/>
-            <a:ext cx="10362895" cy="548640"/>
+            <a:off x="914400" y="5623560"/>
+            <a:ext cx="10362895" cy="640080"/>
           </a:xfrm>
           <a:prstGeom prst="rect">
             <a:avLst/>

</xml_diff>

<commit_message>
Replace the desktop GUI with a live gold + silver web dashboard
The Tkinter window was hard to read and only knew about gold. The new
dashboard fetches real prices from public APIs, converts them to rupees
per gram and per kg, and forecasts 12 months for both metals starting
from today's live price instead of the end of the training file.
</commit_message>
<xml_diff>
--- a/docs/Gold-Price-Prediction-Presentation.pptx
+++ b/docs/Gold-Price-Prediction-Presentation.pptx
@@ -18,6 +18,8 @@
     <p:sldId id="266" r:id="rId17"/>
     <p:sldId id="267" r:id="rId18"/>
     <p:sldId id="268" r:id="rId19"/>
+    <p:sldId id="269" r:id="rId20"/>
+    <p:sldId id="270" r:id="rId21"/>
   </p:sldIdLst>
   <p:sldSz cx="12191695" cy="6858000" type="screen4x3"/>
   <p:notesSz cx="6858000" cy="9144000"/>
@@ -3240,13 +3242,13 @@
               </a:spcAft>
             </a:pPr>
             <a:r>
-              <a:rPr sz="3400" b="1">
+              <a:rPr sz="3200" b="1">
                 <a:solidFill>
                   <a:srgbClr val="FFFFFF"/>
                 </a:solidFill>
                 <a:latin typeface="Calibri"/>
               </a:rPr>
-              <a:t>Gold Price Prediction using Machine Learning</a:t>
+              <a:t>Live Gold &amp; Silver Price Prediction using Machine Learning</a:t>
             </a:r>
           </a:p>
           <a:p>
@@ -3510,7 +3512,7 @@
                 </a:solidFill>
                 <a:latin typeface="Calibri"/>
               </a:rPr>
-              <a:t>Application - Model Comparison</a:t>
+              <a:t>Application - Live Dashboard</a:t>
             </a:r>
           </a:p>
         </p:txBody>
@@ -3549,7 +3551,7 @@
                 </a:solidFill>
                 <a:latin typeface="Calibri"/>
               </a:rPr>
-              <a:t>Gold Price Prediction</a:t>
+              <a:t>Gold &amp; Silver Predictor</a:t>
             </a:r>
           </a:p>
         </p:txBody>
@@ -3722,7 +3724,7 @@
       </p:sp>
       <p:pic>
         <p:nvPicPr>
-          <p:cNvPr id="10" name="Picture 9" descr="screenshot_train.png"/>
+          <p:cNvPr id="10" name="Picture 9" descr="dashboard_overview.png"/>
           <p:cNvPicPr>
             <a:picLocks noChangeAspect="1"/>
           </p:cNvPicPr>
@@ -3736,8 +3738,8 @@
         </p:blipFill>
         <p:spPr>
           <a:xfrm>
-            <a:off x="2703423" y="1325880"/>
-            <a:ext cx="6784848" cy="4480560"/>
+            <a:off x="2053237" y="1325880"/>
+            <a:ext cx="8085221" cy="4480560"/>
           </a:xfrm>
           <a:prstGeom prst="rect">
             <a:avLst/>
@@ -3778,7 +3780,7 @@
                 </a:solidFill>
                 <a:latin typeface="Calibri"/>
               </a:rPr>
-              <a:t>Train tab: accuracy table and the error comparison across all models.</a:t>
+              <a:t>Today's live gold and silver price in rupees per gram, per kg and per 10 gram, with the monthly history since 2000.</a:t>
             </a:r>
           </a:p>
         </p:txBody>
@@ -3923,7 +3925,7 @@
                 </a:solidFill>
                 <a:latin typeface="Calibri"/>
               </a:rPr>
-              <a:t>Conclusion</a:t>
+              <a:t>Application - 12 Month Forecast</a:t>
             </a:r>
           </a:p>
         </p:txBody>
@@ -3962,7 +3964,7 @@
                 </a:solidFill>
                 <a:latin typeface="Calibri"/>
               </a:rPr>
-              <a:t>Gold Price Prediction</a:t>
+              <a:t>Gold &amp; Silver Predictor</a:t>
             </a:r>
           </a:p>
         </p:txBody>
@@ -4133,50 +4135,30 @@
           </a:p>
         </p:txBody>
       </p:sp>
-      <p:sp>
-        <p:nvSpPr>
-          <p:cNvPr id="10" name="Rectangle 9"/>
-          <p:cNvSpPr/>
-          <p:nvPr/>
-        </p:nvSpPr>
-        <p:spPr>
-          <a:xfrm>
-            <a:off x="502920" y="1554480"/>
-            <a:ext cx="82296" cy="4297680"/>
-          </a:xfrm>
-          <a:prstGeom prst="rect">
-            <a:avLst/>
-          </a:prstGeom>
-          <a:solidFill>
-            <a:srgbClr val="C9A227"/>
-          </a:solidFill>
-          <a:ln>
-            <a:noFill/>
-          </a:ln>
-          <a:effectLst/>
-        </p:spPr>
-        <p:style>
-          <a:lnRef idx="1">
-            <a:schemeClr val="accent1"/>
-          </a:lnRef>
-          <a:fillRef idx="3">
-            <a:schemeClr val="accent1"/>
-          </a:fillRef>
-          <a:effectRef idx="2">
-            <a:schemeClr val="accent1"/>
-          </a:effectRef>
-          <a:fontRef idx="minor">
-            <a:schemeClr val="lt1"/>
-          </a:fontRef>
-        </p:style>
-        <p:txBody>
-          <a:bodyPr rtlCol="0" anchor="ctr"/>
-          <a:lstStyle/>
-          <a:p>
-            <a:pPr algn="ctr"/>
-          </a:p>
-        </p:txBody>
-      </p:sp>
+      <p:pic>
+        <p:nvPicPr>
+          <p:cNvPr id="10" name="Picture 9" descr="dashboard_forecast.png"/>
+          <p:cNvPicPr>
+            <a:picLocks noChangeAspect="1"/>
+          </p:cNvPicPr>
+          <p:nvPr/>
+        </p:nvPicPr>
+        <p:blipFill>
+          <a:blip r:embed="rId2"/>
+          <a:stretch>
+            <a:fillRect/>
+          </a:stretch>
+        </p:blipFill>
+        <p:spPr>
+          <a:xfrm>
+            <a:off x="2535138" y="1325880"/>
+            <a:ext cx="7121419" cy="4480560"/>
+          </a:xfrm>
+          <a:prstGeom prst="rect">
+            <a:avLst/>
+          </a:prstGeom>
+        </p:spPr>
+      </p:pic>
       <p:sp>
         <p:nvSpPr>
           <p:cNvPr id="11" name="TextBox 10"/>
@@ -4185,8 +4167,8 @@
         </p:nvSpPr>
         <p:spPr>
           <a:xfrm>
-            <a:off x="868680" y="1371600"/>
-            <a:ext cx="10728655" cy="4663440"/>
+            <a:off x="914400" y="5623560"/>
+            <a:ext cx="10362895" cy="640080"/>
           </a:xfrm>
           <a:prstGeom prst="rect">
             <a:avLst/>
@@ -4194,72 +4176,24 @@
           <a:noFill/>
         </p:spPr>
         <p:txBody>
-          <a:bodyPr wrap="square" anchor="ctr">
+          <a:bodyPr wrap="square">
             <a:spAutoFit/>
           </a:bodyPr>
           <a:lstStyle/>
           <a:p>
-            <a:pPr algn="l">
-              <a:spcAft>
-                <a:spcPts val="2200"/>
-              </a:spcAft>
-            </a:pPr>
-            <a:r>
-              <a:rPr sz="2000" b="0">
-                <a:solidFill>
-                  <a:srgbClr val="222222"/>
-                </a:solidFill>
-                <a:latin typeface="Calibri"/>
-              </a:rPr>
-              <a:t>•   RandomForest gave the best accuracy and clearly beat the naive baseline.</a:t>
-            </a:r>
-          </a:p>
-          <a:p>
-            <a:pPr algn="l">
-              <a:spcAft>
-                <a:spcPts val="2200"/>
-              </a:spcAft>
-            </a:pPr>
-            <a:r>
-              <a:rPr sz="2000" b="0">
-                <a:solidFill>
-                  <a:srgbClr val="222222"/>
-                </a:solidFill>
-                <a:latin typeface="Calibri"/>
-              </a:rPr>
-              <a:t>•   Predicting returns instead of raw prices made the models reliable on a trending series.</a:t>
-            </a:r>
-          </a:p>
-          <a:p>
-            <a:pPr algn="l">
-              <a:spcAft>
-                <a:spcPts val="2200"/>
-              </a:spcAft>
-            </a:pPr>
-            <a:r>
-              <a:rPr sz="2000" b="0">
-                <a:solidFill>
-                  <a:srgbClr val="222222"/>
-                </a:solidFill>
-                <a:latin typeface="Calibri"/>
-              </a:rPr>
-              <a:t>•   The Tkinter GUI turns the trained model into an easy-to-use forecasting tool.</a:t>
-            </a:r>
-          </a:p>
-          <a:p>
-            <a:pPr algn="l">
-              <a:spcAft>
-                <a:spcPts val="2200"/>
-              </a:spcAft>
-            </a:pPr>
-            <a:r>
-              <a:rPr sz="2000" b="0">
-                <a:solidFill>
-                  <a:srgbClr val="222222"/>
-                </a:solidFill>
-                <a:latin typeface="Calibri"/>
-              </a:rPr>
-              <a:t>•   The project demonstrates a complete Machine Learning pipeline from data to interface.</a:t>
+            <a:pPr algn="ctr">
+              <a:spcAft>
+                <a:spcPts val="600"/>
+              </a:spcAft>
+            </a:pPr>
+            <a:r>
+              <a:rPr sz="1300" b="0">
+                <a:solidFill>
+                  <a:srgbClr val="6B7280"/>
+                </a:solidFill>
+                <a:latin typeface="Calibri"/>
+              </a:rPr>
+              <a:t>Solid line = actual price, dashed line = model forecast, plus the month by month expected price in rupees.</a:t>
             </a:r>
           </a:p>
         </p:txBody>
@@ -4404,7 +4338,7 @@
                 </a:solidFill>
                 <a:latin typeface="Calibri"/>
               </a:rPr>
-              <a:t>Future Scope</a:t>
+              <a:t>Application - Model Accuracy</a:t>
             </a:r>
           </a:p>
         </p:txBody>
@@ -4443,7 +4377,7 @@
                 </a:solidFill>
                 <a:latin typeface="Calibri"/>
               </a:rPr>
-              <a:t>Gold Price Prediction</a:t>
+              <a:t>Gold &amp; Silver Predictor</a:t>
             </a:r>
           </a:p>
         </p:txBody>
@@ -4614,50 +4548,30 @@
           </a:p>
         </p:txBody>
       </p:sp>
-      <p:sp>
-        <p:nvSpPr>
-          <p:cNvPr id="10" name="Rectangle 9"/>
-          <p:cNvSpPr/>
-          <p:nvPr/>
-        </p:nvSpPr>
-        <p:spPr>
-          <a:xfrm>
-            <a:off x="502920" y="1554480"/>
-            <a:ext cx="82296" cy="4297680"/>
-          </a:xfrm>
-          <a:prstGeom prst="rect">
-            <a:avLst/>
-          </a:prstGeom>
-          <a:solidFill>
-            <a:srgbClr val="C9A227"/>
-          </a:solidFill>
-          <a:ln>
-            <a:noFill/>
-          </a:ln>
-          <a:effectLst/>
-        </p:spPr>
-        <p:style>
-          <a:lnRef idx="1">
-            <a:schemeClr val="accent1"/>
-          </a:lnRef>
-          <a:fillRef idx="3">
-            <a:schemeClr val="accent1"/>
-          </a:fillRef>
-          <a:effectRef idx="2">
-            <a:schemeClr val="accent1"/>
-          </a:effectRef>
-          <a:fontRef idx="minor">
-            <a:schemeClr val="lt1"/>
-          </a:fontRef>
-        </p:style>
-        <p:txBody>
-          <a:bodyPr rtlCol="0" anchor="ctr"/>
-          <a:lstStyle/>
-          <a:p>
-            <a:pPr algn="ctr"/>
-          </a:p>
-        </p:txBody>
-      </p:sp>
+      <p:pic>
+        <p:nvPicPr>
+          <p:cNvPr id="10" name="Picture 9" descr="dashboard_accuracy.png"/>
+          <p:cNvPicPr>
+            <a:picLocks noChangeAspect="1"/>
+          </p:cNvPicPr>
+          <p:nvPr/>
+        </p:nvPicPr>
+        <p:blipFill>
+          <a:blip r:embed="rId2"/>
+          <a:stretch>
+            <a:fillRect/>
+          </a:stretch>
+        </p:blipFill>
+        <p:spPr>
+          <a:xfrm>
+            <a:off x="731520" y="1325880"/>
+            <a:ext cx="10728655" cy="4269110"/>
+          </a:xfrm>
+          <a:prstGeom prst="rect">
+            <a:avLst/>
+          </a:prstGeom>
+        </p:spPr>
+      </p:pic>
       <p:sp>
         <p:nvSpPr>
           <p:cNvPr id="11" name="TextBox 10"/>
@@ -4666,8 +4580,8 @@
         </p:nvSpPr>
         <p:spPr>
           <a:xfrm>
-            <a:off x="868680" y="1371600"/>
-            <a:ext cx="10728655" cy="4663440"/>
+            <a:off x="914400" y="5623560"/>
+            <a:ext cx="10362895" cy="640080"/>
           </a:xfrm>
           <a:prstGeom prst="rect">
             <a:avLst/>
@@ -4675,72 +4589,24 @@
           <a:noFill/>
         </p:spPr>
         <p:txBody>
-          <a:bodyPr wrap="square" anchor="ctr">
+          <a:bodyPr wrap="square">
             <a:spAutoFit/>
           </a:bodyPr>
           <a:lstStyle/>
           <a:p>
-            <a:pPr algn="l">
-              <a:spcAft>
-                <a:spcPts val="2200"/>
-              </a:spcAft>
-            </a:pPr>
-            <a:r>
-              <a:rPr sz="2000" b="0">
-                <a:solidFill>
-                  <a:srgbClr val="222222"/>
-                </a:solidFill>
-                <a:latin typeface="Calibri"/>
-              </a:rPr>
-              <a:t>•   Add real economic features such as inflation, USD index and interest rates.</a:t>
-            </a:r>
-          </a:p>
-          <a:p>
-            <a:pPr algn="l">
-              <a:spcAft>
-                <a:spcPts val="2200"/>
-              </a:spcAft>
-            </a:pPr>
-            <a:r>
-              <a:rPr sz="2000" b="0">
-                <a:solidFill>
-                  <a:srgbClr val="222222"/>
-                </a:solidFill>
-                <a:latin typeface="Calibri"/>
-              </a:rPr>
-              <a:t>•   Try deep-learning time-series models like LSTM for longer forecasts.</a:t>
-            </a:r>
-          </a:p>
-          <a:p>
-            <a:pPr algn="l">
-              <a:spcAft>
-                <a:spcPts val="2200"/>
-              </a:spcAft>
-            </a:pPr>
-            <a:r>
-              <a:rPr sz="2000" b="0">
-                <a:solidFill>
-                  <a:srgbClr val="222222"/>
-                </a:solidFill>
-                <a:latin typeface="Calibri"/>
-              </a:rPr>
-              <a:t>•   Connect a live gold price API so predictions always use current data.</a:t>
-            </a:r>
-          </a:p>
-          <a:p>
-            <a:pPr algn="l">
-              <a:spcAft>
-                <a:spcPts val="2200"/>
-              </a:spcAft>
-            </a:pPr>
-            <a:r>
-              <a:rPr sz="2000" b="0">
-                <a:solidFill>
-                  <a:srgbClr val="222222"/>
-                </a:solidFill>
-                <a:latin typeface="Calibri"/>
-              </a:rPr>
-              <a:t>•   Show a confidence range instead of a single predicted value.</a:t>
+            <a:pPr algn="ctr">
+              <a:spcAft>
+                <a:spcPts val="600"/>
+              </a:spcAft>
+            </a:pPr>
+            <a:r>
+              <a:rPr sz="1300" b="0">
+                <a:solidFill>
+                  <a:srgbClr val="6B7280"/>
+                </a:solidFill>
+                <a:latin typeface="Calibri"/>
+              </a:rPr>
+              <a:t>Error of every model on 60 unseen months, compared against the naive 'next month = this month' baseline.</a:t>
             </a:r>
           </a:p>
         </p:txBody>
@@ -4772,6 +4638,984 @@
         <p:spPr>
           <a:xfrm>
             <a:off x="0" y="0"/>
+            <a:ext cx="12191695" cy="960120"/>
+          </a:xfrm>
+          <a:prstGeom prst="rect">
+            <a:avLst/>
+          </a:prstGeom>
+          <a:solidFill>
+            <a:srgbClr val="1F3864"/>
+          </a:solidFill>
+          <a:ln>
+            <a:noFill/>
+          </a:ln>
+          <a:effectLst/>
+        </p:spPr>
+        <p:style>
+          <a:lnRef idx="1">
+            <a:schemeClr val="accent1"/>
+          </a:lnRef>
+          <a:fillRef idx="3">
+            <a:schemeClr val="accent1"/>
+          </a:fillRef>
+          <a:effectRef idx="2">
+            <a:schemeClr val="accent1"/>
+          </a:effectRef>
+          <a:fontRef idx="minor">
+            <a:schemeClr val="lt1"/>
+          </a:fontRef>
+        </p:style>
+        <p:txBody>
+          <a:bodyPr rtlCol="0" anchor="ctr"/>
+          <a:lstStyle/>
+          <a:p>
+            <a:pPr algn="ctr"/>
+          </a:p>
+        </p:txBody>
+      </p:sp>
+      <p:sp>
+        <p:nvSpPr>
+          <p:cNvPr id="3" name="Rectangle 2"/>
+          <p:cNvSpPr/>
+          <p:nvPr/>
+        </p:nvSpPr>
+        <p:spPr>
+          <a:xfrm>
+            <a:off x="0" y="960120"/>
+            <a:ext cx="12191695" cy="64008"/>
+          </a:xfrm>
+          <a:prstGeom prst="rect">
+            <a:avLst/>
+          </a:prstGeom>
+          <a:solidFill>
+            <a:srgbClr val="C9A227"/>
+          </a:solidFill>
+          <a:ln>
+            <a:noFill/>
+          </a:ln>
+          <a:effectLst/>
+        </p:spPr>
+        <p:style>
+          <a:lnRef idx="1">
+            <a:schemeClr val="accent1"/>
+          </a:lnRef>
+          <a:fillRef idx="3">
+            <a:schemeClr val="accent1"/>
+          </a:fillRef>
+          <a:effectRef idx="2">
+            <a:schemeClr val="accent1"/>
+          </a:effectRef>
+          <a:fontRef idx="minor">
+            <a:schemeClr val="lt1"/>
+          </a:fontRef>
+        </p:style>
+        <p:txBody>
+          <a:bodyPr rtlCol="0" anchor="ctr"/>
+          <a:lstStyle/>
+          <a:p>
+            <a:pPr algn="ctr"/>
+          </a:p>
+        </p:txBody>
+      </p:sp>
+      <p:sp>
+        <p:nvSpPr>
+          <p:cNvPr id="4" name="TextBox 3"/>
+          <p:cNvSpPr txBox="1"/>
+          <p:nvPr/>
+        </p:nvSpPr>
+        <p:spPr>
+          <a:xfrm>
+            <a:off x="457200" y="137160"/>
+            <a:ext cx="8351215" cy="731520"/>
+          </a:xfrm>
+          <a:prstGeom prst="rect">
+            <a:avLst/>
+          </a:prstGeom>
+          <a:noFill/>
+        </p:spPr>
+        <p:txBody>
+          <a:bodyPr wrap="square" anchor="ctr">
+            <a:spAutoFit/>
+          </a:bodyPr>
+          <a:lstStyle/>
+          <a:p>
+            <a:pPr algn="l">
+              <a:spcAft>
+                <a:spcPts val="600"/>
+              </a:spcAft>
+            </a:pPr>
+            <a:r>
+              <a:rPr sz="2600" b="1">
+                <a:solidFill>
+                  <a:srgbClr val="FFFFFF"/>
+                </a:solidFill>
+                <a:latin typeface="Calibri"/>
+              </a:rPr>
+              <a:t>Conclusion</a:t>
+            </a:r>
+          </a:p>
+        </p:txBody>
+      </p:sp>
+      <p:sp>
+        <p:nvSpPr>
+          <p:cNvPr id="5" name="TextBox 4"/>
+          <p:cNvSpPr txBox="1"/>
+          <p:nvPr/>
+        </p:nvSpPr>
+        <p:spPr>
+          <a:xfrm>
+            <a:off x="8534095" y="137160"/>
+            <a:ext cx="3200400" cy="731520"/>
+          </a:xfrm>
+          <a:prstGeom prst="rect">
+            <a:avLst/>
+          </a:prstGeom>
+          <a:noFill/>
+        </p:spPr>
+        <p:txBody>
+          <a:bodyPr wrap="square" anchor="ctr">
+            <a:spAutoFit/>
+          </a:bodyPr>
+          <a:lstStyle/>
+          <a:p>
+            <a:pPr algn="r">
+              <a:spcAft>
+                <a:spcPts val="600"/>
+              </a:spcAft>
+            </a:pPr>
+            <a:r>
+              <a:rPr sz="1200" b="1">
+                <a:solidFill>
+                  <a:srgbClr val="C9A227"/>
+                </a:solidFill>
+                <a:latin typeface="Calibri"/>
+              </a:rPr>
+              <a:t>Gold &amp; Silver Predictor</a:t>
+            </a:r>
+          </a:p>
+        </p:txBody>
+      </p:sp>
+      <p:sp>
+        <p:nvSpPr>
+          <p:cNvPr id="6" name="Rectangle 5"/>
+          <p:cNvSpPr/>
+          <p:nvPr/>
+        </p:nvSpPr>
+        <p:spPr>
+          <a:xfrm>
+            <a:off x="0" y="6473952"/>
+            <a:ext cx="12191695" cy="384048"/>
+          </a:xfrm>
+          <a:prstGeom prst="rect">
+            <a:avLst/>
+          </a:prstGeom>
+          <a:solidFill>
+            <a:srgbClr val="1F3864"/>
+          </a:solidFill>
+          <a:ln>
+            <a:noFill/>
+          </a:ln>
+          <a:effectLst/>
+        </p:spPr>
+        <p:style>
+          <a:lnRef idx="1">
+            <a:schemeClr val="accent1"/>
+          </a:lnRef>
+          <a:fillRef idx="3">
+            <a:schemeClr val="accent1"/>
+          </a:fillRef>
+          <a:effectRef idx="2">
+            <a:schemeClr val="accent1"/>
+          </a:effectRef>
+          <a:fontRef idx="minor">
+            <a:schemeClr val="lt1"/>
+          </a:fontRef>
+        </p:style>
+        <p:txBody>
+          <a:bodyPr rtlCol="0" anchor="ctr"/>
+          <a:lstStyle/>
+          <a:p>
+            <a:pPr algn="ctr"/>
+          </a:p>
+        </p:txBody>
+      </p:sp>
+      <p:sp>
+        <p:nvSpPr>
+          <p:cNvPr id="7" name="Rectangle 6"/>
+          <p:cNvSpPr/>
+          <p:nvPr/>
+        </p:nvSpPr>
+        <p:spPr>
+          <a:xfrm>
+            <a:off x="0" y="6473952"/>
+            <a:ext cx="128016" cy="384048"/>
+          </a:xfrm>
+          <a:prstGeom prst="rect">
+            <a:avLst/>
+          </a:prstGeom>
+          <a:solidFill>
+            <a:srgbClr val="C9A227"/>
+          </a:solidFill>
+          <a:ln>
+            <a:noFill/>
+          </a:ln>
+          <a:effectLst/>
+        </p:spPr>
+        <p:style>
+          <a:lnRef idx="1">
+            <a:schemeClr val="accent1"/>
+          </a:lnRef>
+          <a:fillRef idx="3">
+            <a:schemeClr val="accent1"/>
+          </a:fillRef>
+          <a:effectRef idx="2">
+            <a:schemeClr val="accent1"/>
+          </a:effectRef>
+          <a:fontRef idx="minor">
+            <a:schemeClr val="lt1"/>
+          </a:fontRef>
+        </p:style>
+        <p:txBody>
+          <a:bodyPr rtlCol="0" anchor="ctr"/>
+          <a:lstStyle/>
+          <a:p>
+            <a:pPr algn="ctr"/>
+          </a:p>
+        </p:txBody>
+      </p:sp>
+      <p:sp>
+        <p:nvSpPr>
+          <p:cNvPr id="8" name="TextBox 7"/>
+          <p:cNvSpPr txBox="1"/>
+          <p:nvPr/>
+        </p:nvSpPr>
+        <p:spPr>
+          <a:xfrm>
+            <a:off x="274320" y="6473952"/>
+            <a:ext cx="10362895" cy="384048"/>
+          </a:xfrm>
+          <a:prstGeom prst="rect">
+            <a:avLst/>
+          </a:prstGeom>
+          <a:noFill/>
+        </p:spPr>
+        <p:txBody>
+          <a:bodyPr wrap="square" anchor="ctr">
+            <a:spAutoFit/>
+          </a:bodyPr>
+          <a:lstStyle/>
+          <a:p>
+            <a:pPr algn="l">
+              <a:spcAft>
+                <a:spcPts val="600"/>
+              </a:spcAft>
+            </a:pPr>
+            <a:r>
+              <a:rPr sz="900" b="0">
+                <a:solidFill>
+                  <a:srgbClr val="FFFFFF"/>
+                </a:solidFill>
+                <a:latin typeface="Calibri"/>
+              </a:rPr>
+              <a:t>Sanchay Bhardwaj (2300650100104)  |  B.S.A. College of Engineering &amp; Technology, Mathura</a:t>
+            </a:r>
+          </a:p>
+        </p:txBody>
+      </p:sp>
+      <p:sp>
+        <p:nvSpPr>
+          <p:cNvPr id="9" name="TextBox 8"/>
+          <p:cNvSpPr txBox="1"/>
+          <p:nvPr/>
+        </p:nvSpPr>
+        <p:spPr>
+          <a:xfrm>
+            <a:off x="10728655" y="6473952"/>
+            <a:ext cx="1188720" cy="384048"/>
+          </a:xfrm>
+          <a:prstGeom prst="rect">
+            <a:avLst/>
+          </a:prstGeom>
+          <a:noFill/>
+        </p:spPr>
+        <p:txBody>
+          <a:bodyPr wrap="square" anchor="ctr">
+            <a:spAutoFit/>
+          </a:bodyPr>
+          <a:lstStyle/>
+          <a:p>
+            <a:pPr algn="r">
+              <a:spcAft>
+                <a:spcPts val="600"/>
+              </a:spcAft>
+            </a:pPr>
+            <a:r>
+              <a:rPr sz="900" b="1">
+                <a:solidFill>
+                  <a:srgbClr val="C9A227"/>
+                </a:solidFill>
+                <a:latin typeface="Calibri"/>
+              </a:rPr>
+              <a:t>Slide 13</a:t>
+            </a:r>
+          </a:p>
+        </p:txBody>
+      </p:sp>
+      <p:sp>
+        <p:nvSpPr>
+          <p:cNvPr id="10" name="Rectangle 9"/>
+          <p:cNvSpPr/>
+          <p:nvPr/>
+        </p:nvSpPr>
+        <p:spPr>
+          <a:xfrm>
+            <a:off x="502920" y="1554480"/>
+            <a:ext cx="82296" cy="4297680"/>
+          </a:xfrm>
+          <a:prstGeom prst="rect">
+            <a:avLst/>
+          </a:prstGeom>
+          <a:solidFill>
+            <a:srgbClr val="C9A227"/>
+          </a:solidFill>
+          <a:ln>
+            <a:noFill/>
+          </a:ln>
+          <a:effectLst/>
+        </p:spPr>
+        <p:style>
+          <a:lnRef idx="1">
+            <a:schemeClr val="accent1"/>
+          </a:lnRef>
+          <a:fillRef idx="3">
+            <a:schemeClr val="accent1"/>
+          </a:fillRef>
+          <a:effectRef idx="2">
+            <a:schemeClr val="accent1"/>
+          </a:effectRef>
+          <a:fontRef idx="minor">
+            <a:schemeClr val="lt1"/>
+          </a:fontRef>
+        </p:style>
+        <p:txBody>
+          <a:bodyPr rtlCol="0" anchor="ctr"/>
+          <a:lstStyle/>
+          <a:p>
+            <a:pPr algn="ctr"/>
+          </a:p>
+        </p:txBody>
+      </p:sp>
+      <p:sp>
+        <p:nvSpPr>
+          <p:cNvPr id="11" name="TextBox 10"/>
+          <p:cNvSpPr txBox="1"/>
+          <p:nvPr/>
+        </p:nvSpPr>
+        <p:spPr>
+          <a:xfrm>
+            <a:off x="868680" y="1371600"/>
+            <a:ext cx="10728655" cy="4663440"/>
+          </a:xfrm>
+          <a:prstGeom prst="rect">
+            <a:avLst/>
+          </a:prstGeom>
+          <a:noFill/>
+        </p:spPr>
+        <p:txBody>
+          <a:bodyPr wrap="square" anchor="ctr">
+            <a:spAutoFit/>
+          </a:bodyPr>
+          <a:lstStyle/>
+          <a:p>
+            <a:pPr algn="l">
+              <a:spcAft>
+                <a:spcPts val="1800"/>
+              </a:spcAft>
+            </a:pPr>
+            <a:r>
+              <a:rPr sz="1900" b="0">
+                <a:solidFill>
+                  <a:srgbClr val="222222"/>
+                </a:solidFill>
+                <a:latin typeface="Calibri"/>
+              </a:rPr>
+              <a:t>•   Random Forest gave the lowest error on both metals and beat the naive baseline.</a:t>
+            </a:r>
+          </a:p>
+          <a:p>
+            <a:pPr algn="l">
+              <a:spcAft>
+                <a:spcPts val="1800"/>
+              </a:spcAft>
+            </a:pPr>
+            <a:r>
+              <a:rPr sz="1900" b="0">
+                <a:solidFill>
+                  <a:srgbClr val="222222"/>
+                </a:solidFill>
+                <a:latin typeface="Calibri"/>
+              </a:rPr>
+              <a:t>•   Predicting returns instead of raw prices made the models reliable on a strongly trending series.</a:t>
+            </a:r>
+          </a:p>
+          <a:p>
+            <a:pPr algn="l">
+              <a:spcAft>
+                <a:spcPts val="1800"/>
+              </a:spcAft>
+            </a:pPr>
+            <a:r>
+              <a:rPr sz="1900" b="0">
+                <a:solidFill>
+                  <a:srgbClr val="222222"/>
+                </a:solidFill>
+                <a:latin typeface="Calibri"/>
+              </a:rPr>
+              <a:t>•   Live prices, rupee conversion and the forecast are combined in one self-explanatory dashboard.</a:t>
+            </a:r>
+          </a:p>
+          <a:p>
+            <a:pPr algn="l">
+              <a:spcAft>
+                <a:spcPts val="1800"/>
+              </a:spcAft>
+            </a:pPr>
+            <a:r>
+              <a:rPr sz="1900" b="0">
+                <a:solidFill>
+                  <a:srgbClr val="222222"/>
+                </a:solidFill>
+                <a:latin typeface="Calibri"/>
+              </a:rPr>
+              <a:t>•   The project demonstrates a complete Machine Learning pipeline - data, model, API, interface.</a:t>
+            </a:r>
+          </a:p>
+        </p:txBody>
+      </p:sp>
+    </p:spTree>
+  </p:cSld>
+  <p:clrMapOvr>
+    <a:masterClrMapping/>
+  </p:clrMapOvr>
+</p:sld>
+</file>
+
+<file path=ppt/slides/slide14.xml><?xml version="1.0" encoding="utf-8"?>
+<p:sld xmlns:a="http://schemas.openxmlformats.org/drawingml/2006/main" xmlns:p="http://schemas.openxmlformats.org/presentationml/2006/main" xmlns:r="http://schemas.openxmlformats.org/officeDocument/2006/relationships">
+  <p:cSld>
+    <p:spTree>
+      <p:nvGrpSpPr>
+        <p:cNvPr id="1" name=""/>
+        <p:cNvGrpSpPr/>
+        <p:nvPr/>
+      </p:nvGrpSpPr>
+      <p:grpSpPr/>
+      <p:sp>
+        <p:nvSpPr>
+          <p:cNvPr id="2" name="Rectangle 1"/>
+          <p:cNvSpPr/>
+          <p:nvPr/>
+        </p:nvSpPr>
+        <p:spPr>
+          <a:xfrm>
+            <a:off x="0" y="0"/>
+            <a:ext cx="12191695" cy="960120"/>
+          </a:xfrm>
+          <a:prstGeom prst="rect">
+            <a:avLst/>
+          </a:prstGeom>
+          <a:solidFill>
+            <a:srgbClr val="1F3864"/>
+          </a:solidFill>
+          <a:ln>
+            <a:noFill/>
+          </a:ln>
+          <a:effectLst/>
+        </p:spPr>
+        <p:style>
+          <a:lnRef idx="1">
+            <a:schemeClr val="accent1"/>
+          </a:lnRef>
+          <a:fillRef idx="3">
+            <a:schemeClr val="accent1"/>
+          </a:fillRef>
+          <a:effectRef idx="2">
+            <a:schemeClr val="accent1"/>
+          </a:effectRef>
+          <a:fontRef idx="minor">
+            <a:schemeClr val="lt1"/>
+          </a:fontRef>
+        </p:style>
+        <p:txBody>
+          <a:bodyPr rtlCol="0" anchor="ctr"/>
+          <a:lstStyle/>
+          <a:p>
+            <a:pPr algn="ctr"/>
+          </a:p>
+        </p:txBody>
+      </p:sp>
+      <p:sp>
+        <p:nvSpPr>
+          <p:cNvPr id="3" name="Rectangle 2"/>
+          <p:cNvSpPr/>
+          <p:nvPr/>
+        </p:nvSpPr>
+        <p:spPr>
+          <a:xfrm>
+            <a:off x="0" y="960120"/>
+            <a:ext cx="12191695" cy="64008"/>
+          </a:xfrm>
+          <a:prstGeom prst="rect">
+            <a:avLst/>
+          </a:prstGeom>
+          <a:solidFill>
+            <a:srgbClr val="C9A227"/>
+          </a:solidFill>
+          <a:ln>
+            <a:noFill/>
+          </a:ln>
+          <a:effectLst/>
+        </p:spPr>
+        <p:style>
+          <a:lnRef idx="1">
+            <a:schemeClr val="accent1"/>
+          </a:lnRef>
+          <a:fillRef idx="3">
+            <a:schemeClr val="accent1"/>
+          </a:fillRef>
+          <a:effectRef idx="2">
+            <a:schemeClr val="accent1"/>
+          </a:effectRef>
+          <a:fontRef idx="minor">
+            <a:schemeClr val="lt1"/>
+          </a:fontRef>
+        </p:style>
+        <p:txBody>
+          <a:bodyPr rtlCol="0" anchor="ctr"/>
+          <a:lstStyle/>
+          <a:p>
+            <a:pPr algn="ctr"/>
+          </a:p>
+        </p:txBody>
+      </p:sp>
+      <p:sp>
+        <p:nvSpPr>
+          <p:cNvPr id="4" name="TextBox 3"/>
+          <p:cNvSpPr txBox="1"/>
+          <p:nvPr/>
+        </p:nvSpPr>
+        <p:spPr>
+          <a:xfrm>
+            <a:off x="457200" y="137160"/>
+            <a:ext cx="8351215" cy="731520"/>
+          </a:xfrm>
+          <a:prstGeom prst="rect">
+            <a:avLst/>
+          </a:prstGeom>
+          <a:noFill/>
+        </p:spPr>
+        <p:txBody>
+          <a:bodyPr wrap="square" anchor="ctr">
+            <a:spAutoFit/>
+          </a:bodyPr>
+          <a:lstStyle/>
+          <a:p>
+            <a:pPr algn="l">
+              <a:spcAft>
+                <a:spcPts val="600"/>
+              </a:spcAft>
+            </a:pPr>
+            <a:r>
+              <a:rPr sz="2600" b="1">
+                <a:solidFill>
+                  <a:srgbClr val="FFFFFF"/>
+                </a:solidFill>
+                <a:latin typeface="Calibri"/>
+              </a:rPr>
+              <a:t>Future Scope</a:t>
+            </a:r>
+          </a:p>
+        </p:txBody>
+      </p:sp>
+      <p:sp>
+        <p:nvSpPr>
+          <p:cNvPr id="5" name="TextBox 4"/>
+          <p:cNvSpPr txBox="1"/>
+          <p:nvPr/>
+        </p:nvSpPr>
+        <p:spPr>
+          <a:xfrm>
+            <a:off x="8534095" y="137160"/>
+            <a:ext cx="3200400" cy="731520"/>
+          </a:xfrm>
+          <a:prstGeom prst="rect">
+            <a:avLst/>
+          </a:prstGeom>
+          <a:noFill/>
+        </p:spPr>
+        <p:txBody>
+          <a:bodyPr wrap="square" anchor="ctr">
+            <a:spAutoFit/>
+          </a:bodyPr>
+          <a:lstStyle/>
+          <a:p>
+            <a:pPr algn="r">
+              <a:spcAft>
+                <a:spcPts val="600"/>
+              </a:spcAft>
+            </a:pPr>
+            <a:r>
+              <a:rPr sz="1200" b="1">
+                <a:solidFill>
+                  <a:srgbClr val="C9A227"/>
+                </a:solidFill>
+                <a:latin typeface="Calibri"/>
+              </a:rPr>
+              <a:t>Gold &amp; Silver Predictor</a:t>
+            </a:r>
+          </a:p>
+        </p:txBody>
+      </p:sp>
+      <p:sp>
+        <p:nvSpPr>
+          <p:cNvPr id="6" name="Rectangle 5"/>
+          <p:cNvSpPr/>
+          <p:nvPr/>
+        </p:nvSpPr>
+        <p:spPr>
+          <a:xfrm>
+            <a:off x="0" y="6473952"/>
+            <a:ext cx="12191695" cy="384048"/>
+          </a:xfrm>
+          <a:prstGeom prst="rect">
+            <a:avLst/>
+          </a:prstGeom>
+          <a:solidFill>
+            <a:srgbClr val="1F3864"/>
+          </a:solidFill>
+          <a:ln>
+            <a:noFill/>
+          </a:ln>
+          <a:effectLst/>
+        </p:spPr>
+        <p:style>
+          <a:lnRef idx="1">
+            <a:schemeClr val="accent1"/>
+          </a:lnRef>
+          <a:fillRef idx="3">
+            <a:schemeClr val="accent1"/>
+          </a:fillRef>
+          <a:effectRef idx="2">
+            <a:schemeClr val="accent1"/>
+          </a:effectRef>
+          <a:fontRef idx="minor">
+            <a:schemeClr val="lt1"/>
+          </a:fontRef>
+        </p:style>
+        <p:txBody>
+          <a:bodyPr rtlCol="0" anchor="ctr"/>
+          <a:lstStyle/>
+          <a:p>
+            <a:pPr algn="ctr"/>
+          </a:p>
+        </p:txBody>
+      </p:sp>
+      <p:sp>
+        <p:nvSpPr>
+          <p:cNvPr id="7" name="Rectangle 6"/>
+          <p:cNvSpPr/>
+          <p:nvPr/>
+        </p:nvSpPr>
+        <p:spPr>
+          <a:xfrm>
+            <a:off x="0" y="6473952"/>
+            <a:ext cx="128016" cy="384048"/>
+          </a:xfrm>
+          <a:prstGeom prst="rect">
+            <a:avLst/>
+          </a:prstGeom>
+          <a:solidFill>
+            <a:srgbClr val="C9A227"/>
+          </a:solidFill>
+          <a:ln>
+            <a:noFill/>
+          </a:ln>
+          <a:effectLst/>
+        </p:spPr>
+        <p:style>
+          <a:lnRef idx="1">
+            <a:schemeClr val="accent1"/>
+          </a:lnRef>
+          <a:fillRef idx="3">
+            <a:schemeClr val="accent1"/>
+          </a:fillRef>
+          <a:effectRef idx="2">
+            <a:schemeClr val="accent1"/>
+          </a:effectRef>
+          <a:fontRef idx="minor">
+            <a:schemeClr val="lt1"/>
+          </a:fontRef>
+        </p:style>
+        <p:txBody>
+          <a:bodyPr rtlCol="0" anchor="ctr"/>
+          <a:lstStyle/>
+          <a:p>
+            <a:pPr algn="ctr"/>
+          </a:p>
+        </p:txBody>
+      </p:sp>
+      <p:sp>
+        <p:nvSpPr>
+          <p:cNvPr id="8" name="TextBox 7"/>
+          <p:cNvSpPr txBox="1"/>
+          <p:nvPr/>
+        </p:nvSpPr>
+        <p:spPr>
+          <a:xfrm>
+            <a:off x="274320" y="6473952"/>
+            <a:ext cx="10362895" cy="384048"/>
+          </a:xfrm>
+          <a:prstGeom prst="rect">
+            <a:avLst/>
+          </a:prstGeom>
+          <a:noFill/>
+        </p:spPr>
+        <p:txBody>
+          <a:bodyPr wrap="square" anchor="ctr">
+            <a:spAutoFit/>
+          </a:bodyPr>
+          <a:lstStyle/>
+          <a:p>
+            <a:pPr algn="l">
+              <a:spcAft>
+                <a:spcPts val="600"/>
+              </a:spcAft>
+            </a:pPr>
+            <a:r>
+              <a:rPr sz="900" b="0">
+                <a:solidFill>
+                  <a:srgbClr val="FFFFFF"/>
+                </a:solidFill>
+                <a:latin typeface="Calibri"/>
+              </a:rPr>
+              <a:t>Sanchay Bhardwaj (2300650100104)  |  B.S.A. College of Engineering &amp; Technology, Mathura</a:t>
+            </a:r>
+          </a:p>
+        </p:txBody>
+      </p:sp>
+      <p:sp>
+        <p:nvSpPr>
+          <p:cNvPr id="9" name="TextBox 8"/>
+          <p:cNvSpPr txBox="1"/>
+          <p:nvPr/>
+        </p:nvSpPr>
+        <p:spPr>
+          <a:xfrm>
+            <a:off x="10728655" y="6473952"/>
+            <a:ext cx="1188720" cy="384048"/>
+          </a:xfrm>
+          <a:prstGeom prst="rect">
+            <a:avLst/>
+          </a:prstGeom>
+          <a:noFill/>
+        </p:spPr>
+        <p:txBody>
+          <a:bodyPr wrap="square" anchor="ctr">
+            <a:spAutoFit/>
+          </a:bodyPr>
+          <a:lstStyle/>
+          <a:p>
+            <a:pPr algn="r">
+              <a:spcAft>
+                <a:spcPts val="600"/>
+              </a:spcAft>
+            </a:pPr>
+            <a:r>
+              <a:rPr sz="900" b="1">
+                <a:solidFill>
+                  <a:srgbClr val="C9A227"/>
+                </a:solidFill>
+                <a:latin typeface="Calibri"/>
+              </a:rPr>
+              <a:t>Slide 14</a:t>
+            </a:r>
+          </a:p>
+        </p:txBody>
+      </p:sp>
+      <p:sp>
+        <p:nvSpPr>
+          <p:cNvPr id="10" name="Rectangle 9"/>
+          <p:cNvSpPr/>
+          <p:nvPr/>
+        </p:nvSpPr>
+        <p:spPr>
+          <a:xfrm>
+            <a:off x="502920" y="1554480"/>
+            <a:ext cx="82296" cy="4297680"/>
+          </a:xfrm>
+          <a:prstGeom prst="rect">
+            <a:avLst/>
+          </a:prstGeom>
+          <a:solidFill>
+            <a:srgbClr val="C9A227"/>
+          </a:solidFill>
+          <a:ln>
+            <a:noFill/>
+          </a:ln>
+          <a:effectLst/>
+        </p:spPr>
+        <p:style>
+          <a:lnRef idx="1">
+            <a:schemeClr val="accent1"/>
+          </a:lnRef>
+          <a:fillRef idx="3">
+            <a:schemeClr val="accent1"/>
+          </a:fillRef>
+          <a:effectRef idx="2">
+            <a:schemeClr val="accent1"/>
+          </a:effectRef>
+          <a:fontRef idx="minor">
+            <a:schemeClr val="lt1"/>
+          </a:fontRef>
+        </p:style>
+        <p:txBody>
+          <a:bodyPr rtlCol="0" anchor="ctr"/>
+          <a:lstStyle/>
+          <a:p>
+            <a:pPr algn="ctr"/>
+          </a:p>
+        </p:txBody>
+      </p:sp>
+      <p:sp>
+        <p:nvSpPr>
+          <p:cNvPr id="11" name="TextBox 10"/>
+          <p:cNvSpPr txBox="1"/>
+          <p:nvPr/>
+        </p:nvSpPr>
+        <p:spPr>
+          <a:xfrm>
+            <a:off x="868680" y="1371600"/>
+            <a:ext cx="10728655" cy="4663440"/>
+          </a:xfrm>
+          <a:prstGeom prst="rect">
+            <a:avLst/>
+          </a:prstGeom>
+          <a:noFill/>
+        </p:spPr>
+        <p:txBody>
+          <a:bodyPr wrap="square" anchor="ctr">
+            <a:spAutoFit/>
+          </a:bodyPr>
+          <a:lstStyle/>
+          <a:p>
+            <a:pPr algn="l">
+              <a:spcAft>
+                <a:spcPts val="1800"/>
+              </a:spcAft>
+            </a:pPr>
+            <a:r>
+              <a:rPr sz="1900" b="0">
+                <a:solidFill>
+                  <a:srgbClr val="222222"/>
+                </a:solidFill>
+                <a:latin typeface="Calibri"/>
+              </a:rPr>
+              <a:t>•   Add real economic features such as inflation, the dollar index and interest rates.</a:t>
+            </a:r>
+          </a:p>
+          <a:p>
+            <a:pPr algn="l">
+              <a:spcAft>
+                <a:spcPts val="1800"/>
+              </a:spcAft>
+            </a:pPr>
+            <a:r>
+              <a:rPr sz="1900" b="0">
+                <a:solidFill>
+                  <a:srgbClr val="222222"/>
+                </a:solidFill>
+                <a:latin typeface="Calibri"/>
+              </a:rPr>
+              <a:t>•   Try deep-learning time-series models like LSTM for longer horizons.</a:t>
+            </a:r>
+          </a:p>
+          <a:p>
+            <a:pPr algn="l">
+              <a:spcAft>
+                <a:spcPts val="1800"/>
+              </a:spcAft>
+            </a:pPr>
+            <a:r>
+              <a:rPr sz="1900" b="0">
+                <a:solidFill>
+                  <a:srgbClr val="222222"/>
+                </a:solidFill>
+                <a:latin typeface="Calibri"/>
+              </a:rPr>
+              <a:t>•   Show a confidence range around the forecast instead of a single number.</a:t>
+            </a:r>
+          </a:p>
+          <a:p>
+            <a:pPr algn="l">
+              <a:spcAft>
+                <a:spcPts val="1800"/>
+              </a:spcAft>
+            </a:pPr>
+            <a:r>
+              <a:rPr sz="1900" b="0">
+                <a:solidFill>
+                  <a:srgbClr val="222222"/>
+                </a:solidFill>
+                <a:latin typeface="Calibri"/>
+              </a:rPr>
+              <a:t>•   Extend to other metals and to jewelers' rate cards used in the local market.</a:t>
+            </a:r>
+          </a:p>
+          <a:p>
+            <a:pPr algn="l">
+              <a:spcAft>
+                <a:spcPts val="1800"/>
+              </a:spcAft>
+            </a:pPr>
+            <a:r>
+              <a:rPr sz="1900" b="0">
+                <a:solidFill>
+                  <a:srgbClr val="222222"/>
+                </a:solidFill>
+                <a:latin typeface="Calibri"/>
+              </a:rPr>
+              <a:t>•   Publish the dashboard online with a scheduled daily data refresh.</a:t>
+            </a:r>
+          </a:p>
+        </p:txBody>
+      </p:sp>
+    </p:spTree>
+  </p:cSld>
+  <p:clrMapOvr>
+    <a:masterClrMapping/>
+  </p:clrMapOvr>
+</p:sld>
+</file>
+
+<file path=ppt/slides/slide15.xml><?xml version="1.0" encoding="utf-8"?>
+<p:sld xmlns:a="http://schemas.openxmlformats.org/drawingml/2006/main" xmlns:p="http://schemas.openxmlformats.org/presentationml/2006/main" xmlns:r="http://schemas.openxmlformats.org/officeDocument/2006/relationships">
+  <p:cSld>
+    <p:spTree>
+      <p:nvGrpSpPr>
+        <p:cNvPr id="1" name=""/>
+        <p:cNvGrpSpPr/>
+        <p:nvPr/>
+      </p:nvGrpSpPr>
+      <p:grpSpPr/>
+      <p:sp>
+        <p:nvSpPr>
+          <p:cNvPr id="2" name="Rectangle 1"/>
+          <p:cNvSpPr/>
+          <p:nvPr/>
+        </p:nvSpPr>
+        <p:spPr>
+          <a:xfrm>
+            <a:off x="0" y="0"/>
             <a:ext cx="12191695" cy="6858000"/>
           </a:xfrm>
           <a:prstGeom prst="rect">
@@ -5180,7 +6024,7 @@
                 </a:solidFill>
                 <a:latin typeface="Calibri"/>
               </a:rPr>
-              <a:t>Gold Price Prediction</a:t>
+              <a:t>Gold &amp; Silver Predictor</a:t>
             </a:r>
           </a:p>
         </p:txBody>
@@ -5419,65 +6263,81 @@
           <a:p>
             <a:pPr algn="l">
               <a:spcAft>
-                <a:spcPts val="2200"/>
-              </a:spcAft>
-            </a:pPr>
-            <a:r>
-              <a:rPr sz="2000" b="0">
+                <a:spcPts val="1800"/>
+              </a:spcAft>
+            </a:pPr>
+            <a:r>
+              <a:rPr sz="1900" b="0">
                 <a:solidFill>
                   <a:srgbClr val="222222"/>
                 </a:solidFill>
                 <a:latin typeface="Calibri"/>
               </a:rPr>
-              <a:t>•   Gold is a globally traded precious metal and a traditional safe-haven asset.</a:t>
+              <a:t>•   Gold and silver are the two most tracked precious metals, priced in US dollars per troy ounce.</a:t>
             </a:r>
           </a:p>
           <a:p>
             <a:pPr algn="l">
               <a:spcAft>
-                <a:spcPts val="2200"/>
-              </a:spcAft>
-            </a:pPr>
-            <a:r>
-              <a:rPr sz="2000" b="0">
+                <a:spcPts val="1800"/>
+              </a:spcAft>
+            </a:pPr>
+            <a:r>
+              <a:rPr sz="1900" b="0">
                 <a:solidFill>
                   <a:srgbClr val="222222"/>
                 </a:solidFill>
                 <a:latin typeface="Calibri"/>
               </a:rPr>
-              <a:t>•   Its price is affected by demand, inflation, currency value and market sentiment.</a:t>
+              <a:t>•   Their prices move with demand, inflation, the dollar and global market sentiment.</a:t>
             </a:r>
           </a:p>
           <a:p>
             <a:pPr algn="l">
               <a:spcAft>
-                <a:spcPts val="2200"/>
-              </a:spcAft>
-            </a:pPr>
-            <a:r>
-              <a:rPr sz="2000" b="0">
+                <a:spcPts val="1800"/>
+              </a:spcAft>
+            </a:pPr>
+            <a:r>
+              <a:rPr sz="1900" b="0">
                 <a:solidFill>
                   <a:srgbClr val="222222"/>
                 </a:solidFill>
                 <a:latin typeface="Calibri"/>
               </a:rPr>
-              <a:t>•   Being able to forecast gold prices helps investors and analysts take better decisions.</a:t>
+              <a:t>•   This project fetches the LIVE price of both metals and converts it into Indian Rupees per gram.</a:t>
             </a:r>
           </a:p>
           <a:p>
             <a:pPr algn="l">
               <a:spcAft>
-                <a:spcPts val="2200"/>
-              </a:spcAft>
-            </a:pPr>
-            <a:r>
-              <a:rPr sz="2000" b="0">
+                <a:spcPts val="1800"/>
+              </a:spcAft>
+            </a:pPr>
+            <a:r>
+              <a:rPr sz="1900" b="0">
                 <a:solidFill>
                   <a:srgbClr val="222222"/>
                 </a:solidFill>
                 <a:latin typeface="Calibri"/>
               </a:rPr>
-              <a:t>•   This project builds a Machine Learning model that predicts the monthly price of gold.</a:t>
+              <a:t>•   A Machine Learning model then forecasts the price for the next 12 months.</a:t>
+            </a:r>
+          </a:p>
+          <a:p>
+            <a:pPr algn="l">
+              <a:spcAft>
+                <a:spcPts val="1800"/>
+              </a:spcAft>
+            </a:pPr>
+            <a:r>
+              <a:rPr sz="1900" b="0">
+                <a:solidFill>
+                  <a:srgbClr val="222222"/>
+                </a:solidFill>
+                <a:latin typeface="Calibri"/>
+              </a:rPr>
+              <a:t>•   Everything is shown on one web dashboard, so the numbers can be read without any training.</a:t>
             </a:r>
           </a:p>
         </p:txBody>
@@ -5661,7 +6521,7 @@
                 </a:solidFill>
                 <a:latin typeface="Calibri"/>
               </a:rPr>
-              <a:t>Gold Price Prediction</a:t>
+              <a:t>Gold &amp; Silver Predictor</a:t>
             </a:r>
           </a:p>
         </p:txBody>
@@ -5900,27 +6760,27 @@
           <a:p>
             <a:pPr algn="l">
               <a:spcAft>
-                <a:spcPts val="2200"/>
-              </a:spcAft>
-            </a:pPr>
-            <a:r>
-              <a:rPr sz="2000" b="0">
+                <a:spcPts val="1800"/>
+              </a:spcAft>
+            </a:pPr>
+            <a:r>
+              <a:rPr sz="1900" b="0">
                 <a:solidFill>
                   <a:srgbClr val="222222"/>
                 </a:solidFill>
                 <a:latin typeface="Calibri"/>
               </a:rPr>
-              <a:t>•   Given the historical monthly price of gold, predict its price for the coming months.</a:t>
+              <a:t>•   Given the historical monthly price of gold and silver, predict their price for the coming months.</a:t>
             </a:r>
           </a:p>
           <a:p>
             <a:pPr algn="l">
               <a:spcAft>
-                <a:spcPts val="2200"/>
-              </a:spcAft>
-            </a:pPr>
-            <a:r>
-              <a:rPr sz="2000" b="0">
+                <a:spcPts val="1800"/>
+              </a:spcAft>
+            </a:pPr>
+            <a:r>
+              <a:rPr sz="1900" b="0">
                 <a:solidFill>
                   <a:srgbClr val="222222"/>
                 </a:solidFill>
@@ -5932,33 +6792,33 @@
           <a:p>
             <a:pPr algn="l">
               <a:spcAft>
-                <a:spcPts val="2200"/>
-              </a:spcAft>
-            </a:pPr>
-            <a:r>
-              <a:rPr sz="2000" b="0">
+                <a:spcPts val="1800"/>
+              </a:spcAft>
+            </a:pPr>
+            <a:r>
+              <a:rPr sz="1900" b="0">
                 <a:solidFill>
                   <a:srgbClr val="222222"/>
                 </a:solidFill>
                 <a:latin typeface="Calibri"/>
               </a:rPr>
-              <a:t>•   Multiple models are trained and the most accurate one is kept for prediction.</a:t>
+              <a:t>•   Several models are trained, scored on data they have never seen, and the best one is kept.</a:t>
             </a:r>
           </a:p>
           <a:p>
             <a:pPr algn="l">
               <a:spcAft>
-                <a:spcPts val="2200"/>
-              </a:spcAft>
-            </a:pPr>
-            <a:r>
-              <a:rPr sz="2000" b="0">
+                <a:spcPts val="1800"/>
+              </a:spcAft>
+            </a:pPr>
+            <a:r>
+              <a:rPr sz="1900" b="0">
                 <a:solidFill>
                   <a:srgbClr val="222222"/>
                 </a:solidFill>
                 <a:latin typeface="Calibri"/>
               </a:rPr>
-              <a:t>•   The winning model is then wrapped in a simple desktop application.</a:t>
+              <a:t>•   The winning model is connected to a live price feed and presented on a dashboard in rupees.</a:t>
             </a:r>
           </a:p>
         </p:txBody>
@@ -6142,7 +7002,7 @@
                 </a:solidFill>
                 <a:latin typeface="Calibri"/>
               </a:rPr>
-              <a:t>Gold Price Prediction</a:t>
+              <a:t>Gold &amp; Silver Predictor</a:t>
             </a:r>
           </a:p>
         </p:txBody>
@@ -6381,81 +7241,81 @@
           <a:p>
             <a:pPr algn="l">
               <a:spcAft>
-                <a:spcPts val="2200"/>
-              </a:spcAft>
-            </a:pPr>
-            <a:r>
-              <a:rPr sz="2000" b="0">
+                <a:spcPts val="1800"/>
+              </a:spcAft>
+            </a:pPr>
+            <a:r>
+              <a:rPr sz="1900" b="0">
                 <a:solidFill>
                   <a:srgbClr val="222222"/>
                 </a:solidFill>
                 <a:latin typeface="Calibri"/>
               </a:rPr>
-              <a:t>•   Prepare a clean monthly gold price dataset for the years 2000 to 2024.</a:t>
+              <a:t>•   Build a clean monthly price dataset for gold and silver from the year 2000 up to today.</a:t>
             </a:r>
           </a:p>
           <a:p>
             <a:pPr algn="l">
               <a:spcAft>
-                <a:spcPts val="2200"/>
-              </a:spcAft>
-            </a:pPr>
-            <a:r>
-              <a:rPr sz="2000" b="0">
+                <a:spcPts val="1800"/>
+              </a:spcAft>
+            </a:pPr>
+            <a:r>
+              <a:rPr sz="1900" b="0">
                 <a:solidFill>
                   <a:srgbClr val="222222"/>
                 </a:solidFill>
                 <a:latin typeface="Calibri"/>
               </a:rPr>
-              <a:t>•   Engineer features that capture the trend and the short-term momentum of prices.</a:t>
+              <a:t>•   Read the live price of both metals and the US dollar to rupee rate from public APIs.</a:t>
             </a:r>
           </a:p>
           <a:p>
             <a:pPr algn="l">
               <a:spcAft>
-                <a:spcPts val="2200"/>
-              </a:spcAft>
-            </a:pPr>
-            <a:r>
-              <a:rPr sz="2000" b="0">
+                <a:spcPts val="1800"/>
+              </a:spcAft>
+            </a:pPr>
+            <a:r>
+              <a:rPr sz="1900" b="0">
                 <a:solidFill>
                   <a:srgbClr val="222222"/>
                 </a:solidFill>
                 <a:latin typeface="Calibri"/>
               </a:rPr>
-              <a:t>•   Train and compare RandomForest, Linear Regression and Ridge models.</a:t>
+              <a:t>•   Engineer features that capture short-term momentum instead of raw price levels.</a:t>
             </a:r>
           </a:p>
           <a:p>
             <a:pPr algn="l">
               <a:spcAft>
-                <a:spcPts val="2200"/>
-              </a:spcAft>
-            </a:pPr>
-            <a:r>
-              <a:rPr sz="2000" b="0">
+                <a:spcPts val="1800"/>
+              </a:spcAft>
+            </a:pPr>
+            <a:r>
+              <a:rPr sz="1900" b="0">
                 <a:solidFill>
                   <a:srgbClr val="222222"/>
                 </a:solidFill>
                 <a:latin typeface="Calibri"/>
               </a:rPr>
-              <a:t>•   Measure accuracy using MAE, RMSE and R-squared against a naive baseline.</a:t>
+              <a:t>•   Compare Random Forest, Linear Regression and Ridge against a naive baseline.</a:t>
             </a:r>
           </a:p>
           <a:p>
             <a:pPr algn="l">
               <a:spcAft>
-                <a:spcPts val="2200"/>
-              </a:spcAft>
-            </a:pPr>
-            <a:r>
-              <a:rPr sz="2000" b="0">
+                <a:spcPts val="1800"/>
+              </a:spcAft>
+            </a:pPr>
+            <a:r>
+              <a:rPr sz="1900" b="0">
                 <a:solidFill>
                   <a:srgbClr val="222222"/>
                 </a:solidFill>
                 <a:latin typeface="Calibri"/>
               </a:rPr>
-              <a:t>•   Provide a simple desktop GUI so anyone can run a prediction.</a:t>
+              <a:t>•   Deliver an attractive dashboard showing present and future prices in Indian Rupees.</a:t>
             </a:r>
           </a:p>
         </p:txBody>
@@ -6600,7 +7460,7 @@
                 </a:solidFill>
                 <a:latin typeface="Calibri"/>
               </a:rPr>
-              <a:t>Dataset</a:t>
+              <a:t>Live Data Sources</a:t>
             </a:r>
           </a:p>
         </p:txBody>
@@ -6639,7 +7499,7 @@
                 </a:solidFill>
                 <a:latin typeface="Calibri"/>
               </a:rPr>
-              <a:t>Gold Price Prediction</a:t>
+              <a:t>Gold &amp; Silver Predictor</a:t>
             </a:r>
           </a:p>
         </p:txBody>
@@ -6878,65 +7738,81 @@
           <a:p>
             <a:pPr algn="l">
               <a:spcAft>
-                <a:spcPts val="2200"/>
-              </a:spcAft>
-            </a:pPr>
-            <a:r>
-              <a:rPr sz="2000" b="0">
+                <a:spcPts val="1800"/>
+              </a:spcAft>
+            </a:pPr>
+            <a:r>
+              <a:rPr sz="1900" b="0">
                 <a:solidFill>
                   <a:srgbClr val="222222"/>
                 </a:solidFill>
                 <a:latin typeface="Calibri"/>
               </a:rPr>
-              <a:t>•   Monthly gold price in USD per troy ounce, from 2000 to 2024 (300 records).</a:t>
+              <a:t>•   api.gold-api.com/price/XAU  -  live gold price in US dollars per troy ounce.</a:t>
             </a:r>
           </a:p>
           <a:p>
             <a:pPr algn="l">
               <a:spcAft>
-                <a:spcPts val="2200"/>
-              </a:spcAft>
-            </a:pPr>
-            <a:r>
-              <a:rPr sz="2000" b="0">
+                <a:spcPts val="1800"/>
+              </a:spcAft>
+            </a:pPr>
+            <a:r>
+              <a:rPr sz="1900" b="0">
                 <a:solidFill>
                   <a:srgbClr val="222222"/>
                 </a:solidFill>
                 <a:latin typeface="Calibri"/>
               </a:rPr>
-              <a:t>•   Columns in the file: Date, Year, Month and Price.</a:t>
+              <a:t>•   api.gold-api.com/price/XAG  -  live silver price in US dollars per troy ounce.</a:t>
             </a:r>
           </a:p>
           <a:p>
             <a:pPr algn="l">
               <a:spcAft>
-                <a:spcPts val="2200"/>
-              </a:spcAft>
-            </a:pPr>
-            <a:r>
-              <a:rPr sz="2000" b="0">
+                <a:spcPts val="1800"/>
+              </a:spcAft>
+            </a:pPr>
+            <a:r>
+              <a:rPr sz="1900" b="0">
                 <a:solidFill>
                   <a:srgbClr val="222222"/>
                 </a:solidFill>
                 <a:latin typeface="Calibri"/>
               </a:rPr>
-              <a:t>•   Built from public annual-average anchors with a small momentum effect added.</a:t>
+              <a:t>•   open.er-api.com  -  today's US dollar to Indian rupee exchange rate.</a:t>
             </a:r>
           </a:p>
           <a:p>
             <a:pPr algn="l">
               <a:spcAft>
-                <a:spcPts val="2200"/>
-              </a:spcAft>
-            </a:pPr>
-            <a:r>
-              <a:rPr sz="2000" b="0">
+                <a:spcPts val="1800"/>
+              </a:spcAft>
+            </a:pPr>
+            <a:r>
+              <a:rPr sz="1900" b="0">
                 <a:solidFill>
                   <a:srgbClr val="222222"/>
                 </a:solidFill>
                 <a:latin typeface="Calibri"/>
               </a:rPr>
-              <a:t>•   Model features: the last 3 monthly returns, plus the month and the year.</a:t>
+              <a:t>•   All three are free public feeds, so no key or login is needed.</a:t>
+            </a:r>
+          </a:p>
+          <a:p>
+            <a:pPr algn="l">
+              <a:spcAft>
+                <a:spcPts val="1800"/>
+              </a:spcAft>
+            </a:pPr>
+            <a:r>
+              <a:rPr sz="1900" b="0">
+                <a:solidFill>
+                  <a:srgbClr val="222222"/>
+                </a:solidFill>
+                <a:latin typeface="Calibri"/>
+              </a:rPr>
+              <a:t>•   Conversion:  Rs per gram = US$ per ounce x USD-INR rate / 31.1035  (one troy ounce = 31.1035 g).</a:t>
             </a:r>
           </a:p>
         </p:txBody>
@@ -7081,7 +7957,7 @@
                 </a:solidFill>
                 <a:latin typeface="Calibri"/>
               </a:rPr>
-              <a:t>Methodology</a:t>
+              <a:t>Dataset</a:t>
             </a:r>
           </a:p>
         </p:txBody>
@@ -7120,7 +7996,7 @@
                 </a:solidFill>
                 <a:latin typeface="Calibri"/>
               </a:rPr>
-              <a:t>Gold Price Prediction</a:t>
+              <a:t>Gold &amp; Silver Predictor</a:t>
             </a:r>
           </a:p>
         </p:txBody>
@@ -7359,81 +8235,81 @@
           <a:p>
             <a:pPr algn="l">
               <a:spcAft>
-                <a:spcPts val="2200"/>
-              </a:spcAft>
-            </a:pPr>
-            <a:r>
-              <a:rPr sz="2000" b="0">
+                <a:spcPts val="1800"/>
+              </a:spcAft>
+            </a:pPr>
+            <a:r>
+              <a:rPr sz="1900" b="0">
                 <a:solidFill>
                   <a:srgbClr val="222222"/>
                 </a:solidFill>
                 <a:latin typeface="Calibri"/>
               </a:rPr>
-              <a:t>•   The model predicts the month-to-month RETURN, not the raw price.</a:t>
+              <a:t>•   Two files: gold_prices.csv and silver_prices.csv - one row per month since January 2000.</a:t>
             </a:r>
           </a:p>
           <a:p>
             <a:pPr algn="l">
               <a:spcAft>
-                <a:spcPts val="2200"/>
-              </a:spcAft>
-            </a:pPr>
-            <a:r>
-              <a:rPr sz="2000" b="0">
+                <a:spcPts val="1800"/>
+              </a:spcAft>
+            </a:pPr>
+            <a:r>
+              <a:rPr sz="1900" b="0">
                 <a:solidFill>
                   <a:srgbClr val="222222"/>
                 </a:solidFill>
                 <a:latin typeface="Calibri"/>
               </a:rPr>
-              <a:t>•   Why: tree models cannot guess a price higher than they have seen, so a rising trend breaks them.</a:t>
+              <a:t>•   Columns: Date, Year, Month and Price (US dollars per troy ounce).</a:t>
             </a:r>
           </a:p>
           <a:p>
             <a:pPr algn="l">
               <a:spcAft>
-                <a:spcPts val="2200"/>
-              </a:spcAft>
-            </a:pPr>
-            <a:r>
-              <a:rPr sz="2000" b="0">
+                <a:spcPts val="1800"/>
+              </a:spcAft>
+            </a:pPr>
+            <a:r>
+              <a:rPr sz="1900" b="0">
                 <a:solidFill>
                   <a:srgbClr val="222222"/>
                 </a:solidFill>
                 <a:latin typeface="Calibri"/>
               </a:rPr>
-              <a:t>•   Price is rebuilt as   next price = last price x (1 + predicted return).</a:t>
+              <a:t>•   Yearly anchors are approximate LBMA annual averages, interpolated month to month with momentum.</a:t>
             </a:r>
           </a:p>
           <a:p>
             <a:pPr algn="l">
               <a:spcAft>
-                <a:spcPts val="2200"/>
-              </a:spcAft>
-            </a:pPr>
-            <a:r>
-              <a:rPr sz="2000" b="0">
+                <a:spcPts val="1800"/>
+              </a:spcAft>
+            </a:pPr>
+            <a:r>
+              <a:rPr sz="1900" b="0">
                 <a:solidFill>
                   <a:srgbClr val="222222"/>
                 </a:solidFill>
                 <a:latin typeface="Calibri"/>
               </a:rPr>
-              <a:t>•   Forecasting rolls forward one month at a time, feeding each answer back as the next input.</a:t>
+              <a:t>•   Model features: the last 3 monthly returns, plus the month and the year.</a:t>
             </a:r>
           </a:p>
           <a:p>
             <a:pPr algn="l">
               <a:spcAft>
-                <a:spcPts val="2200"/>
-              </a:spcAft>
-            </a:pPr>
-            <a:r>
-              <a:rPr sz="2000" b="0">
+                <a:spcPts val="1800"/>
+              </a:spcAft>
+            </a:pPr>
+            <a:r>
+              <a:rPr sz="1900" b="0">
                 <a:solidFill>
                   <a:srgbClr val="222222"/>
                 </a:solidFill>
                 <a:latin typeface="Calibri"/>
               </a:rPr>
-              <a:t>•   A chronological split is used - the last 60 months are kept for testing.</a:t>
+              <a:t>•   The live API price is appended as the latest point, so the forecast always starts from today.</a:t>
             </a:r>
           </a:p>
         </p:txBody>
@@ -7578,7 +8454,7 @@
                 </a:solidFill>
                 <a:latin typeface="Calibri"/>
               </a:rPr>
-              <a:t>Technology Used</a:t>
+              <a:t>Methodology</a:t>
             </a:r>
           </a:p>
         </p:txBody>
@@ -7617,7 +8493,7 @@
                 </a:solidFill>
                 <a:latin typeface="Calibri"/>
               </a:rPr>
-              <a:t>Gold Price Prediction</a:t>
+              <a:t>Gold &amp; Silver Predictor</a:t>
             </a:r>
           </a:p>
         </p:txBody>
@@ -7856,81 +8732,81 @@
           <a:p>
             <a:pPr algn="l">
               <a:spcAft>
-                <a:spcPts val="2200"/>
-              </a:spcAft>
-            </a:pPr>
-            <a:r>
-              <a:rPr sz="2000" b="0">
+                <a:spcPts val="1800"/>
+              </a:spcAft>
+            </a:pPr>
+            <a:r>
+              <a:rPr sz="1900" b="0">
                 <a:solidFill>
                   <a:srgbClr val="222222"/>
                 </a:solidFill>
                 <a:latin typeface="Calibri"/>
               </a:rPr>
-              <a:t>•   Language: Python.</a:t>
+              <a:t>•   The model predicts the month-to-month RETURN, never the raw price.</a:t>
             </a:r>
           </a:p>
           <a:p>
             <a:pPr algn="l">
               <a:spcAft>
-                <a:spcPts val="2200"/>
-              </a:spcAft>
-            </a:pPr>
-            <a:r>
-              <a:rPr sz="2000" b="0">
+                <a:spcPts val="1800"/>
+              </a:spcAft>
+            </a:pPr>
+            <a:r>
+              <a:rPr sz="1900" b="0">
                 <a:solidFill>
                   <a:srgbClr val="222222"/>
                 </a:solidFill>
                 <a:latin typeface="Calibri"/>
               </a:rPr>
-              <a:t>•   Data handling: pandas and NumPy.</a:t>
+              <a:t>•   Why: a tree model cannot guess a price higher than anything it saw, so a 25 year rising trend breaks it.</a:t>
             </a:r>
           </a:p>
           <a:p>
             <a:pPr algn="l">
               <a:spcAft>
-                <a:spcPts val="2200"/>
-              </a:spcAft>
-            </a:pPr>
-            <a:r>
-              <a:rPr sz="2000" b="0">
+                <a:spcPts val="1800"/>
+              </a:spcAft>
+            </a:pPr>
+            <a:r>
+              <a:rPr sz="1900" b="0">
                 <a:solidFill>
                   <a:srgbClr val="222222"/>
                 </a:solidFill>
                 <a:latin typeface="Calibri"/>
               </a:rPr>
-              <a:t>•   Models: scikit-learn - RandomForest, Linear Regression, Ridge.</a:t>
+              <a:t>•   Price is rebuilt as   next price = last price x (1 + predicted return).</a:t>
             </a:r>
           </a:p>
           <a:p>
             <a:pPr algn="l">
               <a:spcAft>
-                <a:spcPts val="2200"/>
-              </a:spcAft>
-            </a:pPr>
-            <a:r>
-              <a:rPr sz="2000" b="0">
+                <a:spcPts val="1800"/>
+              </a:spcAft>
+            </a:pPr>
+            <a:r>
+              <a:rPr sz="1900" b="0">
                 <a:solidFill>
                   <a:srgbClr val="222222"/>
                 </a:solidFill>
                 <a:latin typeface="Calibri"/>
               </a:rPr>
-              <a:t>•   Charts: Matplotlib.</a:t>
+              <a:t>•   Forecasting rolls forward one month at a time, feeding each answer back as the next input.</a:t>
             </a:r>
           </a:p>
           <a:p>
             <a:pPr algn="l">
               <a:spcAft>
-                <a:spcPts val="2200"/>
-              </a:spcAft>
-            </a:pPr>
-            <a:r>
-              <a:rPr sz="2000" b="0">
+                <a:spcPts val="1800"/>
+              </a:spcAft>
+            </a:pPr>
+            <a:r>
+              <a:rPr sz="1900" b="0">
                 <a:solidFill>
                   <a:srgbClr val="222222"/>
                 </a:solidFill>
                 <a:latin typeface="Calibri"/>
               </a:rPr>
-              <a:t>•   Interface: Tkinter.   Save / Load: Joblib.</a:t>
+              <a:t>•   The split is chronological - the last 60 months are held out and never used for fitting.</a:t>
             </a:r>
           </a:p>
         </p:txBody>
@@ -8075,7 +8951,7 @@
                 </a:solidFill>
                 <a:latin typeface="Calibri"/>
               </a:rPr>
-              <a:t>Results</a:t>
+              <a:t>Technology Used</a:t>
             </a:r>
           </a:p>
         </p:txBody>
@@ -8114,7 +8990,7 @@
                 </a:solidFill>
                 <a:latin typeface="Calibri"/>
               </a:rPr>
-              <a:t>Gold Price Prediction</a:t>
+              <a:t>Gold &amp; Silver Predictor</a:t>
             </a:r>
           </a:p>
         </p:txBody>
@@ -8285,6 +9161,503 @@
           </a:p>
         </p:txBody>
       </p:sp>
+      <p:sp>
+        <p:nvSpPr>
+          <p:cNvPr id="10" name="Rectangle 9"/>
+          <p:cNvSpPr/>
+          <p:nvPr/>
+        </p:nvSpPr>
+        <p:spPr>
+          <a:xfrm>
+            <a:off x="502920" y="1554480"/>
+            <a:ext cx="82296" cy="4297680"/>
+          </a:xfrm>
+          <a:prstGeom prst="rect">
+            <a:avLst/>
+          </a:prstGeom>
+          <a:solidFill>
+            <a:srgbClr val="C9A227"/>
+          </a:solidFill>
+          <a:ln>
+            <a:noFill/>
+          </a:ln>
+          <a:effectLst/>
+        </p:spPr>
+        <p:style>
+          <a:lnRef idx="1">
+            <a:schemeClr val="accent1"/>
+          </a:lnRef>
+          <a:fillRef idx="3">
+            <a:schemeClr val="accent1"/>
+          </a:fillRef>
+          <a:effectRef idx="2">
+            <a:schemeClr val="accent1"/>
+          </a:effectRef>
+          <a:fontRef idx="minor">
+            <a:schemeClr val="lt1"/>
+          </a:fontRef>
+        </p:style>
+        <p:txBody>
+          <a:bodyPr rtlCol="0" anchor="ctr"/>
+          <a:lstStyle/>
+          <a:p>
+            <a:pPr algn="ctr"/>
+          </a:p>
+        </p:txBody>
+      </p:sp>
+      <p:sp>
+        <p:nvSpPr>
+          <p:cNvPr id="11" name="TextBox 10"/>
+          <p:cNvSpPr txBox="1"/>
+          <p:nvPr/>
+        </p:nvSpPr>
+        <p:spPr>
+          <a:xfrm>
+            <a:off x="868680" y="1371600"/>
+            <a:ext cx="10728655" cy="4663440"/>
+          </a:xfrm>
+          <a:prstGeom prst="rect">
+            <a:avLst/>
+          </a:prstGeom>
+          <a:noFill/>
+        </p:spPr>
+        <p:txBody>
+          <a:bodyPr wrap="square" anchor="ctr">
+            <a:spAutoFit/>
+          </a:bodyPr>
+          <a:lstStyle/>
+          <a:p>
+            <a:pPr algn="l">
+              <a:spcAft>
+                <a:spcPts val="1800"/>
+              </a:spcAft>
+            </a:pPr>
+            <a:r>
+              <a:rPr sz="1900" b="0">
+                <a:solidFill>
+                  <a:srgbClr val="222222"/>
+                </a:solidFill>
+                <a:latin typeface="Calibri"/>
+              </a:rPr>
+              <a:t>•   Language: Python.</a:t>
+            </a:r>
+          </a:p>
+          <a:p>
+            <a:pPr algn="l">
+              <a:spcAft>
+                <a:spcPts val="1800"/>
+              </a:spcAft>
+            </a:pPr>
+            <a:r>
+              <a:rPr sz="1900" b="0">
+                <a:solidFill>
+                  <a:srgbClr val="222222"/>
+                </a:solidFill>
+                <a:latin typeface="Calibri"/>
+              </a:rPr>
+              <a:t>•   Data handling: pandas and NumPy.</a:t>
+            </a:r>
+          </a:p>
+          <a:p>
+            <a:pPr algn="l">
+              <a:spcAft>
+                <a:spcPts val="1800"/>
+              </a:spcAft>
+            </a:pPr>
+            <a:r>
+              <a:rPr sz="1900" b="0">
+                <a:solidFill>
+                  <a:srgbClr val="222222"/>
+                </a:solidFill>
+                <a:latin typeface="Calibri"/>
+              </a:rPr>
+              <a:t>•   Models: scikit-learn - Random Forest, Linear Regression, Ridge.</a:t>
+            </a:r>
+          </a:p>
+          <a:p>
+            <a:pPr algn="l">
+              <a:spcAft>
+                <a:spcPts val="1800"/>
+              </a:spcAft>
+            </a:pPr>
+            <a:r>
+              <a:rPr sz="1900" b="0">
+                <a:solidFill>
+                  <a:srgbClr val="222222"/>
+                </a:solidFill>
+                <a:latin typeface="Calibri"/>
+              </a:rPr>
+              <a:t>•   Backend: Flask, serving one JSON summary to the page.</a:t>
+            </a:r>
+          </a:p>
+          <a:p>
+            <a:pPr algn="l">
+              <a:spcAft>
+                <a:spcPts val="1800"/>
+              </a:spcAft>
+            </a:pPr>
+            <a:r>
+              <a:rPr sz="1900" b="0">
+                <a:solidFill>
+                  <a:srgbClr val="222222"/>
+                </a:solidFill>
+                <a:latin typeface="Calibri"/>
+              </a:rPr>
+              <a:t>•   Frontend: Chart.js on a dark dashboard.   Model save / load: Joblib.</a:t>
+            </a:r>
+          </a:p>
+        </p:txBody>
+      </p:sp>
+    </p:spTree>
+  </p:cSld>
+  <p:clrMapOvr>
+    <a:masterClrMapping/>
+  </p:clrMapOvr>
+</p:sld>
+</file>
+
+<file path=ppt/slides/slide9.xml><?xml version="1.0" encoding="utf-8"?>
+<p:sld xmlns:a="http://schemas.openxmlformats.org/drawingml/2006/main" xmlns:p="http://schemas.openxmlformats.org/presentationml/2006/main" xmlns:r="http://schemas.openxmlformats.org/officeDocument/2006/relationships">
+  <p:cSld>
+    <p:spTree>
+      <p:nvGrpSpPr>
+        <p:cNvPr id="1" name=""/>
+        <p:cNvGrpSpPr/>
+        <p:nvPr/>
+      </p:nvGrpSpPr>
+      <p:grpSpPr/>
+      <p:sp>
+        <p:nvSpPr>
+          <p:cNvPr id="2" name="Rectangle 1"/>
+          <p:cNvSpPr/>
+          <p:nvPr/>
+        </p:nvSpPr>
+        <p:spPr>
+          <a:xfrm>
+            <a:off x="0" y="0"/>
+            <a:ext cx="12191695" cy="960120"/>
+          </a:xfrm>
+          <a:prstGeom prst="rect">
+            <a:avLst/>
+          </a:prstGeom>
+          <a:solidFill>
+            <a:srgbClr val="1F3864"/>
+          </a:solidFill>
+          <a:ln>
+            <a:noFill/>
+          </a:ln>
+          <a:effectLst/>
+        </p:spPr>
+        <p:style>
+          <a:lnRef idx="1">
+            <a:schemeClr val="accent1"/>
+          </a:lnRef>
+          <a:fillRef idx="3">
+            <a:schemeClr val="accent1"/>
+          </a:fillRef>
+          <a:effectRef idx="2">
+            <a:schemeClr val="accent1"/>
+          </a:effectRef>
+          <a:fontRef idx="minor">
+            <a:schemeClr val="lt1"/>
+          </a:fontRef>
+        </p:style>
+        <p:txBody>
+          <a:bodyPr rtlCol="0" anchor="ctr"/>
+          <a:lstStyle/>
+          <a:p>
+            <a:pPr algn="ctr"/>
+          </a:p>
+        </p:txBody>
+      </p:sp>
+      <p:sp>
+        <p:nvSpPr>
+          <p:cNvPr id="3" name="Rectangle 2"/>
+          <p:cNvSpPr/>
+          <p:nvPr/>
+        </p:nvSpPr>
+        <p:spPr>
+          <a:xfrm>
+            <a:off x="0" y="960120"/>
+            <a:ext cx="12191695" cy="64008"/>
+          </a:xfrm>
+          <a:prstGeom prst="rect">
+            <a:avLst/>
+          </a:prstGeom>
+          <a:solidFill>
+            <a:srgbClr val="C9A227"/>
+          </a:solidFill>
+          <a:ln>
+            <a:noFill/>
+          </a:ln>
+          <a:effectLst/>
+        </p:spPr>
+        <p:style>
+          <a:lnRef idx="1">
+            <a:schemeClr val="accent1"/>
+          </a:lnRef>
+          <a:fillRef idx="3">
+            <a:schemeClr val="accent1"/>
+          </a:fillRef>
+          <a:effectRef idx="2">
+            <a:schemeClr val="accent1"/>
+          </a:effectRef>
+          <a:fontRef idx="minor">
+            <a:schemeClr val="lt1"/>
+          </a:fontRef>
+        </p:style>
+        <p:txBody>
+          <a:bodyPr rtlCol="0" anchor="ctr"/>
+          <a:lstStyle/>
+          <a:p>
+            <a:pPr algn="ctr"/>
+          </a:p>
+        </p:txBody>
+      </p:sp>
+      <p:sp>
+        <p:nvSpPr>
+          <p:cNvPr id="4" name="TextBox 3"/>
+          <p:cNvSpPr txBox="1"/>
+          <p:nvPr/>
+        </p:nvSpPr>
+        <p:spPr>
+          <a:xfrm>
+            <a:off x="457200" y="137160"/>
+            <a:ext cx="8351215" cy="731520"/>
+          </a:xfrm>
+          <a:prstGeom prst="rect">
+            <a:avLst/>
+          </a:prstGeom>
+          <a:noFill/>
+        </p:spPr>
+        <p:txBody>
+          <a:bodyPr wrap="square" anchor="ctr">
+            <a:spAutoFit/>
+          </a:bodyPr>
+          <a:lstStyle/>
+          <a:p>
+            <a:pPr algn="l">
+              <a:spcAft>
+                <a:spcPts val="600"/>
+              </a:spcAft>
+            </a:pPr>
+            <a:r>
+              <a:rPr sz="2600" b="1">
+                <a:solidFill>
+                  <a:srgbClr val="FFFFFF"/>
+                </a:solidFill>
+                <a:latin typeface="Calibri"/>
+              </a:rPr>
+              <a:t>Results</a:t>
+            </a:r>
+          </a:p>
+        </p:txBody>
+      </p:sp>
+      <p:sp>
+        <p:nvSpPr>
+          <p:cNvPr id="5" name="TextBox 4"/>
+          <p:cNvSpPr txBox="1"/>
+          <p:nvPr/>
+        </p:nvSpPr>
+        <p:spPr>
+          <a:xfrm>
+            <a:off x="8534095" y="137160"/>
+            <a:ext cx="3200400" cy="731520"/>
+          </a:xfrm>
+          <a:prstGeom prst="rect">
+            <a:avLst/>
+          </a:prstGeom>
+          <a:noFill/>
+        </p:spPr>
+        <p:txBody>
+          <a:bodyPr wrap="square" anchor="ctr">
+            <a:spAutoFit/>
+          </a:bodyPr>
+          <a:lstStyle/>
+          <a:p>
+            <a:pPr algn="r">
+              <a:spcAft>
+                <a:spcPts val="600"/>
+              </a:spcAft>
+            </a:pPr>
+            <a:r>
+              <a:rPr sz="1200" b="1">
+                <a:solidFill>
+                  <a:srgbClr val="C9A227"/>
+                </a:solidFill>
+                <a:latin typeface="Calibri"/>
+              </a:rPr>
+              <a:t>Gold &amp; Silver Predictor</a:t>
+            </a:r>
+          </a:p>
+        </p:txBody>
+      </p:sp>
+      <p:sp>
+        <p:nvSpPr>
+          <p:cNvPr id="6" name="Rectangle 5"/>
+          <p:cNvSpPr/>
+          <p:nvPr/>
+        </p:nvSpPr>
+        <p:spPr>
+          <a:xfrm>
+            <a:off x="0" y="6473952"/>
+            <a:ext cx="12191695" cy="384048"/>
+          </a:xfrm>
+          <a:prstGeom prst="rect">
+            <a:avLst/>
+          </a:prstGeom>
+          <a:solidFill>
+            <a:srgbClr val="1F3864"/>
+          </a:solidFill>
+          <a:ln>
+            <a:noFill/>
+          </a:ln>
+          <a:effectLst/>
+        </p:spPr>
+        <p:style>
+          <a:lnRef idx="1">
+            <a:schemeClr val="accent1"/>
+          </a:lnRef>
+          <a:fillRef idx="3">
+            <a:schemeClr val="accent1"/>
+          </a:fillRef>
+          <a:effectRef idx="2">
+            <a:schemeClr val="accent1"/>
+          </a:effectRef>
+          <a:fontRef idx="minor">
+            <a:schemeClr val="lt1"/>
+          </a:fontRef>
+        </p:style>
+        <p:txBody>
+          <a:bodyPr rtlCol="0" anchor="ctr"/>
+          <a:lstStyle/>
+          <a:p>
+            <a:pPr algn="ctr"/>
+          </a:p>
+        </p:txBody>
+      </p:sp>
+      <p:sp>
+        <p:nvSpPr>
+          <p:cNvPr id="7" name="Rectangle 6"/>
+          <p:cNvSpPr/>
+          <p:nvPr/>
+        </p:nvSpPr>
+        <p:spPr>
+          <a:xfrm>
+            <a:off x="0" y="6473952"/>
+            <a:ext cx="128016" cy="384048"/>
+          </a:xfrm>
+          <a:prstGeom prst="rect">
+            <a:avLst/>
+          </a:prstGeom>
+          <a:solidFill>
+            <a:srgbClr val="C9A227"/>
+          </a:solidFill>
+          <a:ln>
+            <a:noFill/>
+          </a:ln>
+          <a:effectLst/>
+        </p:spPr>
+        <p:style>
+          <a:lnRef idx="1">
+            <a:schemeClr val="accent1"/>
+          </a:lnRef>
+          <a:fillRef idx="3">
+            <a:schemeClr val="accent1"/>
+          </a:fillRef>
+          <a:effectRef idx="2">
+            <a:schemeClr val="accent1"/>
+          </a:effectRef>
+          <a:fontRef idx="minor">
+            <a:schemeClr val="lt1"/>
+          </a:fontRef>
+        </p:style>
+        <p:txBody>
+          <a:bodyPr rtlCol="0" anchor="ctr"/>
+          <a:lstStyle/>
+          <a:p>
+            <a:pPr algn="ctr"/>
+          </a:p>
+        </p:txBody>
+      </p:sp>
+      <p:sp>
+        <p:nvSpPr>
+          <p:cNvPr id="8" name="TextBox 7"/>
+          <p:cNvSpPr txBox="1"/>
+          <p:nvPr/>
+        </p:nvSpPr>
+        <p:spPr>
+          <a:xfrm>
+            <a:off x="274320" y="6473952"/>
+            <a:ext cx="10362895" cy="384048"/>
+          </a:xfrm>
+          <a:prstGeom prst="rect">
+            <a:avLst/>
+          </a:prstGeom>
+          <a:noFill/>
+        </p:spPr>
+        <p:txBody>
+          <a:bodyPr wrap="square" anchor="ctr">
+            <a:spAutoFit/>
+          </a:bodyPr>
+          <a:lstStyle/>
+          <a:p>
+            <a:pPr algn="l">
+              <a:spcAft>
+                <a:spcPts val="600"/>
+              </a:spcAft>
+            </a:pPr>
+            <a:r>
+              <a:rPr sz="900" b="0">
+                <a:solidFill>
+                  <a:srgbClr val="FFFFFF"/>
+                </a:solidFill>
+                <a:latin typeface="Calibri"/>
+              </a:rPr>
+              <a:t>Sanchay Bhardwaj (2300650100104)  |  B.S.A. College of Engineering &amp; Technology, Mathura</a:t>
+            </a:r>
+          </a:p>
+        </p:txBody>
+      </p:sp>
+      <p:sp>
+        <p:nvSpPr>
+          <p:cNvPr id="9" name="TextBox 8"/>
+          <p:cNvSpPr txBox="1"/>
+          <p:nvPr/>
+        </p:nvSpPr>
+        <p:spPr>
+          <a:xfrm>
+            <a:off x="10728655" y="6473952"/>
+            <a:ext cx="1188720" cy="384048"/>
+          </a:xfrm>
+          <a:prstGeom prst="rect">
+            <a:avLst/>
+          </a:prstGeom>
+          <a:noFill/>
+        </p:spPr>
+        <p:txBody>
+          <a:bodyPr wrap="square" anchor="ctr">
+            <a:spAutoFit/>
+          </a:bodyPr>
+          <a:lstStyle/>
+          <a:p>
+            <a:pPr algn="r">
+              <a:spcAft>
+                <a:spcPts val="600"/>
+              </a:spcAft>
+            </a:pPr>
+            <a:r>
+              <a:rPr sz="900" b="1">
+                <a:solidFill>
+                  <a:srgbClr val="C9A227"/>
+                </a:solidFill>
+                <a:latin typeface="Calibri"/>
+              </a:rPr>
+              <a:t>Slide 9</a:t>
+            </a:r>
+          </a:p>
+        </p:txBody>
+      </p:sp>
       <p:graphicFrame>
         <p:nvGraphicFramePr>
           <p:cNvPr id="10" name="Table 9"/>
@@ -8294,8 +9667,8 @@
           <p:nvPr/>
         </p:nvGraphicFramePr>
         <p:xfrm>
-          <a:off x="640080" y="1737360"/>
-          <a:ext cx="6675120" cy="3108960"/>
+          <a:off x="502920" y="1828800"/>
+          <a:ext cx="7406640" cy="2926080"/>
         </p:xfrm>
         <a:graphic>
           <a:graphicData uri="http://schemas.openxmlformats.org/drawingml/2006/table">
@@ -8304,12 +9677,13 @@
                 <a:tableStyleId>{5C22544A-7EE6-4342-B048-85BDC9FD1C3A}</a:tableStyleId>
               </a:tblPr>
               <a:tblGrid>
-                <a:gridCol w="1668780"/>
-                <a:gridCol w="1668780"/>
-                <a:gridCol w="1668780"/>
-                <a:gridCol w="1668780"/>
+                <a:gridCol w="1481328"/>
+                <a:gridCol w="1481328"/>
+                <a:gridCol w="1481328"/>
+                <a:gridCol w="1481328"/>
+                <a:gridCol w="1481328"/>
               </a:tblGrid>
-              <a:tr h="621792">
+              <a:tr h="585216">
                 <a:tc>
                   <a:txBody>
                     <a:bodyPr anchor="ctr"/>
@@ -8321,7 +9695,7 @@
                         </a:spcAft>
                       </a:pPr>
                       <a:r>
-                        <a:rPr sz="1500" b="1">
+                        <a:rPr sz="1200" b="1">
                           <a:solidFill>
                             <a:srgbClr val="FFFFFF"/>
                           </a:solidFill>
@@ -8348,13 +9722,13 @@
                         </a:spcAft>
                       </a:pPr>
                       <a:r>
-                        <a:rPr sz="1500" b="1">
+                        <a:rPr sz="1200" b="1">
                           <a:solidFill>
                             <a:srgbClr val="FFFFFF"/>
                           </a:solidFill>
                           <a:latin typeface="Calibri"/>
                         </a:rPr>
-                        <a:t>MAE (USD)</a:t>
+                        <a:t>Gold MAE (US$/oz)</a:t>
                       </a:r>
                     </a:p>
                   </a:txBody>
@@ -8375,13 +9749,13 @@
                         </a:spcAft>
                       </a:pPr>
                       <a:r>
-                        <a:rPr sz="1500" b="1">
+                        <a:rPr sz="1200" b="1">
                           <a:solidFill>
                             <a:srgbClr val="FFFFFF"/>
                           </a:solidFill>
                           <a:latin typeface="Calibri"/>
                         </a:rPr>
-                        <a:t>RMSE (USD)</a:t>
+                        <a:t>Gold R-sq</a:t>
                       </a:r>
                     </a:p>
                   </a:txBody>
@@ -8402,13 +9776,40 @@
                         </a:spcAft>
                       </a:pPr>
                       <a:r>
-                        <a:rPr sz="1500" b="1">
+                        <a:rPr sz="1200" b="1">
                           <a:solidFill>
                             <a:srgbClr val="FFFFFF"/>
                           </a:solidFill>
                           <a:latin typeface="Calibri"/>
                         </a:rPr>
-                        <a:t>R-squared</a:t>
+                        <a:t>Silver MAE (US$/oz)</a:t>
+                      </a:r>
+                    </a:p>
+                  </a:txBody>
+                  <a:tcPr>
+                    <a:solidFill>
+                      <a:srgbClr val="1F3864"/>
+                    </a:solidFill>
+                  </a:tcPr>
+                </a:tc>
+                <a:tc>
+                  <a:txBody>
+                    <a:bodyPr anchor="ctr"/>
+                    <a:lstStyle/>
+                    <a:p>
+                      <a:pPr algn="ctr">
+                        <a:spcAft>
+                          <a:spcPts val="600"/>
+                        </a:spcAft>
+                      </a:pPr>
+                      <a:r>
+                        <a:rPr sz="1200" b="1">
+                          <a:solidFill>
+                            <a:srgbClr val="FFFFFF"/>
+                          </a:solidFill>
+                          <a:latin typeface="Calibri"/>
+                        </a:rPr>
+                        <a:t>Silver R-sq</a:t>
                       </a:r>
                     </a:p>
                   </a:txBody>
@@ -8419,7 +9820,7 @@
                   </a:tcPr>
                 </a:tc>
               </a:tr>
-              <a:tr h="621792">
+              <a:tr h="585216">
                 <a:tc>
                   <a:txBody>
                     <a:bodyPr anchor="ctr"/>
@@ -8431,13 +9832,13 @@
                         </a:spcAft>
                       </a:pPr>
                       <a:r>
-                        <a:rPr sz="1400" b="1">
+                        <a:rPr sz="1200" b="1">
                           <a:solidFill>
                             <a:srgbClr val="C9A227"/>
                           </a:solidFill>
                           <a:latin typeface="Calibri"/>
                         </a:rPr>
-                        <a:t>RandomForest</a:t>
+                        <a:t>Random Forest</a:t>
                       </a:r>
                     </a:p>
                   </a:txBody>
@@ -8458,13 +9859,13 @@
                         </a:spcAft>
                       </a:pPr>
                       <a:r>
-                        <a:rPr sz="1400" b="1">
+                        <a:rPr sz="1200" b="1">
                           <a:solidFill>
                             <a:srgbClr val="C9A227"/>
                           </a:solidFill>
                           <a:latin typeface="Calibri"/>
                         </a:rPr>
-                        <a:t>32.71</a:t>
+                        <a:t>44.34</a:t>
                       </a:r>
                     </a:p>
                   </a:txBody>
@@ -8485,13 +9886,13 @@
                         </a:spcAft>
                       </a:pPr>
                       <a:r>
-                        <a:rPr sz="1400" b="1">
+                        <a:rPr sz="1200" b="1">
                           <a:solidFill>
                             <a:srgbClr val="C9A227"/>
                           </a:solidFill>
                           <a:latin typeface="Calibri"/>
                         </a:rPr>
-                        <a:t>44.47</a:t>
+                        <a:t>0.9910</a:t>
                       </a:r>
                     </a:p>
                   </a:txBody>
@@ -8512,13 +9913,40 @@
                         </a:spcAft>
                       </a:pPr>
                       <a:r>
-                        <a:rPr sz="1400" b="1">
+                        <a:rPr sz="1200" b="1">
                           <a:solidFill>
                             <a:srgbClr val="C9A227"/>
                           </a:solidFill>
                           <a:latin typeface="Calibri"/>
                         </a:rPr>
-                        <a:t>0.9613</a:t>
+                        <a:t>0.54</a:t>
+                      </a:r>
+                    </a:p>
+                  </a:txBody>
+                  <a:tcPr>
+                    <a:solidFill>
+                      <a:srgbClr val="EEF3FA"/>
+                    </a:solidFill>
+                  </a:tcPr>
+                </a:tc>
+                <a:tc>
+                  <a:txBody>
+                    <a:bodyPr anchor="ctr"/>
+                    <a:lstStyle/>
+                    <a:p>
+                      <a:pPr algn="ctr">
+                        <a:spcAft>
+                          <a:spcPts val="600"/>
+                        </a:spcAft>
+                      </a:pPr>
+                      <a:r>
+                        <a:rPr sz="1200" b="1">
+                          <a:solidFill>
+                            <a:srgbClr val="C9A227"/>
+                          </a:solidFill>
+                          <a:latin typeface="Calibri"/>
+                        </a:rPr>
+                        <a:t>0.9942</a:t>
                       </a:r>
                     </a:p>
                   </a:txBody>
@@ -8529,7 +9957,7 @@
                   </a:tcPr>
                 </a:tc>
               </a:tr>
-              <a:tr h="621792">
+              <a:tr h="585216">
                 <a:tc>
                   <a:txBody>
                     <a:bodyPr anchor="ctr"/>
@@ -8541,7 +9969,7 @@
                         </a:spcAft>
                       </a:pPr>
                       <a:r>
-                        <a:rPr sz="1400" b="0">
+                        <a:rPr sz="1200" b="0">
                           <a:solidFill>
                             <a:srgbClr val="222222"/>
                           </a:solidFill>
@@ -8568,13 +9996,13 @@
                         </a:spcAft>
                       </a:pPr>
                       <a:r>
-                        <a:rPr sz="1400" b="0">
+                        <a:rPr sz="1200" b="0">
                           <a:solidFill>
                             <a:srgbClr val="222222"/>
                           </a:solidFill>
                           <a:latin typeface="Calibri"/>
                         </a:rPr>
-                        <a:t>32.91</a:t>
+                        <a:t>54.12</a:t>
                       </a:r>
                     </a:p>
                   </a:txBody>
@@ -8595,13 +10023,13 @@
                         </a:spcAft>
                       </a:pPr>
                       <a:r>
-                        <a:rPr sz="1400" b="0">
+                        <a:rPr sz="1200" b="0">
                           <a:solidFill>
                             <a:srgbClr val="222222"/>
                           </a:solidFill>
                           <a:latin typeface="Calibri"/>
                         </a:rPr>
-                        <a:t>44.60</a:t>
+                        <a:t>0.9889</a:t>
                       </a:r>
                     </a:p>
                   </a:txBody>
@@ -8622,13 +10050,40 @@
                         </a:spcAft>
                       </a:pPr>
                       <a:r>
-                        <a:rPr sz="1400" b="0">
+                        <a:rPr sz="1200" b="0">
                           <a:solidFill>
                             <a:srgbClr val="222222"/>
                           </a:solidFill>
                           <a:latin typeface="Calibri"/>
                         </a:rPr>
-                        <a:t>0.9611</a:t>
+                        <a:t>0.62</a:t>
+                      </a:r>
+                    </a:p>
+                  </a:txBody>
+                  <a:tcPr>
+                    <a:solidFill>
+                      <a:srgbClr val="FFFFFF"/>
+                    </a:solidFill>
+                  </a:tcPr>
+                </a:tc>
+                <a:tc>
+                  <a:txBody>
+                    <a:bodyPr anchor="ctr"/>
+                    <a:lstStyle/>
+                    <a:p>
+                      <a:pPr algn="ctr">
+                        <a:spcAft>
+                          <a:spcPts val="600"/>
+                        </a:spcAft>
+                      </a:pPr>
+                      <a:r>
+                        <a:rPr sz="1200" b="0">
+                          <a:solidFill>
+                            <a:srgbClr val="222222"/>
+                          </a:solidFill>
+                          <a:latin typeface="Calibri"/>
+                        </a:rPr>
+                        <a:t>0.9909</a:t>
                       </a:r>
                     </a:p>
                   </a:txBody>
@@ -8639,7 +10094,7 @@
                   </a:tcPr>
                 </a:tc>
               </a:tr>
-              <a:tr h="621792">
+              <a:tr h="585216">
                 <a:tc>
                   <a:txBody>
                     <a:bodyPr anchor="ctr"/>
@@ -8651,7 +10106,7 @@
                         </a:spcAft>
                       </a:pPr>
                       <a:r>
-                        <a:rPr sz="1400" b="0">
+                        <a:rPr sz="1200" b="0">
                           <a:solidFill>
                             <a:srgbClr val="222222"/>
                           </a:solidFill>
@@ -8678,13 +10133,13 @@
                         </a:spcAft>
                       </a:pPr>
                       <a:r>
-                        <a:rPr sz="1400" b="0">
+                        <a:rPr sz="1200" b="0">
                           <a:solidFill>
                             <a:srgbClr val="222222"/>
                           </a:solidFill>
                           <a:latin typeface="Calibri"/>
                         </a:rPr>
-                        <a:t>33.33</a:t>
+                        <a:t>53.54</a:t>
                       </a:r>
                     </a:p>
                   </a:txBody>
@@ -8705,13 +10160,13 @@
                         </a:spcAft>
                       </a:pPr>
                       <a:r>
-                        <a:rPr sz="1400" b="0">
+                        <a:rPr sz="1200" b="0">
                           <a:solidFill>
                             <a:srgbClr val="222222"/>
                           </a:solidFill>
                           <a:latin typeface="Calibri"/>
                         </a:rPr>
-                        <a:t>45.50</a:t>
+                        <a:t>0.9889</a:t>
                       </a:r>
                     </a:p>
                   </a:txBody>
@@ -8732,13 +10187,40 @@
                         </a:spcAft>
                       </a:pPr>
                       <a:r>
-                        <a:rPr sz="1400" b="0">
+                        <a:rPr sz="1200" b="0">
                           <a:solidFill>
                             <a:srgbClr val="222222"/>
                           </a:solidFill>
                           <a:latin typeface="Calibri"/>
                         </a:rPr>
-                        <a:t>0.9595</a:t>
+                        <a:t>0.64</a:t>
+                      </a:r>
+                    </a:p>
+                  </a:txBody>
+                  <a:tcPr>
+                    <a:solidFill>
+                      <a:srgbClr val="EEF3FA"/>
+                    </a:solidFill>
+                  </a:tcPr>
+                </a:tc>
+                <a:tc>
+                  <a:txBody>
+                    <a:bodyPr anchor="ctr"/>
+                    <a:lstStyle/>
+                    <a:p>
+                      <a:pPr algn="ctr">
+                        <a:spcAft>
+                          <a:spcPts val="600"/>
+                        </a:spcAft>
+                      </a:pPr>
+                      <a:r>
+                        <a:rPr sz="1200" b="0">
+                          <a:solidFill>
+                            <a:srgbClr val="222222"/>
+                          </a:solidFill>
+                          <a:latin typeface="Calibri"/>
+                        </a:rPr>
+                        <a:t>0.9903</a:t>
                       </a:r>
                     </a:p>
                   </a:txBody>
@@ -8749,7 +10231,7 @@
                   </a:tcPr>
                 </a:tc>
               </a:tr>
-              <a:tr h="621792">
+              <a:tr h="585216">
                 <a:tc>
                   <a:txBody>
                     <a:bodyPr anchor="ctr"/>
@@ -8761,7 +10243,7 @@
                         </a:spcAft>
                       </a:pPr>
                       <a:r>
-                        <a:rPr sz="1400" b="0">
+                        <a:rPr sz="1200" b="0">
                           <a:solidFill>
                             <a:srgbClr val="222222"/>
                           </a:solidFill>
@@ -8788,13 +10270,13 @@
                         </a:spcAft>
                       </a:pPr>
                       <a:r>
-                        <a:rPr sz="1400" b="0">
+                        <a:rPr sz="1200" b="0">
                           <a:solidFill>
                             <a:srgbClr val="222222"/>
                           </a:solidFill>
                           <a:latin typeface="Calibri"/>
                         </a:rPr>
-                        <a:t>36.14</a:t>
+                        <a:t>56.93</a:t>
                       </a:r>
                     </a:p>
                   </a:txBody>
@@ -8815,13 +10297,13 @@
                         </a:spcAft>
                       </a:pPr>
                       <a:r>
-                        <a:rPr sz="1400" b="0">
+                        <a:rPr sz="1200" b="0">
                           <a:solidFill>
                             <a:srgbClr val="222222"/>
                           </a:solidFill>
                           <a:latin typeface="Calibri"/>
                         </a:rPr>
-                        <a:t>47.97</a:t>
+                        <a:t>0.9875</a:t>
                       </a:r>
                     </a:p>
                   </a:txBody>
@@ -8842,13 +10324,40 @@
                         </a:spcAft>
                       </a:pPr>
                       <a:r>
-                        <a:rPr sz="1400" b="0">
+                        <a:rPr sz="1200" b="0">
                           <a:solidFill>
                             <a:srgbClr val="222222"/>
                           </a:solidFill>
                           <a:latin typeface="Calibri"/>
                         </a:rPr>
-                        <a:t>0.9549</a:t>
+                        <a:t>0.64</a:t>
+                      </a:r>
+                    </a:p>
+                  </a:txBody>
+                  <a:tcPr>
+                    <a:solidFill>
+                      <a:srgbClr val="FFFFFF"/>
+                    </a:solidFill>
+                  </a:tcPr>
+                </a:tc>
+                <a:tc>
+                  <a:txBody>
+                    <a:bodyPr anchor="ctr"/>
+                    <a:lstStyle/>
+                    <a:p>
+                      <a:pPr algn="ctr">
+                        <a:spcAft>
+                          <a:spcPts val="600"/>
+                        </a:spcAft>
+                      </a:pPr>
+                      <a:r>
+                        <a:rPr sz="1200" b="0">
+                          <a:solidFill>
+                            <a:srgbClr val="222222"/>
+                          </a:solidFill>
+                          <a:latin typeface="Calibri"/>
+                        </a:rPr>
+                        <a:t>0.9897</a:t>
                       </a:r>
                     </a:p>
                   </a:txBody>
@@ -8879,8 +10388,8 @@
         </p:blipFill>
         <p:spPr>
           <a:xfrm>
-            <a:off x="7680960" y="1554480"/>
-            <a:ext cx="3931920" cy="3291840"/>
+            <a:off x="8092440" y="1600200"/>
+            <a:ext cx="3749039" cy="3200400"/>
           </a:xfrm>
           <a:prstGeom prst="rect">
             <a:avLst/>
@@ -8895,8 +10404,8 @@
         </p:nvSpPr>
         <p:spPr>
           <a:xfrm>
-            <a:off x="640080" y="5212080"/>
-            <a:ext cx="6675120" cy="914400"/>
+            <a:off x="502920" y="5120640"/>
+            <a:ext cx="7406640" cy="1097280"/>
           </a:xfrm>
           <a:prstGeom prst="rect">
             <a:avLst/>
@@ -8921,420 +10430,7 @@
                 </a:solidFill>
                 <a:latin typeface="Calibri"/>
               </a:rPr>
-              <a:t>RandomForest wins on every metric. Test window: last 60 months (from Jan 2020). Lower MAE / RMSE and higher R-squared are better.</a:t>
-            </a:r>
-          </a:p>
-        </p:txBody>
-      </p:sp>
-    </p:spTree>
-  </p:cSld>
-  <p:clrMapOvr>
-    <a:masterClrMapping/>
-  </p:clrMapOvr>
-</p:sld>
-</file>
-
-<file path=ppt/slides/slide9.xml><?xml version="1.0" encoding="utf-8"?>
-<p:sld xmlns:a="http://schemas.openxmlformats.org/drawingml/2006/main" xmlns:p="http://schemas.openxmlformats.org/presentationml/2006/main" xmlns:r="http://schemas.openxmlformats.org/officeDocument/2006/relationships">
-  <p:cSld>
-    <p:spTree>
-      <p:nvGrpSpPr>
-        <p:cNvPr id="1" name=""/>
-        <p:cNvGrpSpPr/>
-        <p:nvPr/>
-      </p:nvGrpSpPr>
-      <p:grpSpPr/>
-      <p:sp>
-        <p:nvSpPr>
-          <p:cNvPr id="2" name="Rectangle 1"/>
-          <p:cNvSpPr/>
-          <p:nvPr/>
-        </p:nvSpPr>
-        <p:spPr>
-          <a:xfrm>
-            <a:off x="0" y="0"/>
-            <a:ext cx="12191695" cy="960120"/>
-          </a:xfrm>
-          <a:prstGeom prst="rect">
-            <a:avLst/>
-          </a:prstGeom>
-          <a:solidFill>
-            <a:srgbClr val="1F3864"/>
-          </a:solidFill>
-          <a:ln>
-            <a:noFill/>
-          </a:ln>
-          <a:effectLst/>
-        </p:spPr>
-        <p:style>
-          <a:lnRef idx="1">
-            <a:schemeClr val="accent1"/>
-          </a:lnRef>
-          <a:fillRef idx="3">
-            <a:schemeClr val="accent1"/>
-          </a:fillRef>
-          <a:effectRef idx="2">
-            <a:schemeClr val="accent1"/>
-          </a:effectRef>
-          <a:fontRef idx="minor">
-            <a:schemeClr val="lt1"/>
-          </a:fontRef>
-        </p:style>
-        <p:txBody>
-          <a:bodyPr rtlCol="0" anchor="ctr"/>
-          <a:lstStyle/>
-          <a:p>
-            <a:pPr algn="ctr"/>
-          </a:p>
-        </p:txBody>
-      </p:sp>
-      <p:sp>
-        <p:nvSpPr>
-          <p:cNvPr id="3" name="Rectangle 2"/>
-          <p:cNvSpPr/>
-          <p:nvPr/>
-        </p:nvSpPr>
-        <p:spPr>
-          <a:xfrm>
-            <a:off x="0" y="960120"/>
-            <a:ext cx="12191695" cy="64008"/>
-          </a:xfrm>
-          <a:prstGeom prst="rect">
-            <a:avLst/>
-          </a:prstGeom>
-          <a:solidFill>
-            <a:srgbClr val="C9A227"/>
-          </a:solidFill>
-          <a:ln>
-            <a:noFill/>
-          </a:ln>
-          <a:effectLst/>
-        </p:spPr>
-        <p:style>
-          <a:lnRef idx="1">
-            <a:schemeClr val="accent1"/>
-          </a:lnRef>
-          <a:fillRef idx="3">
-            <a:schemeClr val="accent1"/>
-          </a:fillRef>
-          <a:effectRef idx="2">
-            <a:schemeClr val="accent1"/>
-          </a:effectRef>
-          <a:fontRef idx="minor">
-            <a:schemeClr val="lt1"/>
-          </a:fontRef>
-        </p:style>
-        <p:txBody>
-          <a:bodyPr rtlCol="0" anchor="ctr"/>
-          <a:lstStyle/>
-          <a:p>
-            <a:pPr algn="ctr"/>
-          </a:p>
-        </p:txBody>
-      </p:sp>
-      <p:sp>
-        <p:nvSpPr>
-          <p:cNvPr id="4" name="TextBox 3"/>
-          <p:cNvSpPr txBox="1"/>
-          <p:nvPr/>
-        </p:nvSpPr>
-        <p:spPr>
-          <a:xfrm>
-            <a:off x="457200" y="137160"/>
-            <a:ext cx="8351215" cy="731520"/>
-          </a:xfrm>
-          <a:prstGeom prst="rect">
-            <a:avLst/>
-          </a:prstGeom>
-          <a:noFill/>
-        </p:spPr>
-        <p:txBody>
-          <a:bodyPr wrap="square" anchor="ctr">
-            <a:spAutoFit/>
-          </a:bodyPr>
-          <a:lstStyle/>
-          <a:p>
-            <a:pPr algn="l">
-              <a:spcAft>
-                <a:spcPts val="600"/>
-              </a:spcAft>
-            </a:pPr>
-            <a:r>
-              <a:rPr sz="2600" b="1">
-                <a:solidFill>
-                  <a:srgbClr val="FFFFFF"/>
-                </a:solidFill>
-                <a:latin typeface="Calibri"/>
-              </a:rPr>
-              <a:t>Application - Prediction</a:t>
-            </a:r>
-          </a:p>
-        </p:txBody>
-      </p:sp>
-      <p:sp>
-        <p:nvSpPr>
-          <p:cNvPr id="5" name="TextBox 4"/>
-          <p:cNvSpPr txBox="1"/>
-          <p:nvPr/>
-        </p:nvSpPr>
-        <p:spPr>
-          <a:xfrm>
-            <a:off x="8534095" y="137160"/>
-            <a:ext cx="3200400" cy="731520"/>
-          </a:xfrm>
-          <a:prstGeom prst="rect">
-            <a:avLst/>
-          </a:prstGeom>
-          <a:noFill/>
-        </p:spPr>
-        <p:txBody>
-          <a:bodyPr wrap="square" anchor="ctr">
-            <a:spAutoFit/>
-          </a:bodyPr>
-          <a:lstStyle/>
-          <a:p>
-            <a:pPr algn="r">
-              <a:spcAft>
-                <a:spcPts val="600"/>
-              </a:spcAft>
-            </a:pPr>
-            <a:r>
-              <a:rPr sz="1200" b="1">
-                <a:solidFill>
-                  <a:srgbClr val="C9A227"/>
-                </a:solidFill>
-                <a:latin typeface="Calibri"/>
-              </a:rPr>
-              <a:t>Gold Price Prediction</a:t>
-            </a:r>
-          </a:p>
-        </p:txBody>
-      </p:sp>
-      <p:sp>
-        <p:nvSpPr>
-          <p:cNvPr id="6" name="Rectangle 5"/>
-          <p:cNvSpPr/>
-          <p:nvPr/>
-        </p:nvSpPr>
-        <p:spPr>
-          <a:xfrm>
-            <a:off x="0" y="6473952"/>
-            <a:ext cx="12191695" cy="384048"/>
-          </a:xfrm>
-          <a:prstGeom prst="rect">
-            <a:avLst/>
-          </a:prstGeom>
-          <a:solidFill>
-            <a:srgbClr val="1F3864"/>
-          </a:solidFill>
-          <a:ln>
-            <a:noFill/>
-          </a:ln>
-          <a:effectLst/>
-        </p:spPr>
-        <p:style>
-          <a:lnRef idx="1">
-            <a:schemeClr val="accent1"/>
-          </a:lnRef>
-          <a:fillRef idx="3">
-            <a:schemeClr val="accent1"/>
-          </a:fillRef>
-          <a:effectRef idx="2">
-            <a:schemeClr val="accent1"/>
-          </a:effectRef>
-          <a:fontRef idx="minor">
-            <a:schemeClr val="lt1"/>
-          </a:fontRef>
-        </p:style>
-        <p:txBody>
-          <a:bodyPr rtlCol="0" anchor="ctr"/>
-          <a:lstStyle/>
-          <a:p>
-            <a:pPr algn="ctr"/>
-          </a:p>
-        </p:txBody>
-      </p:sp>
-      <p:sp>
-        <p:nvSpPr>
-          <p:cNvPr id="7" name="Rectangle 6"/>
-          <p:cNvSpPr/>
-          <p:nvPr/>
-        </p:nvSpPr>
-        <p:spPr>
-          <a:xfrm>
-            <a:off x="0" y="6473952"/>
-            <a:ext cx="128016" cy="384048"/>
-          </a:xfrm>
-          <a:prstGeom prst="rect">
-            <a:avLst/>
-          </a:prstGeom>
-          <a:solidFill>
-            <a:srgbClr val="C9A227"/>
-          </a:solidFill>
-          <a:ln>
-            <a:noFill/>
-          </a:ln>
-          <a:effectLst/>
-        </p:spPr>
-        <p:style>
-          <a:lnRef idx="1">
-            <a:schemeClr val="accent1"/>
-          </a:lnRef>
-          <a:fillRef idx="3">
-            <a:schemeClr val="accent1"/>
-          </a:fillRef>
-          <a:effectRef idx="2">
-            <a:schemeClr val="accent1"/>
-          </a:effectRef>
-          <a:fontRef idx="minor">
-            <a:schemeClr val="lt1"/>
-          </a:fontRef>
-        </p:style>
-        <p:txBody>
-          <a:bodyPr rtlCol="0" anchor="ctr"/>
-          <a:lstStyle/>
-          <a:p>
-            <a:pPr algn="ctr"/>
-          </a:p>
-        </p:txBody>
-      </p:sp>
-      <p:sp>
-        <p:nvSpPr>
-          <p:cNvPr id="8" name="TextBox 7"/>
-          <p:cNvSpPr txBox="1"/>
-          <p:nvPr/>
-        </p:nvSpPr>
-        <p:spPr>
-          <a:xfrm>
-            <a:off x="274320" y="6473952"/>
-            <a:ext cx="10362895" cy="384048"/>
-          </a:xfrm>
-          <a:prstGeom prst="rect">
-            <a:avLst/>
-          </a:prstGeom>
-          <a:noFill/>
-        </p:spPr>
-        <p:txBody>
-          <a:bodyPr wrap="square" anchor="ctr">
-            <a:spAutoFit/>
-          </a:bodyPr>
-          <a:lstStyle/>
-          <a:p>
-            <a:pPr algn="l">
-              <a:spcAft>
-                <a:spcPts val="600"/>
-              </a:spcAft>
-            </a:pPr>
-            <a:r>
-              <a:rPr sz="900" b="0">
-                <a:solidFill>
-                  <a:srgbClr val="FFFFFF"/>
-                </a:solidFill>
-                <a:latin typeface="Calibri"/>
-              </a:rPr>
-              <a:t>Sanchay Bhardwaj (2300650100104)  |  B.S.A. College of Engineering &amp; Technology, Mathura</a:t>
-            </a:r>
-          </a:p>
-        </p:txBody>
-      </p:sp>
-      <p:sp>
-        <p:nvSpPr>
-          <p:cNvPr id="9" name="TextBox 8"/>
-          <p:cNvSpPr txBox="1"/>
-          <p:nvPr/>
-        </p:nvSpPr>
-        <p:spPr>
-          <a:xfrm>
-            <a:off x="10728655" y="6473952"/>
-            <a:ext cx="1188720" cy="384048"/>
-          </a:xfrm>
-          <a:prstGeom prst="rect">
-            <a:avLst/>
-          </a:prstGeom>
-          <a:noFill/>
-        </p:spPr>
-        <p:txBody>
-          <a:bodyPr wrap="square" anchor="ctr">
-            <a:spAutoFit/>
-          </a:bodyPr>
-          <a:lstStyle/>
-          <a:p>
-            <a:pPr algn="r">
-              <a:spcAft>
-                <a:spcPts val="600"/>
-              </a:spcAft>
-            </a:pPr>
-            <a:r>
-              <a:rPr sz="900" b="1">
-                <a:solidFill>
-                  <a:srgbClr val="C9A227"/>
-                </a:solidFill>
-                <a:latin typeface="Calibri"/>
-              </a:rPr>
-              <a:t>Slide 9</a:t>
-            </a:r>
-          </a:p>
-        </p:txBody>
-      </p:sp>
-      <p:pic>
-        <p:nvPicPr>
-          <p:cNvPr id="10" name="Picture 9" descr="screenshot_predict.png"/>
-          <p:cNvPicPr>
-            <a:picLocks noChangeAspect="1"/>
-          </p:cNvPicPr>
-          <p:nvPr/>
-        </p:nvPicPr>
-        <p:blipFill>
-          <a:blip r:embed="rId2"/>
-          <a:stretch>
-            <a:fillRect/>
-          </a:stretch>
-        </p:blipFill>
-        <p:spPr>
-          <a:xfrm>
-            <a:off x="2703423" y="1325880"/>
-            <a:ext cx="6784848" cy="4480560"/>
-          </a:xfrm>
-          <a:prstGeom prst="rect">
-            <a:avLst/>
-          </a:prstGeom>
-        </p:spPr>
-      </p:pic>
-      <p:sp>
-        <p:nvSpPr>
-          <p:cNvPr id="11" name="TextBox 10"/>
-          <p:cNvSpPr txBox="1"/>
-          <p:nvPr/>
-        </p:nvSpPr>
-        <p:spPr>
-          <a:xfrm>
-            <a:off x="914400" y="5623560"/>
-            <a:ext cx="10362895" cy="640080"/>
-          </a:xfrm>
-          <a:prstGeom prst="rect">
-            <a:avLst/>
-          </a:prstGeom>
-          <a:noFill/>
-        </p:spPr>
-        <p:txBody>
-          <a:bodyPr wrap="square">
-            <a:spAutoFit/>
-          </a:bodyPr>
-          <a:lstStyle/>
-          <a:p>
-            <a:pPr algn="ctr">
-              <a:spcAft>
-                <a:spcPts val="600"/>
-              </a:spcAft>
-            </a:pPr>
-            <a:r>
-              <a:rPr sz="1300" b="0">
-                <a:solidFill>
-                  <a:srgbClr val="6B7280"/>
-                </a:solidFill>
-                <a:latin typeface="Calibri"/>
-              </a:rPr>
-              <a:t>Desktop GUI: choose a horizon and forecast the gold price month by month.</a:t>
+              <a:t>Random Forest wins on both metals and beats the naive baseline. Test window: last 60 months, from Oct 2021. Lower MAE and higher R-squared are better.</a:t>
             </a:r>
           </a:p>
         </p:txBody>

</xml_diff>

<commit_message>
Make the dashboard fit one screen and show the live rate moving
The old page needed scrolling and the price looked frozen, which made it hard to
trust that anything was live. Everything now sits above the fold, the header
carries the developer credit, and each metal card keeps a short tick history so
the rate visibly moves on its own.
</commit_message>
<xml_diff>
--- a/docs/Gold-Price-Prediction-Presentation.pptx
+++ b/docs/Gold-Price-Prediction-Presentation.pptx
@@ -3678,7 +3678,7 @@
                 </a:solidFill>
                 <a:latin typeface="Calibri"/>
               </a:rPr>
-              <a:t>Sanchay Bhardwaj (2300650100104)  |  B.S.A. College of Engineering &amp; Technology, Mathura</a:t>
+              <a:t>Developed by Sanchay Bhardwaj (2300650100104)  |  B.S.A. College of Engineering &amp; Technology, Mathura</a:t>
             </a:r>
           </a:p>
         </p:txBody>
@@ -3738,8 +3738,8 @@
         </p:blipFill>
         <p:spPr>
           <a:xfrm>
-            <a:off x="2053237" y="1325880"/>
-            <a:ext cx="8085221" cy="4480560"/>
+            <a:off x="2047466" y="1325880"/>
+            <a:ext cx="8096762" cy="4389120"/>
           </a:xfrm>
           <a:prstGeom prst="rect">
             <a:avLst/>
@@ -3754,7 +3754,7 @@
         </p:nvSpPr>
         <p:spPr>
           <a:xfrm>
-            <a:off x="914400" y="5623560"/>
+            <a:off x="914400" y="5897880"/>
             <a:ext cx="10362895" cy="640080"/>
           </a:xfrm>
           <a:prstGeom prst="rect">
@@ -3780,7 +3780,7 @@
                 </a:solidFill>
                 <a:latin typeface="Calibri"/>
               </a:rPr>
-              <a:t>Today's live gold and silver price in rupees per gram, per kg and per 10 gram, with the monthly history since 2000.</a:t>
+              <a:t>The complete app on one screen: today's live gold and silver rate in rupees per gram, per 10 gram and per kg, the history since 2000, the 12 month outlook and the accuracy table.</a:t>
             </a:r>
           </a:p>
         </p:txBody>
@@ -3925,7 +3925,7 @@
                 </a:solidFill>
                 <a:latin typeface="Calibri"/>
               </a:rPr>
-              <a:t>Application - 12 Month Forecast</a:t>
+              <a:t>Application - History and Forecast</a:t>
             </a:r>
           </a:p>
         </p:txBody>
@@ -4091,7 +4091,7 @@
                 </a:solidFill>
                 <a:latin typeface="Calibri"/>
               </a:rPr>
-              <a:t>Sanchay Bhardwaj (2300650100104)  |  B.S.A. College of Engineering &amp; Technology, Mathura</a:t>
+              <a:t>Developed by Sanchay Bhardwaj (2300650100104)  |  B.S.A. College of Engineering &amp; Technology, Mathura</a:t>
             </a:r>
           </a:p>
         </p:txBody>
@@ -4151,8 +4151,8 @@
         </p:blipFill>
         <p:spPr>
           <a:xfrm>
-            <a:off x="2535138" y="1325880"/>
-            <a:ext cx="7121419" cy="4480560"/>
+            <a:off x="2676768" y="1325880"/>
+            <a:ext cx="6838158" cy="4389120"/>
           </a:xfrm>
           <a:prstGeom prst="rect">
             <a:avLst/>
@@ -4167,7 +4167,7 @@
         </p:nvSpPr>
         <p:spPr>
           <a:xfrm>
-            <a:off x="914400" y="5623560"/>
+            <a:off x="914400" y="5897880"/>
             <a:ext cx="10362895" cy="640080"/>
           </a:xfrm>
           <a:prstGeom prst="rect">
@@ -4193,7 +4193,7 @@
                 </a:solidFill>
                 <a:latin typeface="Calibri"/>
               </a:rPr>
-              <a:t>Solid line = actual price, dashed line = model forecast, plus the month by month expected price in rupees.</a:t>
+              <a:t>Top: monthly price history of both metals since 2000. Bottom: solid line is the actual price, dashed line is what the model expects for the next 12 months.</a:t>
             </a:r>
           </a:p>
         </p:txBody>
@@ -4338,7 +4338,7 @@
                 </a:solidFill>
                 <a:latin typeface="Calibri"/>
               </a:rPr>
-              <a:t>Application - Model Accuracy</a:t>
+              <a:t>Application - Expected Price and Accuracy</a:t>
             </a:r>
           </a:p>
         </p:txBody>
@@ -4504,7 +4504,7 @@
                 </a:solidFill>
                 <a:latin typeface="Calibri"/>
               </a:rPr>
-              <a:t>Sanchay Bhardwaj (2300650100104)  |  B.S.A. College of Engineering &amp; Technology, Mathura</a:t>
+              <a:t>Developed by Sanchay Bhardwaj (2300650100104)  |  B.S.A. College of Engineering &amp; Technology, Mathura</a:t>
             </a:r>
           </a:p>
         </p:txBody>
@@ -4564,8 +4564,8 @@
         </p:blipFill>
         <p:spPr>
           <a:xfrm>
-            <a:off x="731520" y="1325880"/>
-            <a:ext cx="10728655" cy="4269110"/>
+            <a:off x="3588859" y="1325880"/>
+            <a:ext cx="5013977" cy="4389120"/>
           </a:xfrm>
           <a:prstGeom prst="rect">
             <a:avLst/>
@@ -4580,7 +4580,7 @@
         </p:nvSpPr>
         <p:spPr>
           <a:xfrm>
-            <a:off x="914400" y="5623560"/>
+            <a:off x="914400" y="5897880"/>
             <a:ext cx="10362895" cy="640080"/>
           </a:xfrm>
           <a:prstGeom prst="rect">
@@ -4606,7 +4606,7 @@
                 </a:solidFill>
                 <a:latin typeface="Calibri"/>
               </a:rPr>
-              <a:t>Error of every model on 60 unseen months, compared against the naive 'next month = this month' baseline.</a:t>
+              <a:t>Top: expected gold and silver price after 1, 3, 6 and 12 months in rupees. Bottom: error of every model on 60 unseen months against the naive baseline.</a:t>
             </a:r>
           </a:p>
         </p:txBody>
@@ -4917,7 +4917,7 @@
                 </a:solidFill>
                 <a:latin typeface="Calibri"/>
               </a:rPr>
-              <a:t>Sanchay Bhardwaj (2300650100104)  |  B.S.A. College of Engineering &amp; Technology, Mathura</a:t>
+              <a:t>Developed by Sanchay Bhardwaj (2300650100104)  |  B.S.A. College of Engineering &amp; Technology, Mathura</a:t>
             </a:r>
           </a:p>
         </p:txBody>
@@ -5398,7 +5398,7 @@
                 </a:solidFill>
                 <a:latin typeface="Calibri"/>
               </a:rPr>
-              <a:t>Sanchay Bhardwaj (2300650100104)  |  B.S.A. College of Engineering &amp; Technology, Mathura</a:t>
+              <a:t>Developed by Sanchay Bhardwaj (2300650100104)  |  B.S.A. College of Engineering &amp; Technology, Mathura</a:t>
             </a:r>
           </a:p>
         </p:txBody>
@@ -6151,7 +6151,7 @@
                 </a:solidFill>
                 <a:latin typeface="Calibri"/>
               </a:rPr>
-              <a:t>Sanchay Bhardwaj (2300650100104)  |  B.S.A. College of Engineering &amp; Technology, Mathura</a:t>
+              <a:t>Developed by Sanchay Bhardwaj (2300650100104)  |  B.S.A. College of Engineering &amp; Technology, Mathura</a:t>
             </a:r>
           </a:p>
         </p:txBody>
@@ -6648,7 +6648,7 @@
                 </a:solidFill>
                 <a:latin typeface="Calibri"/>
               </a:rPr>
-              <a:t>Sanchay Bhardwaj (2300650100104)  |  B.S.A. College of Engineering &amp; Technology, Mathura</a:t>
+              <a:t>Developed by Sanchay Bhardwaj (2300650100104)  |  B.S.A. College of Engineering &amp; Technology, Mathura</a:t>
             </a:r>
           </a:p>
         </p:txBody>
@@ -7129,7 +7129,7 @@
                 </a:solidFill>
                 <a:latin typeface="Calibri"/>
               </a:rPr>
-              <a:t>Sanchay Bhardwaj (2300650100104)  |  B.S.A. College of Engineering &amp; Technology, Mathura</a:t>
+              <a:t>Developed by Sanchay Bhardwaj (2300650100104)  |  B.S.A. College of Engineering &amp; Technology, Mathura</a:t>
             </a:r>
           </a:p>
         </p:txBody>
@@ -7626,7 +7626,7 @@
                 </a:solidFill>
                 <a:latin typeface="Calibri"/>
               </a:rPr>
-              <a:t>Sanchay Bhardwaj (2300650100104)  |  B.S.A. College of Engineering &amp; Technology, Mathura</a:t>
+              <a:t>Developed by Sanchay Bhardwaj (2300650100104)  |  B.S.A. College of Engineering &amp; Technology, Mathura</a:t>
             </a:r>
           </a:p>
         </p:txBody>
@@ -8123,7 +8123,7 @@
                 </a:solidFill>
                 <a:latin typeface="Calibri"/>
               </a:rPr>
-              <a:t>Sanchay Bhardwaj (2300650100104)  |  B.S.A. College of Engineering &amp; Technology, Mathura</a:t>
+              <a:t>Developed by Sanchay Bhardwaj (2300650100104)  |  B.S.A. College of Engineering &amp; Technology, Mathura</a:t>
             </a:r>
           </a:p>
         </p:txBody>
@@ -8620,7 +8620,7 @@
                 </a:solidFill>
                 <a:latin typeface="Calibri"/>
               </a:rPr>
-              <a:t>Sanchay Bhardwaj (2300650100104)  |  B.S.A. College of Engineering &amp; Technology, Mathura</a:t>
+              <a:t>Developed by Sanchay Bhardwaj (2300650100104)  |  B.S.A. College of Engineering &amp; Technology, Mathura</a:t>
             </a:r>
           </a:p>
         </p:txBody>
@@ -9117,7 +9117,7 @@
                 </a:solidFill>
                 <a:latin typeface="Calibri"/>
               </a:rPr>
-              <a:t>Sanchay Bhardwaj (2300650100104)  |  B.S.A. College of Engineering &amp; Technology, Mathura</a:t>
+              <a:t>Developed by Sanchay Bhardwaj (2300650100104)  |  B.S.A. College of Engineering &amp; Technology, Mathura</a:t>
             </a:r>
           </a:p>
         </p:txBody>
@@ -9614,7 +9614,7 @@
                 </a:solidFill>
                 <a:latin typeface="Calibri"/>
               </a:rPr>
-              <a:t>Sanchay Bhardwaj (2300650100104)  |  B.S.A. College of Engineering &amp; Technology, Mathura</a:t>
+              <a:t>Developed by Sanchay Bhardwaj (2300650100104)  |  B.S.A. College of Engineering &amp; Technology, Mathura</a:t>
             </a:r>
           </a:p>
         </p:txBody>

</xml_diff>

<commit_message>
Shrink the header and live cards so the dashboard clears a laptop screen
The compact version still needed a little scrolling on a normal window. Smaller
base text, a shorter top bar and a tighter price card bring the whole page under
the fold without dropping any panel.
</commit_message>
<xml_diff>
--- a/docs/Gold-Price-Prediction-Presentation.pptx
+++ b/docs/Gold-Price-Prediction-Presentation.pptx
@@ -3738,8 +3738,8 @@
         </p:blipFill>
         <p:spPr>
           <a:xfrm>
-            <a:off x="2047466" y="1325880"/>
-            <a:ext cx="8096762" cy="4389120"/>
+            <a:off x="1499910" y="1325880"/>
+            <a:ext cx="9191874" cy="4389120"/>
           </a:xfrm>
           <a:prstGeom prst="rect">
             <a:avLst/>
@@ -4151,8 +4151,8 @@
         </p:blipFill>
         <p:spPr>
           <a:xfrm>
-            <a:off x="2676768" y="1325880"/>
-            <a:ext cx="6838158" cy="4389120"/>
+            <a:off x="2302194" y="1325880"/>
+            <a:ext cx="7587306" cy="4389120"/>
           </a:xfrm>
           <a:prstGeom prst="rect">
             <a:avLst/>
@@ -4564,8 +4564,8 @@
         </p:blipFill>
         <p:spPr>
           <a:xfrm>
-            <a:off x="3588859" y="1325880"/>
-            <a:ext cx="5013977" cy="4389120"/>
+            <a:off x="3314208" y="1325880"/>
+            <a:ext cx="5563279" cy="4389120"/>
           </a:xfrm>
           <a:prstGeom prst="rect">
             <a:avLst/>

</xml_diff>